<commit_message>
Enhance PPTX with photos and modern slide design
Agent-Logs-Url: https://github.com/aniket-kanani-3107/aniket-kanani-3107.github.io/sessions/ed57ab2f-e281-408f-95f0-ab29e4769e8e

Co-authored-by: aniket-kanani-3107 <268387354+aniket-kanani-3107@users.noreply.github.com>
</commit_message>
<xml_diff>
--- a/Food-Packaging-Containers.pptx
+++ b/Food-Packaging-Containers.pptx
@@ -10,7 +10,7 @@
     <p:sldId id="258" r:id="rId9"/>
     <p:sldId id="259" r:id="rId10"/>
   </p:sldIdLst>
-  <p:sldSz cx="9144000" cy="6858000" type="screen4x3"/>
+  <p:sldSz cx="12188952" cy="6858000" type="screen4x3"/>
   <p:notesSz cx="6858000" cy="9144000"/>
   <p:defaultTextStyle>
     <a:defPPr>
@@ -3093,21 +3093,118 @@
       <p:grpSpPr/>
       <p:sp>
         <p:nvSpPr>
-          <p:cNvPr id="2" name="Title 1"/>
-          <p:cNvSpPr>
-            <a:spLocks noGrp="1"/>
-          </p:cNvSpPr>
-          <p:nvPr>
-            <p:ph type="title"/>
-          </p:nvPr>
-        </p:nvSpPr>
-        <p:spPr/>
-        <p:txBody>
-          <a:bodyPr/>
-          <a:lstStyle/>
-          <a:p>
-            <a:r>
-              <a:rPr sz="1800"/>
+          <p:cNvPr id="2" name="Rectangle 1"/>
+          <p:cNvSpPr/>
+          <p:nvPr/>
+        </p:nvSpPr>
+        <p:spPr>
+          <a:xfrm>
+            <a:off x="0" y="0"/>
+            <a:ext cx="12188952" cy="6858000"/>
+          </a:xfrm>
+          <a:prstGeom prst="rect">
+            <a:avLst/>
+          </a:prstGeom>
+          <a:solidFill>
+            <a:srgbClr val="000000"/>
+          </a:solidFill>
+          <a:ln>
+            <a:noFill/>
+          </a:ln>
+        </p:spPr>
+        <p:style>
+          <a:lnRef idx="1">
+            <a:schemeClr val="accent1"/>
+          </a:lnRef>
+          <a:fillRef idx="3">
+            <a:schemeClr val="accent1"/>
+          </a:fillRef>
+          <a:effectRef idx="2">
+            <a:schemeClr val="accent1"/>
+          </a:effectRef>
+          <a:fontRef idx="minor">
+            <a:schemeClr val="lt1"/>
+          </a:fontRef>
+        </p:style>
+        <p:txBody>
+          <a:bodyPr rtlCol="0" anchor="ctr"/>
+          <a:lstStyle/>
+          <a:p>
+            <a:pPr algn="ctr"/>
+          </a:p>
+        </p:txBody>
+      </p:sp>
+      <p:sp>
+        <p:nvSpPr>
+          <p:cNvPr id="3" name="Rectangle 2"/>
+          <p:cNvSpPr/>
+          <p:nvPr/>
+        </p:nvSpPr>
+        <p:spPr>
+          <a:xfrm>
+            <a:off x="502920" y="987552"/>
+            <a:ext cx="109728" cy="4297680"/>
+          </a:xfrm>
+          <a:prstGeom prst="rect">
+            <a:avLst/>
+          </a:prstGeom>
+          <a:solidFill>
+            <a:srgbClr val="47BE84"/>
+          </a:solidFill>
+          <a:ln>
+            <a:noFill/>
+          </a:ln>
+        </p:spPr>
+        <p:style>
+          <a:lnRef idx="1">
+            <a:schemeClr val="accent1"/>
+          </a:lnRef>
+          <a:fillRef idx="3">
+            <a:schemeClr val="accent1"/>
+          </a:fillRef>
+          <a:effectRef idx="2">
+            <a:schemeClr val="accent1"/>
+          </a:effectRef>
+          <a:fontRef idx="minor">
+            <a:schemeClr val="lt1"/>
+          </a:fontRef>
+        </p:style>
+        <p:txBody>
+          <a:bodyPr rtlCol="0" anchor="ctr"/>
+          <a:lstStyle/>
+          <a:p>
+            <a:pPr algn="ctr"/>
+          </a:p>
+        </p:txBody>
+      </p:sp>
+      <p:sp>
+        <p:nvSpPr>
+          <p:cNvPr id="4" name="TextBox 3"/>
+          <p:cNvSpPr txBox="1"/>
+          <p:nvPr/>
+        </p:nvSpPr>
+        <p:spPr>
+          <a:xfrm>
+            <a:off x="548640" y="274320"/>
+            <a:ext cx="6583680" cy="640080"/>
+          </a:xfrm>
+          <a:prstGeom prst="rect">
+            <a:avLst/>
+          </a:prstGeom>
+          <a:noFill/>
+        </p:spPr>
+        <p:txBody>
+          <a:bodyPr wrap="none">
+            <a:spAutoFit/>
+          </a:bodyPr>
+          <a:lstStyle/>
+          <a:p>
+            <a:r>
+              <a:rPr b="1" sz="3400">
+                <a:solidFill>
+                  <a:srgbClr val="FFFFFF"/>
+                </a:solidFill>
+              </a:rPr>
               <a:t>Introduction to Food Packaging Containers</a:t>
             </a:r>
           </a:p>
@@ -3115,64 +3212,68 @@
       </p:sp>
       <p:sp>
         <p:nvSpPr>
-          <p:cNvPr id="3" name="Content Placeholder 2"/>
-          <p:cNvSpPr>
-            <a:spLocks noGrp="1"/>
-          </p:cNvSpPr>
-          <p:nvPr>
-            <p:ph idx="1"/>
-          </p:nvPr>
-        </p:nvSpPr>
-        <p:spPr/>
-        <p:txBody>
-          <a:bodyPr/>
-          <a:lstStyle/>
-          <a:p>
-            <a:r>
-              <a:rPr sz="1800"/>
-              <a:t>Food packaging containers are materials used to store, protect, preserve, and transport food products.</a:t>
-            </a:r>
-          </a:p>
-          <a:p>
-            <a:r>
-              <a:rPr sz="1800"/>
-              <a:t>They help maintain food quality, safety, and shelf life while preventing contamination from microorganisms, moisture, air, and physical damage.</a:t>
-            </a:r>
-          </a:p>
-          <a:p>
-            <a:r>
-              <a:rPr sz="1800"/>
-              <a:t>The main functions of food containers include:</a:t>
-            </a:r>
-          </a:p>
-          <a:p>
-            <a:r>
-              <a:rPr sz="1800"/>
-              <a:t>• Protection from physical, chemical, and biological hazards</a:t>
-            </a:r>
-          </a:p>
-          <a:p>
-            <a:r>
-              <a:rPr sz="1800"/>
-              <a:t>• Preservation of freshness and nutritional value</a:t>
-            </a:r>
-          </a:p>
-          <a:p>
-            <a:r>
-              <a:rPr sz="1800"/>
-              <a:t>• Ease of transportation and storage</a:t>
-            </a:r>
-          </a:p>
-          <a:p>
-            <a:r>
-              <a:rPr sz="1800"/>
-              <a:t>• Providing information (labeling, expiry date, ingredients)</a:t>
-            </a:r>
-          </a:p>
-          <a:p>
-            <a:r>
-              <a:rPr sz="1800"/>
-              <a:t>Food packaging is essential in the modern food supply chain, ensuring food reaches consumers safely and in usable condition.</a:t>
+          <p:cNvPr id="5" name="TextBox 4"/>
+          <p:cNvSpPr txBox="1"/>
+          <p:nvPr/>
+        </p:nvSpPr>
+        <p:spPr>
+          <a:xfrm>
+            <a:off x="822960" y="1188720"/>
+            <a:ext cx="6492240" cy="4206240"/>
+          </a:xfrm>
+          <a:prstGeom prst="rect">
+            <a:avLst/>
+          </a:prstGeom>
+          <a:noFill/>
+        </p:spPr>
+        <p:txBody>
+          <a:bodyPr wrap="square">
+            <a:spAutoFit/>
+          </a:bodyPr>
+          <a:lstStyle/>
+          <a:p>
+            <a:pPr>
+              <a:spcAft>
+                <a:spcPts val="600"/>
+              </a:spcAft>
+              <a:defRPr sz="2100">
+                <a:solidFill>
+                  <a:srgbClr val="F5F5F5"/>
+                </a:solidFill>
+              </a:defRPr>
+            </a:pPr>
+            <a:r>
+              <a:t>Food packaging containers store, protect, preserve, and transport food products.</a:t>
+            </a:r>
+          </a:p>
+          <a:p>
+            <a:pPr>
+              <a:spcAft>
+                <a:spcPts val="600"/>
+              </a:spcAft>
+              <a:defRPr sz="2100">
+                <a:solidFill>
+                  <a:srgbClr val="F5F5F5"/>
+                </a:solidFill>
+              </a:defRPr>
+            </a:pPr>
+            <a:r>
+              <a:t>They maintain quality and shelf life while reducing contamination from moisture, air, and microbes.</a:t>
+            </a:r>
+          </a:p>
+          <a:p>
+            <a:pPr>
+              <a:spcAft>
+                <a:spcPts val="600"/>
+              </a:spcAft>
+              <a:defRPr sz="2100">
+                <a:solidFill>
+                  <a:srgbClr val="F5F5F5"/>
+                </a:solidFill>
+              </a:defRPr>
+            </a:pPr>
+            <a:r>
+              <a:t>Main functions include protection, freshness, safer logistics, and clear consumer labeling.</a:t>
             </a:r>
           </a:p>
         </p:txBody>
@@ -3197,21 +3298,75 @@
       <p:grpSpPr/>
       <p:sp>
         <p:nvSpPr>
-          <p:cNvPr id="2" name="Title 1"/>
-          <p:cNvSpPr>
-            <a:spLocks noGrp="1"/>
-          </p:cNvSpPr>
-          <p:nvPr>
-            <p:ph type="title"/>
-          </p:nvPr>
-        </p:nvSpPr>
-        <p:spPr/>
-        <p:txBody>
-          <a:bodyPr/>
-          <a:lstStyle/>
-          <a:p>
-            <a:r>
-              <a:rPr sz="1800"/>
+          <p:cNvPr id="2" name="Rectangle 1"/>
+          <p:cNvSpPr/>
+          <p:nvPr/>
+        </p:nvSpPr>
+        <p:spPr>
+          <a:xfrm>
+            <a:off x="0" y="0"/>
+            <a:ext cx="12188952" cy="6858000"/>
+          </a:xfrm>
+          <a:prstGeom prst="rect">
+            <a:avLst/>
+          </a:prstGeom>
+          <a:solidFill>
+            <a:srgbClr val="F5F8FC"/>
+          </a:solidFill>
+          <a:ln>
+            <a:noFill/>
+          </a:ln>
+        </p:spPr>
+        <p:style>
+          <a:lnRef idx="1">
+            <a:schemeClr val="accent1"/>
+          </a:lnRef>
+          <a:fillRef idx="3">
+            <a:schemeClr val="accent1"/>
+          </a:fillRef>
+          <a:effectRef idx="2">
+            <a:schemeClr val="accent1"/>
+          </a:effectRef>
+          <a:fontRef idx="minor">
+            <a:schemeClr val="lt1"/>
+          </a:fontRef>
+        </p:style>
+        <p:txBody>
+          <a:bodyPr rtlCol="0" anchor="ctr"/>
+          <a:lstStyle/>
+          <a:p>
+            <a:pPr algn="ctr"/>
+          </a:p>
+        </p:txBody>
+      </p:sp>
+      <p:sp>
+        <p:nvSpPr>
+          <p:cNvPr id="3" name="TextBox 2"/>
+          <p:cNvSpPr txBox="1"/>
+          <p:nvPr/>
+        </p:nvSpPr>
+        <p:spPr>
+          <a:xfrm>
+            <a:off x="548640" y="274320"/>
+            <a:ext cx="6583680" cy="640080"/>
+          </a:xfrm>
+          <a:prstGeom prst="rect">
+            <a:avLst/>
+          </a:prstGeom>
+          <a:noFill/>
+        </p:spPr>
+        <p:txBody>
+          <a:bodyPr wrap="none">
+            <a:spAutoFit/>
+          </a:bodyPr>
+          <a:lstStyle/>
+          <a:p>
+            <a:r>
+              <a:rPr b="1" sz="3400">
+                <a:solidFill>
+                  <a:srgbClr val="163963"/>
+                </a:solidFill>
+              </a:rPr>
               <a:t>Types of Food Containers</a:t>
             </a:r>
           </a:p>
@@ -3219,46 +3374,291 @@
       </p:sp>
       <p:sp>
         <p:nvSpPr>
-          <p:cNvPr id="3" name="Content Placeholder 2"/>
-          <p:cNvSpPr>
-            <a:spLocks noGrp="1"/>
-          </p:cNvSpPr>
-          <p:nvPr>
-            <p:ph idx="1"/>
-          </p:nvPr>
-        </p:nvSpPr>
-        <p:spPr/>
-        <p:txBody>
-          <a:bodyPr/>
-          <a:lstStyle/>
-          <a:p>
-            <a:r>
-              <a:rPr sz="1800"/>
-              <a:t>Food packaging containers are made from different materials, each with unique properties and uses:</a:t>
-            </a:r>
-          </a:p>
-          <a:p>
-            <a:r>
-              <a:rPr sz="1800"/>
-              <a:t>1. Plastic Containers – Lightweight, flexible, and cost-effective; used for ready meals, dairy products, and takeaways (e.g., PET bottles, Tupperware)</a:t>
-            </a:r>
-          </a:p>
-          <a:p>
-            <a:r>
-              <a:rPr sz="1800"/>
-              <a:t>2. Glass Containers – Non-reactive and safe; preserves taste and quality; used for sauces, jams, and beverages</a:t>
-            </a:r>
-          </a:p>
-          <a:p>
-            <a:r>
-              <a:rPr sz="1800"/>
-              <a:t>3. Metal Containers – Strong and durable with excellent barrier properties; ideal for long-term storage (e.g., aluminum cans, tin cans)</a:t>
-            </a:r>
-          </a:p>
-          <a:p>
-            <a:r>
-              <a:rPr sz="1800"/>
-              <a:t>4. Paper and Cardboard Containers – Biodegradable and environmentally friendly; used for fast food, bakery items, and takeaway packaging</a:t>
+          <p:cNvPr id="4" name="Rounded Rectangle 3"/>
+          <p:cNvSpPr/>
+          <p:nvPr/>
+        </p:nvSpPr>
+        <p:spPr>
+          <a:xfrm>
+            <a:off x="502920" y="2788920"/>
+            <a:ext cx="2377440" cy="384048"/>
+          </a:xfrm>
+          <a:prstGeom prst="roundRect">
+            <a:avLst/>
+          </a:prstGeom>
+          <a:solidFill>
+            <a:srgbClr val="163963"/>
+          </a:solidFill>
+          <a:ln>
+            <a:noFill/>
+          </a:ln>
+        </p:spPr>
+        <p:style>
+          <a:lnRef idx="1">
+            <a:schemeClr val="accent1"/>
+          </a:lnRef>
+          <a:fillRef idx="3">
+            <a:schemeClr val="accent1"/>
+          </a:fillRef>
+          <a:effectRef idx="2">
+            <a:schemeClr val="accent1"/>
+          </a:effectRef>
+          <a:fontRef idx="minor">
+            <a:schemeClr val="lt1"/>
+          </a:fontRef>
+        </p:style>
+        <p:txBody>
+          <a:bodyPr rtlCol="0" anchor="ctr"/>
+          <a:lstStyle/>
+          <a:p>
+            <a:pPr algn="ctr">
+              <a:defRPr b="1" sz="1400">
+                <a:solidFill>
+                  <a:srgbClr val="FFFFFF"/>
+                </a:solidFill>
+              </a:defRPr>
+            </a:pPr>
+            <a:r>
+              <a:t>Plastic</a:t>
+            </a:r>
+          </a:p>
+        </p:txBody>
+      </p:sp>
+      <p:sp>
+        <p:nvSpPr>
+          <p:cNvPr id="5" name="Rounded Rectangle 4"/>
+          <p:cNvSpPr/>
+          <p:nvPr/>
+        </p:nvSpPr>
+        <p:spPr>
+          <a:xfrm>
+            <a:off x="3154680" y="2788920"/>
+            <a:ext cx="2377440" cy="384048"/>
+          </a:xfrm>
+          <a:prstGeom prst="roundRect">
+            <a:avLst/>
+          </a:prstGeom>
+          <a:solidFill>
+            <a:srgbClr val="163963"/>
+          </a:solidFill>
+          <a:ln>
+            <a:noFill/>
+          </a:ln>
+        </p:spPr>
+        <p:style>
+          <a:lnRef idx="1">
+            <a:schemeClr val="accent1"/>
+          </a:lnRef>
+          <a:fillRef idx="3">
+            <a:schemeClr val="accent1"/>
+          </a:fillRef>
+          <a:effectRef idx="2">
+            <a:schemeClr val="accent1"/>
+          </a:effectRef>
+          <a:fontRef idx="minor">
+            <a:schemeClr val="lt1"/>
+          </a:fontRef>
+        </p:style>
+        <p:txBody>
+          <a:bodyPr rtlCol="0" anchor="ctr"/>
+          <a:lstStyle/>
+          <a:p>
+            <a:pPr algn="ctr">
+              <a:defRPr b="1" sz="1400">
+                <a:solidFill>
+                  <a:srgbClr val="FFFFFF"/>
+                </a:solidFill>
+              </a:defRPr>
+            </a:pPr>
+            <a:r>
+              <a:t>Glass</a:t>
+            </a:r>
+          </a:p>
+        </p:txBody>
+      </p:sp>
+      <p:sp>
+        <p:nvSpPr>
+          <p:cNvPr id="6" name="Rounded Rectangle 5"/>
+          <p:cNvSpPr/>
+          <p:nvPr/>
+        </p:nvSpPr>
+        <p:spPr>
+          <a:xfrm>
+            <a:off x="5806440" y="2788920"/>
+            <a:ext cx="2377440" cy="384048"/>
+          </a:xfrm>
+          <a:prstGeom prst="roundRect">
+            <a:avLst/>
+          </a:prstGeom>
+          <a:solidFill>
+            <a:srgbClr val="163963"/>
+          </a:solidFill>
+          <a:ln>
+            <a:noFill/>
+          </a:ln>
+        </p:spPr>
+        <p:style>
+          <a:lnRef idx="1">
+            <a:schemeClr val="accent1"/>
+          </a:lnRef>
+          <a:fillRef idx="3">
+            <a:schemeClr val="accent1"/>
+          </a:fillRef>
+          <a:effectRef idx="2">
+            <a:schemeClr val="accent1"/>
+          </a:effectRef>
+          <a:fontRef idx="minor">
+            <a:schemeClr val="lt1"/>
+          </a:fontRef>
+        </p:style>
+        <p:txBody>
+          <a:bodyPr rtlCol="0" anchor="ctr"/>
+          <a:lstStyle/>
+          <a:p>
+            <a:pPr algn="ctr">
+              <a:defRPr b="1" sz="1400">
+                <a:solidFill>
+                  <a:srgbClr val="FFFFFF"/>
+                </a:solidFill>
+              </a:defRPr>
+            </a:pPr>
+            <a:r>
+              <a:t>Metal</a:t>
+            </a:r>
+          </a:p>
+        </p:txBody>
+      </p:sp>
+      <p:sp>
+        <p:nvSpPr>
+          <p:cNvPr id="7" name="Rounded Rectangle 6"/>
+          <p:cNvSpPr/>
+          <p:nvPr/>
+        </p:nvSpPr>
+        <p:spPr>
+          <a:xfrm>
+            <a:off x="8458200" y="2788920"/>
+            <a:ext cx="2377440" cy="384048"/>
+          </a:xfrm>
+          <a:prstGeom prst="roundRect">
+            <a:avLst/>
+          </a:prstGeom>
+          <a:solidFill>
+            <a:srgbClr val="163963"/>
+          </a:solidFill>
+          <a:ln>
+            <a:noFill/>
+          </a:ln>
+        </p:spPr>
+        <p:style>
+          <a:lnRef idx="1">
+            <a:schemeClr val="accent1"/>
+          </a:lnRef>
+          <a:fillRef idx="3">
+            <a:schemeClr val="accent1"/>
+          </a:fillRef>
+          <a:effectRef idx="2">
+            <a:schemeClr val="accent1"/>
+          </a:effectRef>
+          <a:fontRef idx="minor">
+            <a:schemeClr val="lt1"/>
+          </a:fontRef>
+        </p:style>
+        <p:txBody>
+          <a:bodyPr rtlCol="0" anchor="ctr"/>
+          <a:lstStyle/>
+          <a:p>
+            <a:pPr algn="ctr">
+              <a:defRPr b="1" sz="1400">
+                <a:solidFill>
+                  <a:srgbClr val="FFFFFF"/>
+                </a:solidFill>
+              </a:defRPr>
+            </a:pPr>
+            <a:r>
+              <a:t>Paper/Cardboard</a:t>
+            </a:r>
+          </a:p>
+        </p:txBody>
+      </p:sp>
+      <p:sp>
+        <p:nvSpPr>
+          <p:cNvPr id="8" name="TextBox 7"/>
+          <p:cNvSpPr txBox="1"/>
+          <p:nvPr/>
+        </p:nvSpPr>
+        <p:spPr>
+          <a:xfrm>
+            <a:off x="685800" y="3429000"/>
+            <a:ext cx="10972800" cy="2926080"/>
+          </a:xfrm>
+          <a:prstGeom prst="rect">
+            <a:avLst/>
+          </a:prstGeom>
+          <a:noFill/>
+        </p:spPr>
+        <p:txBody>
+          <a:bodyPr wrap="square">
+            <a:spAutoFit/>
+          </a:bodyPr>
+          <a:lstStyle/>
+          <a:p>
+            <a:pPr>
+              <a:spcAft>
+                <a:spcPts val="600"/>
+              </a:spcAft>
+              <a:defRPr sz="1800">
+                <a:solidFill>
+                  <a:srgbClr val="1E1E1E"/>
+                </a:solidFill>
+              </a:defRPr>
+            </a:pPr>
+            <a:r>
+              <a:t>• Plastic: lightweight and cost-effective for bottles, dairy, and takeaway packs.</a:t>
+            </a:r>
+          </a:p>
+          <a:p>
+            <a:pPr>
+              <a:spcAft>
+                <a:spcPts val="600"/>
+              </a:spcAft>
+              <a:defRPr sz="1800">
+                <a:solidFill>
+                  <a:srgbClr val="1E1E1E"/>
+                </a:solidFill>
+              </a:defRPr>
+            </a:pPr>
+            <a:r>
+              <a:t>• Glass: non-reactive and flavor-safe for sauces, jams, and beverages.</a:t>
+            </a:r>
+          </a:p>
+          <a:p>
+            <a:pPr>
+              <a:spcAft>
+                <a:spcPts val="600"/>
+              </a:spcAft>
+              <a:defRPr sz="1800">
+                <a:solidFill>
+                  <a:srgbClr val="1E1E1E"/>
+                </a:solidFill>
+              </a:defRPr>
+            </a:pPr>
+            <a:r>
+              <a:t>• Metal: strong barrier for long shelf-life canned foods.</a:t>
+            </a:r>
+          </a:p>
+          <a:p>
+            <a:pPr>
+              <a:spcAft>
+                <a:spcPts val="600"/>
+              </a:spcAft>
+              <a:defRPr sz="1800">
+                <a:solidFill>
+                  <a:srgbClr val="1E1E1E"/>
+                </a:solidFill>
+              </a:defRPr>
+            </a:pPr>
+            <a:r>
+              <a:t>• Paper/Cardboard: biodegradable options for bakery and fast-food packaging.</a:t>
             </a:r>
           </a:p>
         </p:txBody>
@@ -3283,74 +3683,217 @@
       <p:grpSpPr/>
       <p:sp>
         <p:nvSpPr>
-          <p:cNvPr id="2" name="Title 1"/>
-          <p:cNvSpPr>
-            <a:spLocks noGrp="1"/>
-          </p:cNvSpPr>
-          <p:nvPr>
-            <p:ph type="title"/>
-          </p:nvPr>
-        </p:nvSpPr>
-        <p:spPr/>
-        <p:txBody>
-          <a:bodyPr/>
-          <a:lstStyle/>
-          <a:p>
-            <a:r>
-              <a:rPr sz="1800"/>
-              <a:t>Advantages and Disadvantages of Food Containers</a:t>
-            </a:r>
-          </a:p>
-        </p:txBody>
-      </p:sp>
-      <p:sp>
-        <p:nvSpPr>
-          <p:cNvPr id="3" name="Content Placeholder 2"/>
-          <p:cNvSpPr>
-            <a:spLocks noGrp="1"/>
-          </p:cNvSpPr>
-          <p:nvPr>
-            <p:ph idx="1"/>
-          </p:nvPr>
-        </p:nvSpPr>
-        <p:spPr/>
-        <p:txBody>
-          <a:bodyPr/>
-          <a:lstStyle/>
-          <a:p>
-            <a:r>
-              <a:rPr sz="1800"/>
-              <a:t>Each type of food container has benefits and limitations:</a:t>
-            </a:r>
-          </a:p>
-          <a:p>
-            <a:r>
-              <a:rPr sz="1800"/>
-              <a:t>Plastic — Advantages: Lightweight, cheap, versatile | Disadvantages: Environmental pollution, not biodegradable</a:t>
-            </a:r>
-          </a:p>
-          <a:p>
-            <a:r>
-              <a:rPr sz="1800"/>
-              <a:t>Glass — Advantages: Reusable, non-toxic, preserves flavor | Disadvantages: Heavy, fragile</a:t>
-            </a:r>
-          </a:p>
-          <a:p>
-            <a:r>
-              <a:rPr sz="1800"/>
-              <a:t>Metal — Advantages: Long shelf life, strong protection | Disadvantages: Expensive, possible corrosion</a:t>
-            </a:r>
-          </a:p>
-          <a:p>
-            <a:r>
-              <a:rPr sz="1800"/>
-              <a:t>Paper/Cardboard — Advantages: Eco-friendly, recyclable | Disadvantages: Low durability, limited moisture resistance</a:t>
-            </a:r>
-          </a:p>
-          <a:p>
-            <a:r>
-              <a:rPr sz="1800"/>
-              <a:t>Choosing the right container depends on food type, storage duration, and environmental considerations.</a:t>
+          <p:cNvPr id="2" name="Rectangle 1"/>
+          <p:cNvSpPr/>
+          <p:nvPr/>
+        </p:nvSpPr>
+        <p:spPr>
+          <a:xfrm>
+            <a:off x="0" y="0"/>
+            <a:ext cx="6825813" cy="6858000"/>
+          </a:xfrm>
+          <a:prstGeom prst="rect">
+            <a:avLst/>
+          </a:prstGeom>
+          <a:solidFill>
+            <a:srgbClr val="1C2734"/>
+          </a:solidFill>
+          <a:ln>
+            <a:noFill/>
+          </a:ln>
+        </p:spPr>
+        <p:style>
+          <a:lnRef idx="1">
+            <a:schemeClr val="accent1"/>
+          </a:lnRef>
+          <a:fillRef idx="3">
+            <a:schemeClr val="accent1"/>
+          </a:fillRef>
+          <a:effectRef idx="2">
+            <a:schemeClr val="accent1"/>
+          </a:effectRef>
+          <a:fontRef idx="minor">
+            <a:schemeClr val="lt1"/>
+          </a:fontRef>
+        </p:style>
+        <p:txBody>
+          <a:bodyPr rtlCol="0" anchor="ctr"/>
+          <a:lstStyle/>
+          <a:p>
+            <a:pPr algn="ctr"/>
+          </a:p>
+        </p:txBody>
+      </p:sp>
+      <p:sp>
+        <p:nvSpPr>
+          <p:cNvPr id="3" name="Rectangle 2"/>
+          <p:cNvSpPr/>
+          <p:nvPr/>
+        </p:nvSpPr>
+        <p:spPr>
+          <a:xfrm>
+            <a:off x="6825813" y="0"/>
+            <a:ext cx="5363138" cy="6858000"/>
+          </a:xfrm>
+          <a:prstGeom prst="rect">
+            <a:avLst/>
+          </a:prstGeom>
+          <a:solidFill>
+            <a:srgbClr val="ECF0F4"/>
+          </a:solidFill>
+          <a:ln>
+            <a:noFill/>
+          </a:ln>
+        </p:spPr>
+        <p:style>
+          <a:lnRef idx="1">
+            <a:schemeClr val="accent1"/>
+          </a:lnRef>
+          <a:fillRef idx="3">
+            <a:schemeClr val="accent1"/>
+          </a:fillRef>
+          <a:effectRef idx="2">
+            <a:schemeClr val="accent1"/>
+          </a:effectRef>
+          <a:fontRef idx="minor">
+            <a:schemeClr val="lt1"/>
+          </a:fontRef>
+        </p:style>
+        <p:txBody>
+          <a:bodyPr rtlCol="0" anchor="ctr"/>
+          <a:lstStyle/>
+          <a:p>
+            <a:pPr algn="ctr"/>
+          </a:p>
+        </p:txBody>
+      </p:sp>
+      <p:sp>
+        <p:nvSpPr>
+          <p:cNvPr id="4" name="TextBox 3"/>
+          <p:cNvSpPr txBox="1"/>
+          <p:nvPr/>
+        </p:nvSpPr>
+        <p:spPr>
+          <a:xfrm>
+            <a:off x="548640" y="320040"/>
+            <a:ext cx="5943600" cy="640080"/>
+          </a:xfrm>
+          <a:prstGeom prst="rect">
+            <a:avLst/>
+          </a:prstGeom>
+          <a:noFill/>
+        </p:spPr>
+        <p:txBody>
+          <a:bodyPr wrap="none">
+            <a:spAutoFit/>
+          </a:bodyPr>
+          <a:lstStyle/>
+          <a:p>
+            <a:r>
+              <a:rPr b="1" sz="3400">
+                <a:solidFill>
+                  <a:srgbClr val="FFFFFF"/>
+                </a:solidFill>
+              </a:rPr>
+              <a:t>Advantages and Disadvantages</a:t>
+            </a:r>
+          </a:p>
+        </p:txBody>
+      </p:sp>
+      <p:sp>
+        <p:nvSpPr>
+          <p:cNvPr id="5" name="TextBox 4"/>
+          <p:cNvSpPr txBox="1"/>
+          <p:nvPr/>
+        </p:nvSpPr>
+        <p:spPr>
+          <a:xfrm>
+            <a:off x="640080" y="1143000"/>
+            <a:ext cx="5943600" cy="5303520"/>
+          </a:xfrm>
+          <a:prstGeom prst="rect">
+            <a:avLst/>
+          </a:prstGeom>
+          <a:noFill/>
+        </p:spPr>
+        <p:txBody>
+          <a:bodyPr wrap="square">
+            <a:spAutoFit/>
+          </a:bodyPr>
+          <a:lstStyle/>
+          <a:p>
+            <a:pPr>
+              <a:spcAft>
+                <a:spcPts val="600"/>
+              </a:spcAft>
+              <a:defRPr sz="1800">
+                <a:solidFill>
+                  <a:srgbClr val="EEF5FA"/>
+                </a:solidFill>
+              </a:defRPr>
+            </a:pPr>
+            <a:r>
+              <a:t>Plastic: + Lightweight, cheap | - Pollution risk</a:t>
+            </a:r>
+          </a:p>
+          <a:p>
+            <a:pPr>
+              <a:spcAft>
+                <a:spcPts val="600"/>
+              </a:spcAft>
+              <a:defRPr sz="1800">
+                <a:solidFill>
+                  <a:srgbClr val="EEF5FA"/>
+                </a:solidFill>
+              </a:defRPr>
+            </a:pPr>
+            <a:r>
+              <a:t>Glass: + Reusable, non-toxic | - Heavy, fragile</a:t>
+            </a:r>
+          </a:p>
+          <a:p>
+            <a:pPr>
+              <a:spcAft>
+                <a:spcPts val="600"/>
+              </a:spcAft>
+              <a:defRPr sz="1800">
+                <a:solidFill>
+                  <a:srgbClr val="EEF5FA"/>
+                </a:solidFill>
+              </a:defRPr>
+            </a:pPr>
+            <a:r>
+              <a:t>Metal: + Strong protection, long shelf life | - Cost, corrosion risk</a:t>
+            </a:r>
+          </a:p>
+          <a:p>
+            <a:pPr>
+              <a:spcAft>
+                <a:spcPts val="600"/>
+              </a:spcAft>
+              <a:defRPr sz="1800">
+                <a:solidFill>
+                  <a:srgbClr val="EEF5FA"/>
+                </a:solidFill>
+              </a:defRPr>
+            </a:pPr>
+            <a:r>
+              <a:t>Paper: + Recyclable, eco-friendly | - Lower moisture resistance</a:t>
+            </a:r>
+          </a:p>
+          <a:p>
+            <a:pPr>
+              <a:spcAft>
+                <a:spcPts val="600"/>
+              </a:spcAft>
+              <a:defRPr sz="1800">
+                <a:solidFill>
+                  <a:srgbClr val="EEF5FA"/>
+                </a:solidFill>
+              </a:defRPr>
+            </a:pPr>
+            <a:r>
+              <a:t>Best choice depends on product type, storage time, and sustainability goals.</a:t>
             </a:r>
           </a:p>
         </p:txBody>
@@ -3375,21 +3918,120 @@
       <p:grpSpPr/>
       <p:sp>
         <p:nvSpPr>
-          <p:cNvPr id="2" name="Title 1"/>
-          <p:cNvSpPr>
-            <a:spLocks noGrp="1"/>
-          </p:cNvSpPr>
-          <p:nvPr>
-            <p:ph type="title"/>
-          </p:nvPr>
-        </p:nvSpPr>
-        <p:spPr/>
-        <p:txBody>
-          <a:bodyPr/>
-          <a:lstStyle/>
-          <a:p>
-            <a:r>
-              <a:rPr sz="1800"/>
+          <p:cNvPr id="2" name="Rectangle 1"/>
+          <p:cNvSpPr/>
+          <p:nvPr/>
+        </p:nvSpPr>
+        <p:spPr>
+          <a:xfrm>
+            <a:off x="0" y="0"/>
+            <a:ext cx="12188952" cy="6858000"/>
+          </a:xfrm>
+          <a:prstGeom prst="rect">
+            <a:avLst/>
+          </a:prstGeom>
+          <a:solidFill>
+            <a:srgbClr val="072D20"/>
+          </a:solidFill>
+          <a:ln>
+            <a:noFill/>
+          </a:ln>
+        </p:spPr>
+        <p:style>
+          <a:lnRef idx="1">
+            <a:schemeClr val="accent1"/>
+          </a:lnRef>
+          <a:fillRef idx="3">
+            <a:schemeClr val="accent1"/>
+          </a:fillRef>
+          <a:effectRef idx="2">
+            <a:schemeClr val="accent1"/>
+          </a:effectRef>
+          <a:fontRef idx="minor">
+            <a:schemeClr val="lt1"/>
+          </a:fontRef>
+        </p:style>
+        <p:txBody>
+          <a:bodyPr rtlCol="0" anchor="ctr"/>
+          <a:lstStyle/>
+          <a:p>
+            <a:pPr algn="ctr"/>
+          </a:p>
+        </p:txBody>
+      </p:sp>
+      <p:sp>
+        <p:nvSpPr>
+          <p:cNvPr id="3" name="Rounded Rectangle 2"/>
+          <p:cNvSpPr/>
+          <p:nvPr/>
+        </p:nvSpPr>
+        <p:spPr>
+          <a:xfrm>
+            <a:off x="640080" y="640080"/>
+            <a:ext cx="10881360" cy="5486400"/>
+          </a:xfrm>
+          <a:prstGeom prst="roundRect">
+            <a:avLst/>
+          </a:prstGeom>
+          <a:solidFill>
+            <a:srgbClr val="FFFFFF"/>
+          </a:solidFill>
+          <a:ln w="31750">
+            <a:solidFill>
+              <a:srgbClr val="47BE84"/>
+            </a:solidFill>
+          </a:ln>
+        </p:spPr>
+        <p:style>
+          <a:lnRef idx="1">
+            <a:schemeClr val="accent1"/>
+          </a:lnRef>
+          <a:fillRef idx="3">
+            <a:schemeClr val="accent1"/>
+          </a:fillRef>
+          <a:effectRef idx="2">
+            <a:schemeClr val="accent1"/>
+          </a:effectRef>
+          <a:fontRef idx="minor">
+            <a:schemeClr val="lt1"/>
+          </a:fontRef>
+        </p:style>
+        <p:txBody>
+          <a:bodyPr rtlCol="0" anchor="ctr"/>
+          <a:lstStyle/>
+          <a:p>
+            <a:pPr algn="ctr"/>
+          </a:p>
+        </p:txBody>
+      </p:sp>
+      <p:sp>
+        <p:nvSpPr>
+          <p:cNvPr id="4" name="TextBox 3"/>
+          <p:cNvSpPr txBox="1"/>
+          <p:nvPr/>
+        </p:nvSpPr>
+        <p:spPr>
+          <a:xfrm>
+            <a:off x="914400" y="914400"/>
+            <a:ext cx="9875520" cy="731520"/>
+          </a:xfrm>
+          <a:prstGeom prst="rect">
+            <a:avLst/>
+          </a:prstGeom>
+          <a:noFill/>
+        </p:spPr>
+        <p:txBody>
+          <a:bodyPr wrap="none">
+            <a:spAutoFit/>
+          </a:bodyPr>
+          <a:lstStyle/>
+          <a:p>
+            <a:r>
+              <a:rPr b="1" sz="3400">
+                <a:solidFill>
+                  <a:srgbClr val="0E4B39"/>
+                </a:solidFill>
+              </a:rPr>
               <a:t>Conclusion &amp; Future of Food Packaging</a:t>
             </a:r>
           </a:p>
@@ -3397,70 +4039,83 @@
       </p:sp>
       <p:sp>
         <p:nvSpPr>
-          <p:cNvPr id="3" name="Content Placeholder 2"/>
-          <p:cNvSpPr>
-            <a:spLocks noGrp="1"/>
-          </p:cNvSpPr>
-          <p:nvPr>
-            <p:ph idx="1"/>
-          </p:nvPr>
-        </p:nvSpPr>
-        <p:spPr/>
-        <p:txBody>
-          <a:bodyPr/>
-          <a:lstStyle/>
-          <a:p>
-            <a:r>
-              <a:rPr sz="1800"/>
-              <a:t>Food packaging containers are essential for ensuring food safety, quality, and convenience.</a:t>
-            </a:r>
-          </a:p>
-          <a:p>
-            <a:r>
-              <a:rPr sz="1800"/>
-              <a:t>Different materials serve different purposes, and selecting the appropriate container is crucial for effective food preservation.</a:t>
-            </a:r>
-          </a:p>
-          <a:p>
-            <a:r>
-              <a:rPr sz="1800"/>
-              <a:t>In recent years, there has been growing focus on sustainable packaging solutions.</a:t>
-            </a:r>
-          </a:p>
-          <a:p>
-            <a:r>
-              <a:rPr sz="1800"/>
-              <a:t>Industries are moving toward:</a:t>
-            </a:r>
-          </a:p>
-          <a:p>
-            <a:r>
-              <a:rPr sz="1800"/>
-              <a:t>• Biodegradable and compostable materials</a:t>
-            </a:r>
-          </a:p>
-          <a:p>
-            <a:r>
-              <a:rPr sz="1800"/>
-              <a:t>• Reusable packaging systems</a:t>
-            </a:r>
-          </a:p>
-          <a:p>
-            <a:r>
-              <a:rPr sz="1800"/>
-              <a:t>• Reduction of plastic waste</a:t>
-            </a:r>
-          </a:p>
-          <a:p>
-            <a:r>
-              <a:rPr sz="1800"/>
-              <a:t>The future of food packaging lies in balancing functionality, cost, and environmental impact.</a:t>
-            </a:r>
-          </a:p>
-          <a:p>
-            <a:r>
-              <a:rPr sz="1800"/>
-              <a:t>Bonus line: “The selection of packaging material directly impacts food safety, shelf life, and environmental sustainability.”</a:t>
+          <p:cNvPr id="5" name="TextBox 4"/>
+          <p:cNvSpPr txBox="1"/>
+          <p:nvPr/>
+        </p:nvSpPr>
+        <p:spPr>
+          <a:xfrm>
+            <a:off x="1005840" y="1737360"/>
+            <a:ext cx="9784080" cy="3200400"/>
+          </a:xfrm>
+          <a:prstGeom prst="rect">
+            <a:avLst/>
+          </a:prstGeom>
+          <a:noFill/>
+        </p:spPr>
+        <p:txBody>
+          <a:bodyPr wrap="square">
+            <a:spAutoFit/>
+          </a:bodyPr>
+          <a:lstStyle/>
+          <a:p>
+            <a:pPr>
+              <a:spcAft>
+                <a:spcPts val="600"/>
+              </a:spcAft>
+              <a:defRPr sz="2200">
+                <a:solidFill>
+                  <a:srgbClr val="142D26"/>
+                </a:solidFill>
+              </a:defRPr>
+            </a:pPr>
+            <a:r>
+              <a:t>Food containers are essential for safety, quality, and convenience in modern supply chains.</a:t>
+            </a:r>
+          </a:p>
+          <a:p>
+            <a:pPr>
+              <a:spcAft>
+                <a:spcPts val="600"/>
+              </a:spcAft>
+              <a:defRPr sz="2200">
+                <a:solidFill>
+                  <a:srgbClr val="142D26"/>
+                </a:solidFill>
+              </a:defRPr>
+            </a:pPr>
+            <a:r>
+              <a:t>Future-focused packaging is shifting to biodegradable materials and reusable systems.</a:t>
+            </a:r>
+          </a:p>
+          <a:p>
+            <a:pPr>
+              <a:spcAft>
+                <a:spcPts val="600"/>
+              </a:spcAft>
+              <a:defRPr sz="2200">
+                <a:solidFill>
+                  <a:srgbClr val="142D26"/>
+                </a:solidFill>
+              </a:defRPr>
+            </a:pPr>
+            <a:r>
+              <a:t>Reducing plastic waste is now a major global design and policy priority.</a:t>
+            </a:r>
+          </a:p>
+          <a:p>
+            <a:pPr>
+              <a:spcAft>
+                <a:spcPts val="600"/>
+              </a:spcAft>
+              <a:defRPr sz="2200">
+                <a:solidFill>
+                  <a:srgbClr val="142D26"/>
+                </a:solidFill>
+              </a:defRPr>
+            </a:pPr>
+            <a:r>
+              <a:t>Bonus Tip: Packaging choices directly impact food safety, shelf life, and sustainability.</a:t>
             </a:r>
           </a:p>
         </p:txBody>

</xml_diff>

<commit_message>
Create 4-slide professor review PPT with photos and key LCE comparisons
Agent-Logs-Url: https://github.com/aniket-kanani-3107/aniket-kanani-3107.github.io/sessions/d17d2272-7562-402b-92d9-a3d2d34d65a6

Co-authored-by: aniket-kanani-3107 <268387354+aniket-kanani-3107@users.noreply.github.com>
</commit_message>
<xml_diff>
--- a/Food-Packaging-Containers.pptx
+++ b/Food-Packaging-Containers.pptx
@@ -3136,20 +3136,90 @@
       </p:sp>
       <p:sp>
         <p:nvSpPr>
-          <p:cNvPr id="3" name="Rectangle 2"/>
+          <p:cNvPr id="3" name="TextBox 2"/>
+          <p:cNvSpPr txBox="1"/>
+          <p:nvPr/>
+        </p:nvSpPr>
+        <p:spPr>
+          <a:xfrm>
+            <a:off x="731520" y="457200"/>
+            <a:ext cx="10972800" cy="640080"/>
+          </a:xfrm>
+          <a:prstGeom prst="rect">
+            <a:avLst/>
+          </a:prstGeom>
+          <a:noFill/>
+        </p:spPr>
+        <p:txBody>
+          <a:bodyPr wrap="none">
+            <a:spAutoFit/>
+          </a:bodyPr>
+          <a:lstStyle/>
+          <a:p>
+            <a:pPr>
+              <a:defRPr b="1" sz="3800">
+                <a:solidFill>
+                  <a:srgbClr val="FFFFFF"/>
+                </a:solidFill>
+              </a:defRPr>
+            </a:pPr>
+            <a:r>
+              <a:t>Life Cycle Engineering Application</a:t>
+            </a:r>
+          </a:p>
+        </p:txBody>
+      </p:sp>
+      <p:sp>
+        <p:nvSpPr>
+          <p:cNvPr id="4" name="TextBox 3"/>
+          <p:cNvSpPr txBox="1"/>
+          <p:nvPr/>
+        </p:nvSpPr>
+        <p:spPr>
+          <a:xfrm>
+            <a:off x="731520" y="1188720"/>
+            <a:ext cx="10789920" cy="640080"/>
+          </a:xfrm>
+          <a:prstGeom prst="rect">
+            <a:avLst/>
+          </a:prstGeom>
+          <a:noFill/>
+        </p:spPr>
+        <p:txBody>
+          <a:bodyPr wrap="none">
+            <a:spAutoFit/>
+          </a:bodyPr>
+          <a:lstStyle/>
+          <a:p>
+            <a:pPr>
+              <a:defRPr b="1" sz="2800">
+                <a:solidFill>
+                  <a:srgbClr val="FFFFFF"/>
+                </a:solidFill>
+              </a:defRPr>
+            </a:pPr>
+            <a:r>
+              <a:t>PLA vs. Biodegradable PPE Food Packaging Containers</a:t>
+            </a:r>
+          </a:p>
+        </p:txBody>
+      </p:sp>
+      <p:sp>
+        <p:nvSpPr>
+          <p:cNvPr id="5" name="Rounded Rectangle 4"/>
           <p:cNvSpPr/>
           <p:nvPr/>
         </p:nvSpPr>
         <p:spPr>
           <a:xfrm>
-            <a:off x="502920" y="987552"/>
-            <a:ext cx="109728" cy="4297680"/>
-          </a:xfrm>
-          <a:prstGeom prst="rect">
+            <a:off x="731520" y="2057400"/>
+            <a:ext cx="7223760" cy="4389120"/>
+          </a:xfrm>
+          <a:prstGeom prst="roundRect">
             <a:avLst/>
           </a:prstGeom>
           <a:solidFill>
-            <a:srgbClr val="47BE84"/>
+            <a:srgbClr val="FFFFFF"/>
           </a:solidFill>
           <a:ln>
             <a:noFill/>
@@ -3179,47 +3249,14 @@
       </p:sp>
       <p:sp>
         <p:nvSpPr>
-          <p:cNvPr id="4" name="TextBox 3"/>
+          <p:cNvPr id="6" name="TextBox 5"/>
           <p:cNvSpPr txBox="1"/>
           <p:nvPr/>
         </p:nvSpPr>
         <p:spPr>
           <a:xfrm>
-            <a:off x="548640" y="274320"/>
-            <a:ext cx="6583680" cy="640080"/>
-          </a:xfrm>
-          <a:prstGeom prst="rect">
-            <a:avLst/>
-          </a:prstGeom>
-          <a:noFill/>
-        </p:spPr>
-        <p:txBody>
-          <a:bodyPr wrap="none">
-            <a:spAutoFit/>
-          </a:bodyPr>
-          <a:lstStyle/>
-          <a:p>
-            <a:r>
-              <a:rPr b="1" sz="3400">
-                <a:solidFill>
-                  <a:srgbClr val="FFFFFF"/>
-                </a:solidFill>
-              </a:rPr>
-              <a:t>Introduction to Food Packaging Containers</a:t>
-            </a:r>
-          </a:p>
-        </p:txBody>
-      </p:sp>
-      <p:sp>
-        <p:nvSpPr>
-          <p:cNvPr id="5" name="TextBox 4"/>
-          <p:cNvSpPr txBox="1"/>
-          <p:nvPr/>
-        </p:nvSpPr>
-        <p:spPr>
-          <a:xfrm>
-            <a:off x="822960" y="1188720"/>
-            <a:ext cx="6492240" cy="4206240"/>
+            <a:off x="1005840" y="2331720"/>
+            <a:ext cx="6583680" cy="3566160"/>
           </a:xfrm>
           <a:prstGeom prst="rect">
             <a:avLst/>
@@ -3234,46 +3271,103 @@
           <a:p>
             <a:pPr>
               <a:spcAft>
-                <a:spcPts val="600"/>
+                <a:spcPts val="400"/>
               </a:spcAft>
-              <a:defRPr sz="2100">
-                <a:solidFill>
-                  <a:srgbClr val="F5F5F5"/>
+              <a:defRPr sz="2000">
+                <a:solidFill>
+                  <a:srgbClr val="162535"/>
                 </a:solidFill>
               </a:defRPr>
             </a:pPr>
             <a:r>
-              <a:t>Food packaging containers store, protect, preserve, and transport food products.</a:t>
+              <a:t>Course: Life Cycle Engineering 2026</a:t>
             </a:r>
           </a:p>
           <a:p>
             <a:pPr>
               <a:spcAft>
-                <a:spcPts val="600"/>
+                <a:spcPts val="400"/>
               </a:spcAft>
-              <a:defRPr sz="2100">
-                <a:solidFill>
-                  <a:srgbClr val="F5F5F5"/>
+              <a:defRPr sz="2000">
+                <a:solidFill>
+                  <a:srgbClr val="162535"/>
                 </a:solidFill>
               </a:defRPr>
             </a:pPr>
             <a:r>
-              <a:t>They maintain quality and shelf life while reducing contamination from moisture, air, and microbes.</a:t>
+              <a:t>Professor: Paulo Peças</a:t>
             </a:r>
           </a:p>
           <a:p>
             <a:pPr>
               <a:spcAft>
-                <a:spcPts val="600"/>
+                <a:spcPts val="400"/>
               </a:spcAft>
-              <a:defRPr sz="2100">
-                <a:solidFill>
-                  <a:srgbClr val="F5F5F5"/>
+              <a:defRPr sz="2000">
+                <a:solidFill>
+                  <a:srgbClr val="162535"/>
                 </a:solidFill>
               </a:defRPr>
             </a:pPr>
             <a:r>
-              <a:t>Main functions include protection, freshness, safer logistics, and clear consumer labeling.</a:t>
+              <a:t>Group Members: ____________________</a:t>
+            </a:r>
+          </a:p>
+          <a:p>
+            <a:pPr>
+              <a:spcAft>
+                <a:spcPts val="400"/>
+              </a:spcAft>
+              <a:defRPr sz="2000">
+                <a:solidFill>
+                  <a:srgbClr val="162535"/>
+                </a:solidFill>
+              </a:defRPr>
+            </a:pPr>
+            <a:r>
+              <a:t>Date: July 1, 2026</a:t>
+            </a:r>
+          </a:p>
+          <a:p>
+            <a:pPr>
+              <a:spcAft>
+                <a:spcPts val="400"/>
+              </a:spcAft>
+              <a:defRPr sz="2000">
+                <a:solidFill>
+                  <a:srgbClr val="162535"/>
+                </a:solidFill>
+              </a:defRPr>
+            </a:pPr>
+          </a:p>
+          <a:p>
+            <a:pPr>
+              <a:spcAft>
+                <a:spcPts val="400"/>
+              </a:spcAft>
+              <a:defRPr sz="2000">
+                <a:solidFill>
+                  <a:srgbClr val="162535"/>
+                </a:solidFill>
+              </a:defRPr>
+            </a:pPr>
+            <a:r>
+              <a:t>Why this product?</a:t>
+            </a:r>
+          </a:p>
+          <a:p>
+            <a:pPr>
+              <a:spcAft>
+                <a:spcPts val="400"/>
+              </a:spcAft>
+              <a:defRPr sz="2000">
+                <a:solidFill>
+                  <a:srgbClr val="162535"/>
+                </a:solidFill>
+              </a:defRPr>
+            </a:pPr>
+            <a:r>
+              <a:t>Takeaway containers are high-volume single-use items and a major lever for plastic-waste reduction under EU policy shifts.</a:t>
             </a:r>
           </a:p>
         </p:txBody>
@@ -3311,7 +3405,7 @@
             <a:avLst/>
           </a:prstGeom>
           <a:solidFill>
-            <a:srgbClr val="F5F8FC"/>
+            <a:srgbClr val="F4F8FC"/>
           </a:solidFill>
           <a:ln>
             <a:noFill/>
@@ -3347,8 +3441,8 @@
         </p:nvSpPr>
         <p:spPr>
           <a:xfrm>
-            <a:off x="548640" y="274320"/>
-            <a:ext cx="6583680" cy="640080"/>
+            <a:off x="502920" y="228600"/>
+            <a:ext cx="10972800" cy="640080"/>
           </a:xfrm>
           <a:prstGeom prst="rect">
             <a:avLst/>
@@ -3361,13 +3455,15 @@
           </a:bodyPr>
           <a:lstStyle/>
           <a:p>
-            <a:r>
-              <a:rPr b="1" sz="3400">
-                <a:solidFill>
-                  <a:srgbClr val="163963"/>
-                </a:solidFill>
-              </a:rPr>
-              <a:t>Types of Food Containers</a:t>
+            <a:pPr>
+              <a:defRPr b="1" sz="3000">
+                <a:solidFill>
+                  <a:srgbClr val="113C69"/>
+                </a:solidFill>
+              </a:defRPr>
+            </a:pPr>
+            <a:r>
+              <a:t>Product Characterization, Alternatives, and Process Model</a:t>
             </a:r>
           </a:p>
         </p:txBody>
@@ -3380,17 +3476,19 @@
         </p:nvSpPr>
         <p:spPr>
           <a:xfrm>
-            <a:off x="502920" y="2788920"/>
-            <a:ext cx="2377440" cy="384048"/>
+            <a:off x="502920" y="914400"/>
+            <a:ext cx="5486400" cy="2377440"/>
           </a:xfrm>
           <a:prstGeom prst="roundRect">
             <a:avLst/>
           </a:prstGeom>
           <a:solidFill>
-            <a:srgbClr val="163963"/>
+            <a:srgbClr val="FFFFFF"/>
           </a:solidFill>
           <a:ln>
-            <a:noFill/>
+            <a:solidFill>
+              <a:srgbClr val="CBD6E3"/>
+            </a:solidFill>
           </a:ln>
         </p:spPr>
         <p:style>
@@ -3411,38 +3509,167 @@
           <a:bodyPr rtlCol="0" anchor="ctr"/>
           <a:lstStyle/>
           <a:p>
-            <a:pPr algn="ctr">
-              <a:defRPr b="1" sz="1400">
-                <a:solidFill>
-                  <a:srgbClr val="FFFFFF"/>
+            <a:pPr algn="ctr"/>
+          </a:p>
+        </p:txBody>
+      </p:sp>
+      <p:sp>
+        <p:nvSpPr>
+          <p:cNvPr id="5" name="TextBox 4"/>
+          <p:cNvSpPr txBox="1"/>
+          <p:nvPr/>
+        </p:nvSpPr>
+        <p:spPr>
+          <a:xfrm>
+            <a:off x="731520" y="1143000"/>
+            <a:ext cx="5029200" cy="1920240"/>
+          </a:xfrm>
+          <a:prstGeom prst="rect">
+            <a:avLst/>
+          </a:prstGeom>
+          <a:noFill/>
+        </p:spPr>
+        <p:txBody>
+          <a:bodyPr wrap="square">
+            <a:spAutoFit/>
+          </a:bodyPr>
+          <a:lstStyle/>
+          <a:p>
+            <a:pPr>
+              <a:spcAft>
+                <a:spcPts val="400"/>
+              </a:spcAft>
+              <a:defRPr sz="1400">
+                <a:solidFill>
+                  <a:srgbClr val="222E3A"/>
                 </a:solidFill>
               </a:defRPr>
             </a:pPr>
             <a:r>
-              <a:t>Plastic</a:t>
-            </a:r>
-          </a:p>
-        </p:txBody>
-      </p:sp>
-      <p:sp>
-        <p:nvSpPr>
-          <p:cNvPr id="5" name="Rounded Rectangle 4"/>
+              <a:t>• Functional Unit: 1,000 containers (500–750 mL)</a:t>
+            </a:r>
+          </a:p>
+          <a:p>
+            <a:pPr>
+              <a:spcAft>
+                <a:spcPts val="400"/>
+              </a:spcAft>
+              <a:defRPr sz="1400">
+                <a:solidFill>
+                  <a:srgbClr val="222E3A"/>
+                </a:solidFill>
+              </a:defRPr>
+            </a:pPr>
+            <a:r>
+              <a:t>• Market Size (EU): 8–10 billion units/year</a:t>
+            </a:r>
+          </a:p>
+          <a:p>
+            <a:pPr>
+              <a:spcAft>
+                <a:spcPts val="400"/>
+              </a:spcAft>
+              <a:defRPr sz="1400">
+                <a:solidFill>
+                  <a:srgbClr val="222E3A"/>
+                </a:solidFill>
+              </a:defRPr>
+            </a:pPr>
+            <a:r>
+              <a:t>• Requirements: food-safe, heat-resistant, lightweight, low-cost, scalable</a:t>
+            </a:r>
+          </a:p>
+          <a:p>
+            <a:pPr>
+              <a:spcAft>
+                <a:spcPts val="400"/>
+              </a:spcAft>
+              <a:defRPr sz="1400">
+                <a:solidFill>
+                  <a:srgbClr val="222E3A"/>
+                </a:solidFill>
+              </a:defRPr>
+            </a:pPr>
+            <a:r>
+              <a:t>• PLA: density 1.24 g/cm³ | thermoforming | ~55°C | industrial composting</a:t>
+            </a:r>
+          </a:p>
+          <a:p>
+            <a:pPr>
+              <a:spcAft>
+                <a:spcPts val="400"/>
+              </a:spcAft>
+              <a:defRPr sz="1400">
+                <a:solidFill>
+                  <a:srgbClr val="222E3A"/>
+                </a:solidFill>
+              </a:defRPr>
+            </a:pPr>
+            <a:r>
+              <a:t>• PPE: density 0.90 g/cm³ | injection moulding | up to 100°C | limited compostability</a:t>
+            </a:r>
+          </a:p>
+        </p:txBody>
+      </p:sp>
+      <p:sp>
+        <p:nvSpPr>
+          <p:cNvPr id="6" name="TextBox 5"/>
+          <p:cNvSpPr txBox="1"/>
+          <p:nvPr/>
+        </p:nvSpPr>
+        <p:spPr>
+          <a:xfrm>
+            <a:off x="640080" y="3611880"/>
+            <a:ext cx="2103120" cy="365760"/>
+          </a:xfrm>
+          <a:prstGeom prst="rect">
+            <a:avLst/>
+          </a:prstGeom>
+          <a:noFill/>
+        </p:spPr>
+        <p:txBody>
+          <a:bodyPr wrap="square">
+            <a:spAutoFit/>
+          </a:bodyPr>
+          <a:lstStyle/>
+          <a:p>
+            <a:pPr>
+              <a:spcAft>
+                <a:spcPts val="400"/>
+              </a:spcAft>
+              <a:defRPr sz="1400" b="1">
+                <a:solidFill>
+                  <a:srgbClr val="075745"/>
+                </a:solidFill>
+              </a:defRPr>
+            </a:pPr>
+            <a:r>
+              <a:t>PLA Process Chain</a:t>
+            </a:r>
+          </a:p>
+        </p:txBody>
+      </p:sp>
+      <p:sp>
+        <p:nvSpPr>
+          <p:cNvPr id="7" name="Rounded Rectangle 6"/>
           <p:cNvSpPr/>
           <p:nvPr/>
         </p:nvSpPr>
         <p:spPr>
           <a:xfrm>
-            <a:off x="3154680" y="2788920"/>
-            <a:ext cx="2377440" cy="384048"/>
+            <a:off x="640080" y="3977639"/>
+            <a:ext cx="960120" cy="502920"/>
           </a:xfrm>
           <a:prstGeom prst="roundRect">
             <a:avLst/>
           </a:prstGeom>
           <a:solidFill>
-            <a:srgbClr val="163963"/>
+            <a:srgbClr val="DBF2EB"/>
           </a:solidFill>
           <a:ln>
-            <a:noFill/>
+            <a:solidFill>
+              <a:srgbClr val="529B82"/>
+            </a:solidFill>
           </a:ln>
         </p:spPr>
         <p:style>
@@ -3464,34 +3691,30 @@
           <a:lstStyle/>
           <a:p>
             <a:pPr algn="ctr">
-              <a:defRPr b="1" sz="1400">
-                <a:solidFill>
-                  <a:srgbClr val="FFFFFF"/>
-                </a:solidFill>
-              </a:defRPr>
+              <a:defRPr sz="1000"/>
             </a:pPr>
             <a:r>
-              <a:t>Glass</a:t>
-            </a:r>
-          </a:p>
-        </p:txBody>
-      </p:sp>
-      <p:sp>
-        <p:nvSpPr>
-          <p:cNvPr id="6" name="Rounded Rectangle 5"/>
+              <a:t>PLA granulate</a:t>
+            </a:r>
+          </a:p>
+        </p:txBody>
+      </p:sp>
+      <p:sp>
+        <p:nvSpPr>
+          <p:cNvPr id="8" name="Rectangle 7"/>
           <p:cNvSpPr/>
           <p:nvPr/>
         </p:nvSpPr>
         <p:spPr>
           <a:xfrm>
-            <a:off x="5806440" y="2788920"/>
-            <a:ext cx="2377440" cy="384048"/>
-          </a:xfrm>
-          <a:prstGeom prst="roundRect">
+            <a:off x="1618488" y="4169663"/>
+            <a:ext cx="320040" cy="91440"/>
+          </a:xfrm>
+          <a:prstGeom prst="rect">
             <a:avLst/>
           </a:prstGeom>
           <a:solidFill>
-            <a:srgbClr val="163963"/>
+            <a:srgbClr val="529B82"/>
           </a:solidFill>
           <a:ln>
             <a:noFill/>
@@ -3515,38 +3738,31 @@
           <a:bodyPr rtlCol="0" anchor="ctr"/>
           <a:lstStyle/>
           <a:p>
-            <a:pPr algn="ctr">
-              <a:defRPr b="1" sz="1400">
-                <a:solidFill>
-                  <a:srgbClr val="FFFFFF"/>
-                </a:solidFill>
-              </a:defRPr>
-            </a:pPr>
-            <a:r>
-              <a:t>Metal</a:t>
-            </a:r>
-          </a:p>
-        </p:txBody>
-      </p:sp>
-      <p:sp>
-        <p:nvSpPr>
-          <p:cNvPr id="7" name="Rounded Rectangle 6"/>
+            <a:pPr algn="ctr"/>
+          </a:p>
+        </p:txBody>
+      </p:sp>
+      <p:sp>
+        <p:nvSpPr>
+          <p:cNvPr id="9" name="Rounded Rectangle 8"/>
           <p:cNvSpPr/>
           <p:nvPr/>
         </p:nvSpPr>
         <p:spPr>
           <a:xfrm>
-            <a:off x="8458200" y="2788920"/>
-            <a:ext cx="2377440" cy="384048"/>
+            <a:off x="1965960" y="3977639"/>
+            <a:ext cx="960120" cy="502920"/>
           </a:xfrm>
           <a:prstGeom prst="roundRect">
             <a:avLst/>
           </a:prstGeom>
           <a:solidFill>
-            <a:srgbClr val="163963"/>
+            <a:srgbClr val="DBF2EB"/>
           </a:solidFill>
           <a:ln>
-            <a:noFill/>
+            <a:solidFill>
+              <a:srgbClr val="529B82"/>
+            </a:solidFill>
           </a:ln>
         </p:spPr>
         <p:style>
@@ -3568,28 +3784,303 @@
           <a:lstStyle/>
           <a:p>
             <a:pPr algn="ctr">
-              <a:defRPr b="1" sz="1400">
-                <a:solidFill>
-                  <a:srgbClr val="FFFFFF"/>
-                </a:solidFill>
-              </a:defRPr>
+              <a:defRPr sz="1000"/>
             </a:pPr>
             <a:r>
-              <a:t>Paper/Cardboard</a:t>
-            </a:r>
-          </a:p>
-        </p:txBody>
-      </p:sp>
-      <p:sp>
-        <p:nvSpPr>
-          <p:cNvPr id="8" name="TextBox 7"/>
+              <a:t>Sheet extrusion</a:t>
+            </a:r>
+          </a:p>
+        </p:txBody>
+      </p:sp>
+      <p:sp>
+        <p:nvSpPr>
+          <p:cNvPr id="10" name="Rectangle 9"/>
+          <p:cNvSpPr/>
+          <p:nvPr/>
+        </p:nvSpPr>
+        <p:spPr>
+          <a:xfrm>
+            <a:off x="2944368" y="4169663"/>
+            <a:ext cx="320040" cy="91440"/>
+          </a:xfrm>
+          <a:prstGeom prst="rect">
+            <a:avLst/>
+          </a:prstGeom>
+          <a:solidFill>
+            <a:srgbClr val="529B82"/>
+          </a:solidFill>
+          <a:ln>
+            <a:noFill/>
+          </a:ln>
+        </p:spPr>
+        <p:style>
+          <a:lnRef idx="1">
+            <a:schemeClr val="accent1"/>
+          </a:lnRef>
+          <a:fillRef idx="3">
+            <a:schemeClr val="accent1"/>
+          </a:fillRef>
+          <a:effectRef idx="2">
+            <a:schemeClr val="accent1"/>
+          </a:effectRef>
+          <a:fontRef idx="minor">
+            <a:schemeClr val="lt1"/>
+          </a:fontRef>
+        </p:style>
+        <p:txBody>
+          <a:bodyPr rtlCol="0" anchor="ctr"/>
+          <a:lstStyle/>
+          <a:p>
+            <a:pPr algn="ctr"/>
+          </a:p>
+        </p:txBody>
+      </p:sp>
+      <p:sp>
+        <p:nvSpPr>
+          <p:cNvPr id="11" name="Rounded Rectangle 10"/>
+          <p:cNvSpPr/>
+          <p:nvPr/>
+        </p:nvSpPr>
+        <p:spPr>
+          <a:xfrm>
+            <a:off x="3291839" y="3977639"/>
+            <a:ext cx="960120" cy="502920"/>
+          </a:xfrm>
+          <a:prstGeom prst="roundRect">
+            <a:avLst/>
+          </a:prstGeom>
+          <a:solidFill>
+            <a:srgbClr val="DBF2EB"/>
+          </a:solidFill>
+          <a:ln>
+            <a:solidFill>
+              <a:srgbClr val="529B82"/>
+            </a:solidFill>
+          </a:ln>
+        </p:spPr>
+        <p:style>
+          <a:lnRef idx="1">
+            <a:schemeClr val="accent1"/>
+          </a:lnRef>
+          <a:fillRef idx="3">
+            <a:schemeClr val="accent1"/>
+          </a:fillRef>
+          <a:effectRef idx="2">
+            <a:schemeClr val="accent1"/>
+          </a:effectRef>
+          <a:fontRef idx="minor">
+            <a:schemeClr val="lt1"/>
+          </a:fontRef>
+        </p:style>
+        <p:txBody>
+          <a:bodyPr rtlCol="0" anchor="ctr"/>
+          <a:lstStyle/>
+          <a:p>
+            <a:pPr algn="ctr">
+              <a:defRPr sz="1000"/>
+            </a:pPr>
+            <a:r>
+              <a:t>Thermoforming</a:t>
+            </a:r>
+          </a:p>
+        </p:txBody>
+      </p:sp>
+      <p:sp>
+        <p:nvSpPr>
+          <p:cNvPr id="12" name="Rectangle 11"/>
+          <p:cNvSpPr/>
+          <p:nvPr/>
+        </p:nvSpPr>
+        <p:spPr>
+          <a:xfrm>
+            <a:off x="4270248" y="4169663"/>
+            <a:ext cx="320040" cy="91440"/>
+          </a:xfrm>
+          <a:prstGeom prst="rect">
+            <a:avLst/>
+          </a:prstGeom>
+          <a:solidFill>
+            <a:srgbClr val="529B82"/>
+          </a:solidFill>
+          <a:ln>
+            <a:noFill/>
+          </a:ln>
+        </p:spPr>
+        <p:style>
+          <a:lnRef idx="1">
+            <a:schemeClr val="accent1"/>
+          </a:lnRef>
+          <a:fillRef idx="3">
+            <a:schemeClr val="accent1"/>
+          </a:fillRef>
+          <a:effectRef idx="2">
+            <a:schemeClr val="accent1"/>
+          </a:effectRef>
+          <a:fontRef idx="minor">
+            <a:schemeClr val="lt1"/>
+          </a:fontRef>
+        </p:style>
+        <p:txBody>
+          <a:bodyPr rtlCol="0" anchor="ctr"/>
+          <a:lstStyle/>
+          <a:p>
+            <a:pPr algn="ctr"/>
+          </a:p>
+        </p:txBody>
+      </p:sp>
+      <p:sp>
+        <p:nvSpPr>
+          <p:cNvPr id="13" name="Rounded Rectangle 12"/>
+          <p:cNvSpPr/>
+          <p:nvPr/>
+        </p:nvSpPr>
+        <p:spPr>
+          <a:xfrm>
+            <a:off x="4617720" y="3977639"/>
+            <a:ext cx="960120" cy="502920"/>
+          </a:xfrm>
+          <a:prstGeom prst="roundRect">
+            <a:avLst/>
+          </a:prstGeom>
+          <a:solidFill>
+            <a:srgbClr val="DBF2EB"/>
+          </a:solidFill>
+          <a:ln>
+            <a:solidFill>
+              <a:srgbClr val="529B82"/>
+            </a:solidFill>
+          </a:ln>
+        </p:spPr>
+        <p:style>
+          <a:lnRef idx="1">
+            <a:schemeClr val="accent1"/>
+          </a:lnRef>
+          <a:fillRef idx="3">
+            <a:schemeClr val="accent1"/>
+          </a:fillRef>
+          <a:effectRef idx="2">
+            <a:schemeClr val="accent1"/>
+          </a:effectRef>
+          <a:fontRef idx="minor">
+            <a:schemeClr val="lt1"/>
+          </a:fontRef>
+        </p:style>
+        <p:txBody>
+          <a:bodyPr rtlCol="0" anchor="ctr"/>
+          <a:lstStyle/>
+          <a:p>
+            <a:pPr algn="ctr">
+              <a:defRPr sz="1000"/>
+            </a:pPr>
+            <a:r>
+              <a:t>Trimming</a:t>
+            </a:r>
+          </a:p>
+        </p:txBody>
+      </p:sp>
+      <p:sp>
+        <p:nvSpPr>
+          <p:cNvPr id="14" name="Rectangle 13"/>
+          <p:cNvSpPr/>
+          <p:nvPr/>
+        </p:nvSpPr>
+        <p:spPr>
+          <a:xfrm>
+            <a:off x="5596128" y="4169663"/>
+            <a:ext cx="320040" cy="91440"/>
+          </a:xfrm>
+          <a:prstGeom prst="rect">
+            <a:avLst/>
+          </a:prstGeom>
+          <a:solidFill>
+            <a:srgbClr val="529B82"/>
+          </a:solidFill>
+          <a:ln>
+            <a:noFill/>
+          </a:ln>
+        </p:spPr>
+        <p:style>
+          <a:lnRef idx="1">
+            <a:schemeClr val="accent1"/>
+          </a:lnRef>
+          <a:fillRef idx="3">
+            <a:schemeClr val="accent1"/>
+          </a:fillRef>
+          <a:effectRef idx="2">
+            <a:schemeClr val="accent1"/>
+          </a:effectRef>
+          <a:fontRef idx="minor">
+            <a:schemeClr val="lt1"/>
+          </a:fontRef>
+        </p:style>
+        <p:txBody>
+          <a:bodyPr rtlCol="0" anchor="ctr"/>
+          <a:lstStyle/>
+          <a:p>
+            <a:pPr algn="ctr"/>
+          </a:p>
+        </p:txBody>
+      </p:sp>
+      <p:sp>
+        <p:nvSpPr>
+          <p:cNvPr id="15" name="Rounded Rectangle 14"/>
+          <p:cNvSpPr/>
+          <p:nvPr/>
+        </p:nvSpPr>
+        <p:spPr>
+          <a:xfrm>
+            <a:off x="5943600" y="3977639"/>
+            <a:ext cx="960120" cy="502920"/>
+          </a:xfrm>
+          <a:prstGeom prst="roundRect">
+            <a:avLst/>
+          </a:prstGeom>
+          <a:solidFill>
+            <a:srgbClr val="DBF2EB"/>
+          </a:solidFill>
+          <a:ln>
+            <a:solidFill>
+              <a:srgbClr val="529B82"/>
+            </a:solidFill>
+          </a:ln>
+        </p:spPr>
+        <p:style>
+          <a:lnRef idx="1">
+            <a:schemeClr val="accent1"/>
+          </a:lnRef>
+          <a:fillRef idx="3">
+            <a:schemeClr val="accent1"/>
+          </a:fillRef>
+          <a:effectRef idx="2">
+            <a:schemeClr val="accent1"/>
+          </a:effectRef>
+          <a:fontRef idx="minor">
+            <a:schemeClr val="lt1"/>
+          </a:fontRef>
+        </p:style>
+        <p:txBody>
+          <a:bodyPr rtlCol="0" anchor="ctr"/>
+          <a:lstStyle/>
+          <a:p>
+            <a:pPr algn="ctr">
+              <a:defRPr sz="1000"/>
+            </a:pPr>
+            <a:r>
+              <a:t>Packaging</a:t>
+            </a:r>
+          </a:p>
+        </p:txBody>
+      </p:sp>
+      <p:sp>
+        <p:nvSpPr>
+          <p:cNvPr id="16" name="TextBox 15"/>
           <p:cNvSpPr txBox="1"/>
           <p:nvPr/>
         </p:nvSpPr>
         <p:spPr>
           <a:xfrm>
-            <a:off x="685800" y="3429000"/>
-            <a:ext cx="10972800" cy="2926080"/>
+            <a:off x="640080" y="4681728"/>
+            <a:ext cx="2103120" cy="365760"/>
           </a:xfrm>
           <a:prstGeom prst="rect">
             <a:avLst/>
@@ -3604,61 +4095,476 @@
           <a:p>
             <a:pPr>
               <a:spcAft>
-                <a:spcPts val="600"/>
+                <a:spcPts val="400"/>
               </a:spcAft>
-              <a:defRPr sz="1800">
-                <a:solidFill>
-                  <a:srgbClr val="1E1E1E"/>
+              <a:defRPr sz="1400" b="1">
+                <a:solidFill>
+                  <a:srgbClr val="70430C"/>
                 </a:solidFill>
               </a:defRPr>
             </a:pPr>
             <a:r>
-              <a:t>• Plastic: lightweight and cost-effective for bottles, dairy, and takeaway packs.</a:t>
-            </a:r>
-          </a:p>
+              <a:t>PPE Process Chain</a:t>
+            </a:r>
+          </a:p>
+        </p:txBody>
+      </p:sp>
+      <p:sp>
+        <p:nvSpPr>
+          <p:cNvPr id="17" name="Rounded Rectangle 16"/>
+          <p:cNvSpPr/>
+          <p:nvPr/>
+        </p:nvSpPr>
+        <p:spPr>
+          <a:xfrm>
+            <a:off x="640080" y="5029200"/>
+            <a:ext cx="960120" cy="502920"/>
+          </a:xfrm>
+          <a:prstGeom prst="roundRect">
+            <a:avLst/>
+          </a:prstGeom>
+          <a:solidFill>
+            <a:srgbClr val="FFECD6"/>
+          </a:solidFill>
+          <a:ln>
+            <a:solidFill>
+              <a:srgbClr val="C2833A"/>
+            </a:solidFill>
+          </a:ln>
+        </p:spPr>
+        <p:style>
+          <a:lnRef idx="1">
+            <a:schemeClr val="accent1"/>
+          </a:lnRef>
+          <a:fillRef idx="3">
+            <a:schemeClr val="accent1"/>
+          </a:fillRef>
+          <a:effectRef idx="2">
+            <a:schemeClr val="accent1"/>
+          </a:effectRef>
+          <a:fontRef idx="minor">
+            <a:schemeClr val="lt1"/>
+          </a:fontRef>
+        </p:style>
+        <p:txBody>
+          <a:bodyPr rtlCol="0" anchor="ctr"/>
+          <a:lstStyle/>
+          <a:p>
+            <a:pPr algn="ctr">
+              <a:defRPr sz="1000"/>
+            </a:pPr>
+            <a:r>
+              <a:t>PPE granulate</a:t>
+            </a:r>
+          </a:p>
+        </p:txBody>
+      </p:sp>
+      <p:sp>
+        <p:nvSpPr>
+          <p:cNvPr id="18" name="Rectangle 17"/>
+          <p:cNvSpPr/>
+          <p:nvPr/>
+        </p:nvSpPr>
+        <p:spPr>
+          <a:xfrm>
+            <a:off x="1618488" y="5221224"/>
+            <a:ext cx="320040" cy="91440"/>
+          </a:xfrm>
+          <a:prstGeom prst="rect">
+            <a:avLst/>
+          </a:prstGeom>
+          <a:solidFill>
+            <a:srgbClr val="C2833A"/>
+          </a:solidFill>
+          <a:ln>
+            <a:noFill/>
+          </a:ln>
+        </p:spPr>
+        <p:style>
+          <a:lnRef idx="1">
+            <a:schemeClr val="accent1"/>
+          </a:lnRef>
+          <a:fillRef idx="3">
+            <a:schemeClr val="accent1"/>
+          </a:fillRef>
+          <a:effectRef idx="2">
+            <a:schemeClr val="accent1"/>
+          </a:effectRef>
+          <a:fontRef idx="minor">
+            <a:schemeClr val="lt1"/>
+          </a:fontRef>
+        </p:style>
+        <p:txBody>
+          <a:bodyPr rtlCol="0" anchor="ctr"/>
+          <a:lstStyle/>
+          <a:p>
+            <a:pPr algn="ctr"/>
+          </a:p>
+        </p:txBody>
+      </p:sp>
+      <p:sp>
+        <p:nvSpPr>
+          <p:cNvPr id="19" name="Rounded Rectangle 18"/>
+          <p:cNvSpPr/>
+          <p:nvPr/>
+        </p:nvSpPr>
+        <p:spPr>
+          <a:xfrm>
+            <a:off x="1965960" y="5029200"/>
+            <a:ext cx="960120" cy="502920"/>
+          </a:xfrm>
+          <a:prstGeom prst="roundRect">
+            <a:avLst/>
+          </a:prstGeom>
+          <a:solidFill>
+            <a:srgbClr val="FFECD6"/>
+          </a:solidFill>
+          <a:ln>
+            <a:solidFill>
+              <a:srgbClr val="C2833A"/>
+            </a:solidFill>
+          </a:ln>
+        </p:spPr>
+        <p:style>
+          <a:lnRef idx="1">
+            <a:schemeClr val="accent1"/>
+          </a:lnRef>
+          <a:fillRef idx="3">
+            <a:schemeClr val="accent1"/>
+          </a:fillRef>
+          <a:effectRef idx="2">
+            <a:schemeClr val="accent1"/>
+          </a:effectRef>
+          <a:fontRef idx="minor">
+            <a:schemeClr val="lt1"/>
+          </a:fontRef>
+        </p:style>
+        <p:txBody>
+          <a:bodyPr rtlCol="0" anchor="ctr"/>
+          <a:lstStyle/>
+          <a:p>
+            <a:pPr algn="ctr">
+              <a:defRPr sz="1000"/>
+            </a:pPr>
+            <a:r>
+              <a:t>Injection moulding</a:t>
+            </a:r>
+          </a:p>
+        </p:txBody>
+      </p:sp>
+      <p:sp>
+        <p:nvSpPr>
+          <p:cNvPr id="20" name="Rectangle 19"/>
+          <p:cNvSpPr/>
+          <p:nvPr/>
+        </p:nvSpPr>
+        <p:spPr>
+          <a:xfrm>
+            <a:off x="2944368" y="5221224"/>
+            <a:ext cx="320040" cy="91440"/>
+          </a:xfrm>
+          <a:prstGeom prst="rect">
+            <a:avLst/>
+          </a:prstGeom>
+          <a:solidFill>
+            <a:srgbClr val="C2833A"/>
+          </a:solidFill>
+          <a:ln>
+            <a:noFill/>
+          </a:ln>
+        </p:spPr>
+        <p:style>
+          <a:lnRef idx="1">
+            <a:schemeClr val="accent1"/>
+          </a:lnRef>
+          <a:fillRef idx="3">
+            <a:schemeClr val="accent1"/>
+          </a:fillRef>
+          <a:effectRef idx="2">
+            <a:schemeClr val="accent1"/>
+          </a:effectRef>
+          <a:fontRef idx="minor">
+            <a:schemeClr val="lt1"/>
+          </a:fontRef>
+        </p:style>
+        <p:txBody>
+          <a:bodyPr rtlCol="0" anchor="ctr"/>
+          <a:lstStyle/>
+          <a:p>
+            <a:pPr algn="ctr"/>
+          </a:p>
+        </p:txBody>
+      </p:sp>
+      <p:sp>
+        <p:nvSpPr>
+          <p:cNvPr id="21" name="Rounded Rectangle 20"/>
+          <p:cNvSpPr/>
+          <p:nvPr/>
+        </p:nvSpPr>
+        <p:spPr>
+          <a:xfrm>
+            <a:off x="3291839" y="5029200"/>
+            <a:ext cx="960120" cy="502920"/>
+          </a:xfrm>
+          <a:prstGeom prst="roundRect">
+            <a:avLst/>
+          </a:prstGeom>
+          <a:solidFill>
+            <a:srgbClr val="FFECD6"/>
+          </a:solidFill>
+          <a:ln>
+            <a:solidFill>
+              <a:srgbClr val="C2833A"/>
+            </a:solidFill>
+          </a:ln>
+        </p:spPr>
+        <p:style>
+          <a:lnRef idx="1">
+            <a:schemeClr val="accent1"/>
+          </a:lnRef>
+          <a:fillRef idx="3">
+            <a:schemeClr val="accent1"/>
+          </a:fillRef>
+          <a:effectRef idx="2">
+            <a:schemeClr val="accent1"/>
+          </a:effectRef>
+          <a:fontRef idx="minor">
+            <a:schemeClr val="lt1"/>
+          </a:fontRef>
+        </p:style>
+        <p:txBody>
+          <a:bodyPr rtlCol="0" anchor="ctr"/>
+          <a:lstStyle/>
+          <a:p>
+            <a:pPr algn="ctr">
+              <a:defRPr sz="1000"/>
+            </a:pPr>
+            <a:r>
+              <a:t>Cooling</a:t>
+            </a:r>
+          </a:p>
+        </p:txBody>
+      </p:sp>
+      <p:sp>
+        <p:nvSpPr>
+          <p:cNvPr id="22" name="Rectangle 21"/>
+          <p:cNvSpPr/>
+          <p:nvPr/>
+        </p:nvSpPr>
+        <p:spPr>
+          <a:xfrm>
+            <a:off x="4270248" y="5221224"/>
+            <a:ext cx="320040" cy="91440"/>
+          </a:xfrm>
+          <a:prstGeom prst="rect">
+            <a:avLst/>
+          </a:prstGeom>
+          <a:solidFill>
+            <a:srgbClr val="C2833A"/>
+          </a:solidFill>
+          <a:ln>
+            <a:noFill/>
+          </a:ln>
+        </p:spPr>
+        <p:style>
+          <a:lnRef idx="1">
+            <a:schemeClr val="accent1"/>
+          </a:lnRef>
+          <a:fillRef idx="3">
+            <a:schemeClr val="accent1"/>
+          </a:fillRef>
+          <a:effectRef idx="2">
+            <a:schemeClr val="accent1"/>
+          </a:effectRef>
+          <a:fontRef idx="minor">
+            <a:schemeClr val="lt1"/>
+          </a:fontRef>
+        </p:style>
+        <p:txBody>
+          <a:bodyPr rtlCol="0" anchor="ctr"/>
+          <a:lstStyle/>
+          <a:p>
+            <a:pPr algn="ctr"/>
+          </a:p>
+        </p:txBody>
+      </p:sp>
+      <p:sp>
+        <p:nvSpPr>
+          <p:cNvPr id="23" name="Rounded Rectangle 22"/>
+          <p:cNvSpPr/>
+          <p:nvPr/>
+        </p:nvSpPr>
+        <p:spPr>
+          <a:xfrm>
+            <a:off x="4617720" y="5029200"/>
+            <a:ext cx="960120" cy="502920"/>
+          </a:xfrm>
+          <a:prstGeom prst="roundRect">
+            <a:avLst/>
+          </a:prstGeom>
+          <a:solidFill>
+            <a:srgbClr val="FFECD6"/>
+          </a:solidFill>
+          <a:ln>
+            <a:solidFill>
+              <a:srgbClr val="C2833A"/>
+            </a:solidFill>
+          </a:ln>
+        </p:spPr>
+        <p:style>
+          <a:lnRef idx="1">
+            <a:schemeClr val="accent1"/>
+          </a:lnRef>
+          <a:fillRef idx="3">
+            <a:schemeClr val="accent1"/>
+          </a:fillRef>
+          <a:effectRef idx="2">
+            <a:schemeClr val="accent1"/>
+          </a:effectRef>
+          <a:fontRef idx="minor">
+            <a:schemeClr val="lt1"/>
+          </a:fontRef>
+        </p:style>
+        <p:txBody>
+          <a:bodyPr rtlCol="0" anchor="ctr"/>
+          <a:lstStyle/>
+          <a:p>
+            <a:pPr algn="ctr">
+              <a:defRPr sz="1000"/>
+            </a:pPr>
+            <a:r>
+              <a:t>Ejection</a:t>
+            </a:r>
+          </a:p>
+        </p:txBody>
+      </p:sp>
+      <p:sp>
+        <p:nvSpPr>
+          <p:cNvPr id="24" name="Rectangle 23"/>
+          <p:cNvSpPr/>
+          <p:nvPr/>
+        </p:nvSpPr>
+        <p:spPr>
+          <a:xfrm>
+            <a:off x="5596128" y="5221224"/>
+            <a:ext cx="320040" cy="91440"/>
+          </a:xfrm>
+          <a:prstGeom prst="rect">
+            <a:avLst/>
+          </a:prstGeom>
+          <a:solidFill>
+            <a:srgbClr val="C2833A"/>
+          </a:solidFill>
+          <a:ln>
+            <a:noFill/>
+          </a:ln>
+        </p:spPr>
+        <p:style>
+          <a:lnRef idx="1">
+            <a:schemeClr val="accent1"/>
+          </a:lnRef>
+          <a:fillRef idx="3">
+            <a:schemeClr val="accent1"/>
+          </a:fillRef>
+          <a:effectRef idx="2">
+            <a:schemeClr val="accent1"/>
+          </a:effectRef>
+          <a:fontRef idx="minor">
+            <a:schemeClr val="lt1"/>
+          </a:fontRef>
+        </p:style>
+        <p:txBody>
+          <a:bodyPr rtlCol="0" anchor="ctr"/>
+          <a:lstStyle/>
+          <a:p>
+            <a:pPr algn="ctr"/>
+          </a:p>
+        </p:txBody>
+      </p:sp>
+      <p:sp>
+        <p:nvSpPr>
+          <p:cNvPr id="25" name="Rounded Rectangle 24"/>
+          <p:cNvSpPr/>
+          <p:nvPr/>
+        </p:nvSpPr>
+        <p:spPr>
+          <a:xfrm>
+            <a:off x="5943600" y="5029200"/>
+            <a:ext cx="960120" cy="502920"/>
+          </a:xfrm>
+          <a:prstGeom prst="roundRect">
+            <a:avLst/>
+          </a:prstGeom>
+          <a:solidFill>
+            <a:srgbClr val="FFECD6"/>
+          </a:solidFill>
+          <a:ln>
+            <a:solidFill>
+              <a:srgbClr val="C2833A"/>
+            </a:solidFill>
+          </a:ln>
+        </p:spPr>
+        <p:style>
+          <a:lnRef idx="1">
+            <a:schemeClr val="accent1"/>
+          </a:lnRef>
+          <a:fillRef idx="3">
+            <a:schemeClr val="accent1"/>
+          </a:fillRef>
+          <a:effectRef idx="2">
+            <a:schemeClr val="accent1"/>
+          </a:effectRef>
+          <a:fontRef idx="minor">
+            <a:schemeClr val="lt1"/>
+          </a:fontRef>
+        </p:style>
+        <p:txBody>
+          <a:bodyPr rtlCol="0" anchor="ctr"/>
+          <a:lstStyle/>
+          <a:p>
+            <a:pPr algn="ctr">
+              <a:defRPr sz="1000"/>
+            </a:pPr>
+            <a:r>
+              <a:t>Packaging</a:t>
+            </a:r>
+          </a:p>
+        </p:txBody>
+      </p:sp>
+      <p:sp>
+        <p:nvSpPr>
+          <p:cNvPr id="26" name="TextBox 25"/>
+          <p:cNvSpPr txBox="1"/>
+          <p:nvPr/>
+        </p:nvSpPr>
+        <p:spPr>
+          <a:xfrm>
+            <a:off x="6263640" y="3337560"/>
+            <a:ext cx="5394960" cy="640080"/>
+          </a:xfrm>
+          <a:prstGeom prst="rect">
+            <a:avLst/>
+          </a:prstGeom>
+          <a:noFill/>
+        </p:spPr>
+        <p:txBody>
+          <a:bodyPr wrap="square">
+            <a:spAutoFit/>
+          </a:bodyPr>
+          <a:lstStyle/>
           <a:p>
             <a:pPr>
               <a:spcAft>
-                <a:spcPts val="600"/>
+                <a:spcPts val="400"/>
               </a:spcAft>
-              <a:defRPr sz="1800">
-                <a:solidFill>
-                  <a:srgbClr val="1E1E1E"/>
+              <a:defRPr sz="1200">
+                <a:solidFill>
+                  <a:srgbClr val="232323"/>
                 </a:solidFill>
               </a:defRPr>
             </a:pPr>
             <a:r>
-              <a:t>• Glass: non-reactive and flavor-safe for sauces, jams, and beverages.</a:t>
-            </a:r>
-          </a:p>
-          <a:p>
-            <a:pPr>
-              <a:spcAft>
-                <a:spcPts val="600"/>
-              </a:spcAft>
-              <a:defRPr sz="1800">
-                <a:solidFill>
-                  <a:srgbClr val="1E1E1E"/>
-                </a:solidFill>
-              </a:defRPr>
-            </a:pPr>
-            <a:r>
-              <a:t>• Metal: strong barrier for long shelf-life canned foods.</a:t>
-            </a:r>
-          </a:p>
-          <a:p>
-            <a:pPr>
-              <a:spcAft>
-                <a:spcPts val="600"/>
-              </a:spcAft>
-              <a:defRPr sz="1800">
-                <a:solidFill>
-                  <a:srgbClr val="1E1E1E"/>
-                </a:solidFill>
-              </a:defRPr>
-            </a:pPr>
-            <a:r>
-              <a:t>• Paper/Cardboard: biodegradable options for bakery and fast-food packaging.</a:t>
+              <a:t>• Machine Selection: PLA → Thermoforming machine | PPE → Injection moulding machine</a:t>
             </a:r>
           </a:p>
         </p:txBody>
@@ -3690,13 +4596,13 @@
         <p:spPr>
           <a:xfrm>
             <a:off x="0" y="0"/>
-            <a:ext cx="6825813" cy="6858000"/>
+            <a:ext cx="12188952" cy="6858000"/>
           </a:xfrm>
           <a:prstGeom prst="rect">
             <a:avLst/>
           </a:prstGeom>
           <a:solidFill>
-            <a:srgbClr val="1C2734"/>
+            <a:srgbClr val="FAFAFC"/>
           </a:solidFill>
           <a:ln>
             <a:noFill/>
@@ -3726,23 +4632,60 @@
       </p:sp>
       <p:sp>
         <p:nvSpPr>
-          <p:cNvPr id="3" name="Rectangle 2"/>
+          <p:cNvPr id="3" name="TextBox 2"/>
+          <p:cNvSpPr txBox="1"/>
+          <p:nvPr/>
+        </p:nvSpPr>
+        <p:spPr>
+          <a:xfrm>
+            <a:off x="502920" y="228600"/>
+            <a:ext cx="10972800" cy="640080"/>
+          </a:xfrm>
+          <a:prstGeom prst="rect">
+            <a:avLst/>
+          </a:prstGeom>
+          <a:noFill/>
+        </p:spPr>
+        <p:txBody>
+          <a:bodyPr wrap="none">
+            <a:spAutoFit/>
+          </a:bodyPr>
+          <a:lstStyle/>
+          <a:p>
+            <a:pPr>
+              <a:defRPr b="1" sz="3000">
+                <a:solidFill>
+                  <a:srgbClr val="531E6B"/>
+                </a:solidFill>
+              </a:defRPr>
+            </a:pPr>
+            <a:r>
+              <a:t>Core Results: LCC and LCA (per 1,000 containers)</a:t>
+            </a:r>
+          </a:p>
+        </p:txBody>
+      </p:sp>
+      <p:sp>
+        <p:nvSpPr>
+          <p:cNvPr id="4" name="Rounded Rectangle 3"/>
           <p:cNvSpPr/>
           <p:nvPr/>
         </p:nvSpPr>
         <p:spPr>
           <a:xfrm>
-            <a:off x="6825813" y="0"/>
-            <a:ext cx="5363138" cy="6858000"/>
-          </a:xfrm>
-          <a:prstGeom prst="rect">
+            <a:off x="548640" y="914400"/>
+            <a:ext cx="5577840" cy="2468880"/>
+          </a:xfrm>
+          <a:prstGeom prst="roundRect">
             <a:avLst/>
           </a:prstGeom>
           <a:solidFill>
-            <a:srgbClr val="ECF0F4"/>
+            <a:srgbClr val="FFFFFF"/>
           </a:solidFill>
           <a:ln>
-            <a:noFill/>
+            <a:solidFill>
+              <a:srgbClr val="D9C7E4"/>
+            </a:solidFill>
           </a:ln>
         </p:spPr>
         <p:style>
@@ -3769,47 +4712,14 @@
       </p:sp>
       <p:sp>
         <p:nvSpPr>
-          <p:cNvPr id="4" name="TextBox 3"/>
-          <p:cNvSpPr txBox="1"/>
-          <p:nvPr/>
-        </p:nvSpPr>
-        <p:spPr>
-          <a:xfrm>
-            <a:off x="548640" y="320040"/>
-            <a:ext cx="5943600" cy="640080"/>
-          </a:xfrm>
-          <a:prstGeom prst="rect">
-            <a:avLst/>
-          </a:prstGeom>
-          <a:noFill/>
-        </p:spPr>
-        <p:txBody>
-          <a:bodyPr wrap="none">
-            <a:spAutoFit/>
-          </a:bodyPr>
-          <a:lstStyle/>
-          <a:p>
-            <a:r>
-              <a:rPr b="1" sz="3400">
-                <a:solidFill>
-                  <a:srgbClr val="FFFFFF"/>
-                </a:solidFill>
-              </a:rPr>
-              <a:t>Advantages and Disadvantages</a:t>
-            </a:r>
-          </a:p>
-        </p:txBody>
-      </p:sp>
-      <p:sp>
-        <p:nvSpPr>
           <p:cNvPr id="5" name="TextBox 4"/>
           <p:cNvSpPr txBox="1"/>
           <p:nvPr/>
         </p:nvSpPr>
         <p:spPr>
           <a:xfrm>
-            <a:off x="640080" y="1143000"/>
-            <a:ext cx="5943600" cy="5303520"/>
+            <a:off x="777240" y="1143000"/>
+            <a:ext cx="5212080" cy="1463040"/>
           </a:xfrm>
           <a:prstGeom prst="rect">
             <a:avLst/>
@@ -3824,76 +4734,875 @@
           <a:p>
             <a:pPr>
               <a:spcAft>
-                <a:spcPts val="600"/>
+                <a:spcPts val="400"/>
               </a:spcAft>
-              <a:defRPr sz="1800">
-                <a:solidFill>
-                  <a:srgbClr val="EEF5FA"/>
+              <a:defRPr sz="1300">
+                <a:solidFill>
+                  <a:srgbClr val="282828"/>
                 </a:solidFill>
               </a:defRPr>
             </a:pPr>
             <a:r>
-              <a:t>Plastic: + Lightweight, cheap | - Pollution risk</a:t>
+              <a:t>• LCC Total: PLA = €66.3 | PPE = €54.4  → PPE economically superior</a:t>
             </a:r>
           </a:p>
           <a:p>
             <a:pPr>
               <a:spcAft>
-                <a:spcPts val="600"/>
+                <a:spcPts val="400"/>
               </a:spcAft>
-              <a:defRPr sz="1800">
-                <a:solidFill>
-                  <a:srgbClr val="EEF5FA"/>
+              <a:defRPr sz="1300">
+                <a:solidFill>
+                  <a:srgbClr val="282828"/>
                 </a:solidFill>
               </a:defRPr>
             </a:pPr>
             <a:r>
-              <a:t>Glass: + Reusable, non-toxic | - Heavy, fragile</a:t>
+              <a:t>• Material: 39.6 vs 22.4 | Energy: 6.5 vs 8.2</a:t>
             </a:r>
           </a:p>
           <a:p>
             <a:pPr>
               <a:spcAft>
-                <a:spcPts val="600"/>
+                <a:spcPts val="400"/>
               </a:spcAft>
-              <a:defRPr sz="1800">
-                <a:solidFill>
-                  <a:srgbClr val="EEF5FA"/>
+              <a:defRPr sz="1300">
+                <a:solidFill>
+                  <a:srgbClr val="282828"/>
                 </a:solidFill>
               </a:defRPr>
             </a:pPr>
             <a:r>
-              <a:t>Metal: + Strong protection, long shelf life | - Cost, corrosion risk</a:t>
-            </a:r>
-          </a:p>
+              <a:t>• Labour: 12 vs 12 | Depreciation: 4 vs 6 | Tooling: 3 vs 5 | Waste: 1.2 vs 0.8</a:t>
+            </a:r>
+          </a:p>
+        </p:txBody>
+      </p:sp>
+      <p:sp>
+        <p:nvSpPr>
+          <p:cNvPr id="6" name="TextBox 5"/>
+          <p:cNvSpPr txBox="1"/>
+          <p:nvPr/>
+        </p:nvSpPr>
+        <p:spPr>
+          <a:xfrm>
+            <a:off x="777240" y="2606040"/>
+            <a:ext cx="2743200" cy="320040"/>
+          </a:xfrm>
+          <a:prstGeom prst="rect">
+            <a:avLst/>
+          </a:prstGeom>
+          <a:noFill/>
+        </p:spPr>
+        <p:txBody>
+          <a:bodyPr wrap="square">
+            <a:spAutoFit/>
+          </a:bodyPr>
+          <a:lstStyle/>
           <a:p>
             <a:pPr>
               <a:spcAft>
-                <a:spcPts val="600"/>
+                <a:spcPts val="400"/>
               </a:spcAft>
-              <a:defRPr sz="1800">
-                <a:solidFill>
-                  <a:srgbClr val="EEF5FA"/>
+              <a:defRPr sz="1200" b="1">
+                <a:solidFill>
+                  <a:srgbClr val="5C217A"/>
                 </a:solidFill>
               </a:defRPr>
             </a:pPr>
             <a:r>
-              <a:t>Paper: + Recyclable, eco-friendly | - Lower moisture resistance</a:t>
-            </a:r>
-          </a:p>
+              <a:t>LCC Total Cost Comparison</a:t>
+            </a:r>
+          </a:p>
+        </p:txBody>
+      </p:sp>
+      <p:sp>
+        <p:nvSpPr>
+          <p:cNvPr id="7" name="TextBox 6"/>
+          <p:cNvSpPr txBox="1"/>
+          <p:nvPr/>
+        </p:nvSpPr>
+        <p:spPr>
+          <a:xfrm>
+            <a:off x="777240" y="3154680"/>
+            <a:ext cx="365760" cy="274320"/>
+          </a:xfrm>
+          <a:prstGeom prst="rect">
+            <a:avLst/>
+          </a:prstGeom>
+          <a:noFill/>
+        </p:spPr>
+        <p:txBody>
+          <a:bodyPr wrap="square">
+            <a:spAutoFit/>
+          </a:bodyPr>
+          <a:lstStyle/>
           <a:p>
             <a:pPr>
               <a:spcAft>
-                <a:spcPts val="600"/>
+                <a:spcPts val="400"/>
               </a:spcAft>
-              <a:defRPr sz="1800">
-                <a:solidFill>
-                  <a:srgbClr val="EEF5FA"/>
+              <a:defRPr sz="1100">
+                <a:solidFill>
+                  <a:srgbClr val="323232"/>
                 </a:solidFill>
               </a:defRPr>
             </a:pPr>
             <a:r>
-              <a:t>Best choice depends on product type, storage time, and sustainability goals.</a:t>
+              <a:t>PLA</a:t>
+            </a:r>
+          </a:p>
+        </p:txBody>
+      </p:sp>
+      <p:sp>
+        <p:nvSpPr>
+          <p:cNvPr id="8" name="Rectangle 7"/>
+          <p:cNvSpPr/>
+          <p:nvPr/>
+        </p:nvSpPr>
+        <p:spPr>
+          <a:xfrm>
+            <a:off x="1188720" y="3154680"/>
+            <a:ext cx="2121865" cy="320040"/>
+          </a:xfrm>
+          <a:prstGeom prst="rect">
+            <a:avLst/>
+          </a:prstGeom>
+          <a:solidFill>
+            <a:srgbClr val="8A50AB"/>
+          </a:solidFill>
+          <a:ln>
+            <a:noFill/>
+          </a:ln>
+        </p:spPr>
+        <p:style>
+          <a:lnRef idx="1">
+            <a:schemeClr val="accent1"/>
+          </a:lnRef>
+          <a:fillRef idx="3">
+            <a:schemeClr val="accent1"/>
+          </a:fillRef>
+          <a:effectRef idx="2">
+            <a:schemeClr val="accent1"/>
+          </a:effectRef>
+          <a:fontRef idx="minor">
+            <a:schemeClr val="lt1"/>
+          </a:fontRef>
+        </p:style>
+        <p:txBody>
+          <a:bodyPr rtlCol="0" anchor="ctr"/>
+          <a:lstStyle/>
+          <a:p>
+            <a:pPr algn="ctr"/>
+          </a:p>
+        </p:txBody>
+      </p:sp>
+      <p:sp>
+        <p:nvSpPr>
+          <p:cNvPr id="9" name="TextBox 8"/>
+          <p:cNvSpPr txBox="1"/>
+          <p:nvPr/>
+        </p:nvSpPr>
+        <p:spPr>
+          <a:xfrm>
+            <a:off x="3402025" y="3154680"/>
+            <a:ext cx="548640" cy="274320"/>
+          </a:xfrm>
+          <a:prstGeom prst="rect">
+            <a:avLst/>
+          </a:prstGeom>
+          <a:noFill/>
+        </p:spPr>
+        <p:txBody>
+          <a:bodyPr wrap="square">
+            <a:spAutoFit/>
+          </a:bodyPr>
+          <a:lstStyle/>
+          <a:p>
+            <a:pPr>
+              <a:spcAft>
+                <a:spcPts val="400"/>
+              </a:spcAft>
+              <a:defRPr sz="1100">
+                <a:solidFill>
+                  <a:srgbClr val="2D2D2D"/>
+                </a:solidFill>
+              </a:defRPr>
+            </a:pPr>
+            <a:r>
+              <a:t>66.3</a:t>
+            </a:r>
+          </a:p>
+        </p:txBody>
+      </p:sp>
+      <p:sp>
+        <p:nvSpPr>
+          <p:cNvPr id="10" name="TextBox 9"/>
+          <p:cNvSpPr txBox="1"/>
+          <p:nvPr/>
+        </p:nvSpPr>
+        <p:spPr>
+          <a:xfrm>
+            <a:off x="777240" y="3730752"/>
+            <a:ext cx="365760" cy="274320"/>
+          </a:xfrm>
+          <a:prstGeom prst="rect">
+            <a:avLst/>
+          </a:prstGeom>
+          <a:noFill/>
+        </p:spPr>
+        <p:txBody>
+          <a:bodyPr wrap="square">
+            <a:spAutoFit/>
+          </a:bodyPr>
+          <a:lstStyle/>
+          <a:p>
+            <a:pPr>
+              <a:spcAft>
+                <a:spcPts val="400"/>
+              </a:spcAft>
+              <a:defRPr sz="1100">
+                <a:solidFill>
+                  <a:srgbClr val="323232"/>
+                </a:solidFill>
+              </a:defRPr>
+            </a:pPr>
+            <a:r>
+              <a:t>PPE</a:t>
+            </a:r>
+          </a:p>
+        </p:txBody>
+      </p:sp>
+      <p:sp>
+        <p:nvSpPr>
+          <p:cNvPr id="11" name="Rectangle 10"/>
+          <p:cNvSpPr/>
+          <p:nvPr/>
+        </p:nvSpPr>
+        <p:spPr>
+          <a:xfrm>
+            <a:off x="1188720" y="3730752"/>
+            <a:ext cx="1741017" cy="320040"/>
+          </a:xfrm>
+          <a:prstGeom prst="rect">
+            <a:avLst/>
+          </a:prstGeom>
+          <a:solidFill>
+            <a:srgbClr val="628FDB"/>
+          </a:solidFill>
+          <a:ln>
+            <a:noFill/>
+          </a:ln>
+        </p:spPr>
+        <p:style>
+          <a:lnRef idx="1">
+            <a:schemeClr val="accent1"/>
+          </a:lnRef>
+          <a:fillRef idx="3">
+            <a:schemeClr val="accent1"/>
+          </a:fillRef>
+          <a:effectRef idx="2">
+            <a:schemeClr val="accent1"/>
+          </a:effectRef>
+          <a:fontRef idx="minor">
+            <a:schemeClr val="lt1"/>
+          </a:fontRef>
+        </p:style>
+        <p:txBody>
+          <a:bodyPr rtlCol="0" anchor="ctr"/>
+          <a:lstStyle/>
+          <a:p>
+            <a:pPr algn="ctr"/>
+          </a:p>
+        </p:txBody>
+      </p:sp>
+      <p:sp>
+        <p:nvSpPr>
+          <p:cNvPr id="12" name="TextBox 11"/>
+          <p:cNvSpPr txBox="1"/>
+          <p:nvPr/>
+        </p:nvSpPr>
+        <p:spPr>
+          <a:xfrm>
+            <a:off x="3021177" y="3730752"/>
+            <a:ext cx="548640" cy="274320"/>
+          </a:xfrm>
+          <a:prstGeom prst="rect">
+            <a:avLst/>
+          </a:prstGeom>
+          <a:noFill/>
+        </p:spPr>
+        <p:txBody>
+          <a:bodyPr wrap="square">
+            <a:spAutoFit/>
+          </a:bodyPr>
+          <a:lstStyle/>
+          <a:p>
+            <a:pPr>
+              <a:spcAft>
+                <a:spcPts val="400"/>
+              </a:spcAft>
+              <a:defRPr sz="1100">
+                <a:solidFill>
+                  <a:srgbClr val="2D2D2D"/>
+                </a:solidFill>
+              </a:defRPr>
+            </a:pPr>
+            <a:r>
+              <a:t>54.4</a:t>
+            </a:r>
+          </a:p>
+        </p:txBody>
+      </p:sp>
+      <p:sp>
+        <p:nvSpPr>
+          <p:cNvPr id="13" name="Rounded Rectangle 12"/>
+          <p:cNvSpPr/>
+          <p:nvPr/>
+        </p:nvSpPr>
+        <p:spPr>
+          <a:xfrm>
+            <a:off x="6355080" y="914400"/>
+            <a:ext cx="5303520" cy="5394960"/>
+          </a:xfrm>
+          <a:prstGeom prst="roundRect">
+            <a:avLst/>
+          </a:prstGeom>
+          <a:solidFill>
+            <a:srgbClr val="FFFFFF"/>
+          </a:solidFill>
+          <a:ln>
+            <a:solidFill>
+              <a:srgbClr val="BADCC8"/>
+            </a:solidFill>
+          </a:ln>
+        </p:spPr>
+        <p:style>
+          <a:lnRef idx="1">
+            <a:schemeClr val="accent1"/>
+          </a:lnRef>
+          <a:fillRef idx="3">
+            <a:schemeClr val="accent1"/>
+          </a:fillRef>
+          <a:effectRef idx="2">
+            <a:schemeClr val="accent1"/>
+          </a:effectRef>
+          <a:fontRef idx="minor">
+            <a:schemeClr val="lt1"/>
+          </a:fontRef>
+        </p:style>
+        <p:txBody>
+          <a:bodyPr rtlCol="0" anchor="ctr"/>
+          <a:lstStyle/>
+          <a:p>
+            <a:pPr algn="ctr"/>
+          </a:p>
+        </p:txBody>
+      </p:sp>
+      <p:sp>
+        <p:nvSpPr>
+          <p:cNvPr id="14" name="TextBox 13"/>
+          <p:cNvSpPr txBox="1"/>
+          <p:nvPr/>
+        </p:nvSpPr>
+        <p:spPr>
+          <a:xfrm>
+            <a:off x="6583680" y="1143000"/>
+            <a:ext cx="4754880" cy="1737360"/>
+          </a:xfrm>
+          <a:prstGeom prst="rect">
+            <a:avLst/>
+          </a:prstGeom>
+          <a:noFill/>
+        </p:spPr>
+        <p:txBody>
+          <a:bodyPr wrap="square">
+            <a:spAutoFit/>
+          </a:bodyPr>
+          <a:lstStyle/>
+          <a:p>
+            <a:pPr>
+              <a:spcAft>
+                <a:spcPts val="400"/>
+              </a:spcAft>
+              <a:defRPr sz="1200">
+                <a:solidFill>
+                  <a:srgbClr val="232323"/>
+                </a:solidFill>
+              </a:defRPr>
+            </a:pPr>
+            <a:r>
+              <a:t>• LCA Highlights</a:t>
+            </a:r>
+          </a:p>
+          <a:p>
+            <a:pPr>
+              <a:spcAft>
+                <a:spcPts val="400"/>
+              </a:spcAft>
+              <a:defRPr sz="1200">
+                <a:solidFill>
+                  <a:srgbClr val="232323"/>
+                </a:solidFill>
+              </a:defRPr>
+            </a:pPr>
+            <a:r>
+              <a:t>• GWP (kg CO₂-eq): PLA 28 vs PPE 34 (PLA better)</a:t>
+            </a:r>
+          </a:p>
+          <a:p>
+            <a:pPr>
+              <a:spcAft>
+                <a:spcPts val="400"/>
+              </a:spcAft>
+              <a:defRPr sz="1200">
+                <a:solidFill>
+                  <a:srgbClr val="232323"/>
+                </a:solidFill>
+              </a:defRPr>
+            </a:pPr>
+            <a:r>
+              <a:t>• Energy Demand (MJ): PLA 420 vs PPE 510 (PLA better)</a:t>
+            </a:r>
+          </a:p>
+          <a:p>
+            <a:pPr>
+              <a:spcAft>
+                <a:spcPts val="400"/>
+              </a:spcAft>
+              <a:defRPr sz="1200">
+                <a:solidFill>
+                  <a:srgbClr val="232323"/>
+                </a:solidFill>
+              </a:defRPr>
+            </a:pPr>
+            <a:r>
+              <a:t>• Water Use (L): PLA 180 vs PPE 60 (PPE better)</a:t>
+            </a:r>
+          </a:p>
+          <a:p>
+            <a:pPr>
+              <a:spcAft>
+                <a:spcPts val="400"/>
+              </a:spcAft>
+              <a:defRPr sz="1200">
+                <a:solidFill>
+                  <a:srgbClr val="232323"/>
+                </a:solidFill>
+              </a:defRPr>
+            </a:pPr>
+            <a:r>
+              <a:t>• End-of-life performance depends on composting availability for PLA.</a:t>
+            </a:r>
+          </a:p>
+        </p:txBody>
+      </p:sp>
+      <p:sp>
+        <p:nvSpPr>
+          <p:cNvPr id="15" name="TextBox 14"/>
+          <p:cNvSpPr txBox="1"/>
+          <p:nvPr/>
+        </p:nvSpPr>
+        <p:spPr>
+          <a:xfrm>
+            <a:off x="6583680" y="3063240"/>
+            <a:ext cx="731520" cy="228600"/>
+          </a:xfrm>
+          <a:prstGeom prst="rect">
+            <a:avLst/>
+          </a:prstGeom>
+          <a:noFill/>
+        </p:spPr>
+        <p:txBody>
+          <a:bodyPr wrap="square">
+            <a:spAutoFit/>
+          </a:bodyPr>
+          <a:lstStyle/>
+          <a:p>
+            <a:pPr>
+              <a:spcAft>
+                <a:spcPts val="400"/>
+              </a:spcAft>
+              <a:defRPr sz="1100">
+                <a:solidFill>
+                  <a:srgbClr val="323232"/>
+                </a:solidFill>
+              </a:defRPr>
+            </a:pPr>
+            <a:r>
+              <a:t>GWP</a:t>
+            </a:r>
+          </a:p>
+        </p:txBody>
+      </p:sp>
+      <p:sp>
+        <p:nvSpPr>
+          <p:cNvPr id="16" name="Rectangle 15"/>
+          <p:cNvSpPr/>
+          <p:nvPr/>
+        </p:nvSpPr>
+        <p:spPr>
+          <a:xfrm>
+            <a:off x="7406640" y="3063240"/>
+            <a:ext cx="1882588" cy="228600"/>
+          </a:xfrm>
+          <a:prstGeom prst="rect">
+            <a:avLst/>
+          </a:prstGeom>
+          <a:solidFill>
+            <a:srgbClr val="50B185"/>
+          </a:solidFill>
+          <a:ln>
+            <a:noFill/>
+          </a:ln>
+        </p:spPr>
+        <p:style>
+          <a:lnRef idx="1">
+            <a:schemeClr val="accent1"/>
+          </a:lnRef>
+          <a:fillRef idx="3">
+            <a:schemeClr val="accent1"/>
+          </a:fillRef>
+          <a:effectRef idx="2">
+            <a:schemeClr val="accent1"/>
+          </a:effectRef>
+          <a:fontRef idx="minor">
+            <a:schemeClr val="lt1"/>
+          </a:fontRef>
+        </p:style>
+        <p:txBody>
+          <a:bodyPr rtlCol="0" anchor="ctr"/>
+          <a:lstStyle/>
+          <a:p>
+            <a:pPr algn="ctr"/>
+          </a:p>
+        </p:txBody>
+      </p:sp>
+      <p:sp>
+        <p:nvSpPr>
+          <p:cNvPr id="17" name="Rectangle 16"/>
+          <p:cNvSpPr/>
+          <p:nvPr/>
+        </p:nvSpPr>
+        <p:spPr>
+          <a:xfrm>
+            <a:off x="7406640" y="3355848"/>
+            <a:ext cx="2286000" cy="228600"/>
+          </a:xfrm>
+          <a:prstGeom prst="rect">
+            <a:avLst/>
+          </a:prstGeom>
+          <a:solidFill>
+            <a:srgbClr val="EC9061"/>
+          </a:solidFill>
+          <a:ln>
+            <a:noFill/>
+          </a:ln>
+        </p:spPr>
+        <p:style>
+          <a:lnRef idx="1">
+            <a:schemeClr val="accent1"/>
+          </a:lnRef>
+          <a:fillRef idx="3">
+            <a:schemeClr val="accent1"/>
+          </a:fillRef>
+          <a:effectRef idx="2">
+            <a:schemeClr val="accent1"/>
+          </a:effectRef>
+          <a:fontRef idx="minor">
+            <a:schemeClr val="lt1"/>
+          </a:fontRef>
+        </p:style>
+        <p:txBody>
+          <a:bodyPr rtlCol="0" anchor="ctr"/>
+          <a:lstStyle/>
+          <a:p>
+            <a:pPr algn="ctr"/>
+          </a:p>
+        </p:txBody>
+      </p:sp>
+      <p:sp>
+        <p:nvSpPr>
+          <p:cNvPr id="18" name="TextBox 17"/>
+          <p:cNvSpPr txBox="1"/>
+          <p:nvPr/>
+        </p:nvSpPr>
+        <p:spPr>
+          <a:xfrm>
+            <a:off x="6583680" y="3977639"/>
+            <a:ext cx="731520" cy="228600"/>
+          </a:xfrm>
+          <a:prstGeom prst="rect">
+            <a:avLst/>
+          </a:prstGeom>
+          <a:noFill/>
+        </p:spPr>
+        <p:txBody>
+          <a:bodyPr wrap="square">
+            <a:spAutoFit/>
+          </a:bodyPr>
+          <a:lstStyle/>
+          <a:p>
+            <a:pPr>
+              <a:spcAft>
+                <a:spcPts val="400"/>
+              </a:spcAft>
+              <a:defRPr sz="1100">
+                <a:solidFill>
+                  <a:srgbClr val="323232"/>
+                </a:solidFill>
+              </a:defRPr>
+            </a:pPr>
+            <a:r>
+              <a:t>Energy</a:t>
+            </a:r>
+          </a:p>
+        </p:txBody>
+      </p:sp>
+      <p:sp>
+        <p:nvSpPr>
+          <p:cNvPr id="19" name="Rectangle 18"/>
+          <p:cNvSpPr/>
+          <p:nvPr/>
+        </p:nvSpPr>
+        <p:spPr>
+          <a:xfrm>
+            <a:off x="7406640" y="3977639"/>
+            <a:ext cx="1882588" cy="228600"/>
+          </a:xfrm>
+          <a:prstGeom prst="rect">
+            <a:avLst/>
+          </a:prstGeom>
+          <a:solidFill>
+            <a:srgbClr val="50B185"/>
+          </a:solidFill>
+          <a:ln>
+            <a:noFill/>
+          </a:ln>
+        </p:spPr>
+        <p:style>
+          <a:lnRef idx="1">
+            <a:schemeClr val="accent1"/>
+          </a:lnRef>
+          <a:fillRef idx="3">
+            <a:schemeClr val="accent1"/>
+          </a:fillRef>
+          <a:effectRef idx="2">
+            <a:schemeClr val="accent1"/>
+          </a:effectRef>
+          <a:fontRef idx="minor">
+            <a:schemeClr val="lt1"/>
+          </a:fontRef>
+        </p:style>
+        <p:txBody>
+          <a:bodyPr rtlCol="0" anchor="ctr"/>
+          <a:lstStyle/>
+          <a:p>
+            <a:pPr algn="ctr"/>
+          </a:p>
+        </p:txBody>
+      </p:sp>
+      <p:sp>
+        <p:nvSpPr>
+          <p:cNvPr id="20" name="Rectangle 19"/>
+          <p:cNvSpPr/>
+          <p:nvPr/>
+        </p:nvSpPr>
+        <p:spPr>
+          <a:xfrm>
+            <a:off x="7406640" y="4270248"/>
+            <a:ext cx="2286000" cy="228600"/>
+          </a:xfrm>
+          <a:prstGeom prst="rect">
+            <a:avLst/>
+          </a:prstGeom>
+          <a:solidFill>
+            <a:srgbClr val="EC9061"/>
+          </a:solidFill>
+          <a:ln>
+            <a:noFill/>
+          </a:ln>
+        </p:spPr>
+        <p:style>
+          <a:lnRef idx="1">
+            <a:schemeClr val="accent1"/>
+          </a:lnRef>
+          <a:fillRef idx="3">
+            <a:schemeClr val="accent1"/>
+          </a:fillRef>
+          <a:effectRef idx="2">
+            <a:schemeClr val="accent1"/>
+          </a:effectRef>
+          <a:fontRef idx="minor">
+            <a:schemeClr val="lt1"/>
+          </a:fontRef>
+        </p:style>
+        <p:txBody>
+          <a:bodyPr rtlCol="0" anchor="ctr"/>
+          <a:lstStyle/>
+          <a:p>
+            <a:pPr algn="ctr"/>
+          </a:p>
+        </p:txBody>
+      </p:sp>
+      <p:sp>
+        <p:nvSpPr>
+          <p:cNvPr id="21" name="TextBox 20"/>
+          <p:cNvSpPr txBox="1"/>
+          <p:nvPr/>
+        </p:nvSpPr>
+        <p:spPr>
+          <a:xfrm>
+            <a:off x="6583680" y="4892040"/>
+            <a:ext cx="731520" cy="228600"/>
+          </a:xfrm>
+          <a:prstGeom prst="rect">
+            <a:avLst/>
+          </a:prstGeom>
+          <a:noFill/>
+        </p:spPr>
+        <p:txBody>
+          <a:bodyPr wrap="square">
+            <a:spAutoFit/>
+          </a:bodyPr>
+          <a:lstStyle/>
+          <a:p>
+            <a:pPr>
+              <a:spcAft>
+                <a:spcPts val="400"/>
+              </a:spcAft>
+              <a:defRPr sz="1100">
+                <a:solidFill>
+                  <a:srgbClr val="323232"/>
+                </a:solidFill>
+              </a:defRPr>
+            </a:pPr>
+            <a:r>
+              <a:t>Water</a:t>
+            </a:r>
+          </a:p>
+        </p:txBody>
+      </p:sp>
+      <p:sp>
+        <p:nvSpPr>
+          <p:cNvPr id="22" name="Rectangle 21"/>
+          <p:cNvSpPr/>
+          <p:nvPr/>
+        </p:nvSpPr>
+        <p:spPr>
+          <a:xfrm>
+            <a:off x="7406640" y="4892040"/>
+            <a:ext cx="2286000" cy="228600"/>
+          </a:xfrm>
+          <a:prstGeom prst="rect">
+            <a:avLst/>
+          </a:prstGeom>
+          <a:solidFill>
+            <a:srgbClr val="50B185"/>
+          </a:solidFill>
+          <a:ln>
+            <a:noFill/>
+          </a:ln>
+        </p:spPr>
+        <p:style>
+          <a:lnRef idx="1">
+            <a:schemeClr val="accent1"/>
+          </a:lnRef>
+          <a:fillRef idx="3">
+            <a:schemeClr val="accent1"/>
+          </a:fillRef>
+          <a:effectRef idx="2">
+            <a:schemeClr val="accent1"/>
+          </a:effectRef>
+          <a:fontRef idx="minor">
+            <a:schemeClr val="lt1"/>
+          </a:fontRef>
+        </p:style>
+        <p:txBody>
+          <a:bodyPr rtlCol="0" anchor="ctr"/>
+          <a:lstStyle/>
+          <a:p>
+            <a:pPr algn="ctr"/>
+          </a:p>
+        </p:txBody>
+      </p:sp>
+      <p:sp>
+        <p:nvSpPr>
+          <p:cNvPr id="23" name="Rectangle 22"/>
+          <p:cNvSpPr/>
+          <p:nvPr/>
+        </p:nvSpPr>
+        <p:spPr>
+          <a:xfrm>
+            <a:off x="7406640" y="5184648"/>
+            <a:ext cx="761999" cy="228600"/>
+          </a:xfrm>
+          <a:prstGeom prst="rect">
+            <a:avLst/>
+          </a:prstGeom>
+          <a:solidFill>
+            <a:srgbClr val="EC9061"/>
+          </a:solidFill>
+          <a:ln>
+            <a:noFill/>
+          </a:ln>
+        </p:spPr>
+        <p:style>
+          <a:lnRef idx="1">
+            <a:schemeClr val="accent1"/>
+          </a:lnRef>
+          <a:fillRef idx="3">
+            <a:schemeClr val="accent1"/>
+          </a:fillRef>
+          <a:effectRef idx="2">
+            <a:schemeClr val="accent1"/>
+          </a:effectRef>
+          <a:fontRef idx="minor">
+            <a:schemeClr val="lt1"/>
+          </a:fontRef>
+        </p:style>
+        <p:txBody>
+          <a:bodyPr rtlCol="0" anchor="ctr"/>
+          <a:lstStyle/>
+          <a:p>
+            <a:pPr algn="ctr"/>
+          </a:p>
+        </p:txBody>
+      </p:sp>
+      <p:sp>
+        <p:nvSpPr>
+          <p:cNvPr id="24" name="TextBox 23"/>
+          <p:cNvSpPr txBox="1"/>
+          <p:nvPr/>
+        </p:nvSpPr>
+        <p:spPr>
+          <a:xfrm>
+            <a:off x="10012680" y="5715000"/>
+            <a:ext cx="1554480" cy="274320"/>
+          </a:xfrm>
+          <a:prstGeom prst="rect">
+            <a:avLst/>
+          </a:prstGeom>
+          <a:noFill/>
+        </p:spPr>
+        <p:txBody>
+          <a:bodyPr wrap="square">
+            <a:spAutoFit/>
+          </a:bodyPr>
+          <a:lstStyle/>
+          <a:p>
+            <a:pPr>
+              <a:spcAft>
+                <a:spcPts val="400"/>
+              </a:spcAft>
+              <a:defRPr sz="1000">
+                <a:solidFill>
+                  <a:srgbClr val="3C3C3C"/>
+                </a:solidFill>
+              </a:defRPr>
+            </a:pPr>
+            <a:r>
+              <a:t>Green=PLA  Orange=PPE</a:t>
             </a:r>
           </a:p>
         </p:txBody>
@@ -3931,7 +5640,7 @@
             <a:avLst/>
           </a:prstGeom>
           <a:solidFill>
-            <a:srgbClr val="072D20"/>
+            <a:srgbClr val="09262D"/>
           </a:solidFill>
           <a:ln>
             <a:noFill/>
@@ -3961,14 +5670,49 @@
       </p:sp>
       <p:sp>
         <p:nvSpPr>
-          <p:cNvPr id="3" name="Rounded Rectangle 2"/>
+          <p:cNvPr id="3" name="TextBox 2"/>
+          <p:cNvSpPr txBox="1"/>
+          <p:nvPr/>
+        </p:nvSpPr>
+        <p:spPr>
+          <a:xfrm>
+            <a:off x="548640" y="274320"/>
+            <a:ext cx="10972800" cy="640080"/>
+          </a:xfrm>
+          <a:prstGeom prst="rect">
+            <a:avLst/>
+          </a:prstGeom>
+          <a:noFill/>
+        </p:spPr>
+        <p:txBody>
+          <a:bodyPr wrap="none">
+            <a:spAutoFit/>
+          </a:bodyPr>
+          <a:lstStyle/>
+          <a:p>
+            <a:pPr>
+              <a:defRPr b="1" sz="3100">
+                <a:solidFill>
+                  <a:srgbClr val="FFFFFF"/>
+                </a:solidFill>
+              </a:defRPr>
+            </a:pPr>
+            <a:r>
+              <a:t>Sensitivity, Positioning, and Final Recommendation</a:t>
+            </a:r>
+          </a:p>
+        </p:txBody>
+      </p:sp>
+      <p:sp>
+        <p:nvSpPr>
+          <p:cNvPr id="4" name="Rounded Rectangle 3"/>
           <p:cNvSpPr/>
           <p:nvPr/>
         </p:nvSpPr>
         <p:spPr>
           <a:xfrm>
-            <a:off x="640080" y="640080"/>
-            <a:ext cx="10881360" cy="5486400"/>
+            <a:off x="640080" y="914400"/>
+            <a:ext cx="5669280" cy="5394960"/>
           </a:xfrm>
           <a:prstGeom prst="roundRect">
             <a:avLst/>
@@ -3976,10 +5720,8 @@
           <a:solidFill>
             <a:srgbClr val="FFFFFF"/>
           </a:solidFill>
-          <a:ln w="31750">
-            <a:solidFill>
-              <a:srgbClr val="47BE84"/>
-            </a:solidFill>
+          <a:ln>
+            <a:noFill/>
           </a:ln>
         </p:spPr>
         <p:style>
@@ -4006,47 +5748,14 @@
       </p:sp>
       <p:sp>
         <p:nvSpPr>
-          <p:cNvPr id="4" name="TextBox 3"/>
-          <p:cNvSpPr txBox="1"/>
-          <p:nvPr/>
-        </p:nvSpPr>
-        <p:spPr>
-          <a:xfrm>
-            <a:off x="914400" y="914400"/>
-            <a:ext cx="9875520" cy="731520"/>
-          </a:xfrm>
-          <a:prstGeom prst="rect">
-            <a:avLst/>
-          </a:prstGeom>
-          <a:noFill/>
-        </p:spPr>
-        <p:txBody>
-          <a:bodyPr wrap="none">
-            <a:spAutoFit/>
-          </a:bodyPr>
-          <a:lstStyle/>
-          <a:p>
-            <a:r>
-              <a:rPr b="1" sz="3400">
-                <a:solidFill>
-                  <a:srgbClr val="0E4B39"/>
-                </a:solidFill>
-              </a:rPr>
-              <a:t>Conclusion &amp; Future of Food Packaging</a:t>
-            </a:r>
-          </a:p>
-        </p:txBody>
-      </p:sp>
-      <p:sp>
-        <p:nvSpPr>
           <p:cNvPr id="5" name="TextBox 4"/>
           <p:cNvSpPr txBox="1"/>
           <p:nvPr/>
         </p:nvSpPr>
         <p:spPr>
           <a:xfrm>
-            <a:off x="1005840" y="1737360"/>
-            <a:ext cx="9784080" cy="3200400"/>
+            <a:off x="914400" y="1188720"/>
+            <a:ext cx="5120640" cy="2377440"/>
           </a:xfrm>
           <a:prstGeom prst="rect">
             <a:avLst/>
@@ -4061,61 +5770,1019 @@
           <a:p>
             <a:pPr>
               <a:spcAft>
-                <a:spcPts val="600"/>
+                <a:spcPts val="400"/>
               </a:spcAft>
-              <a:defRPr sz="2200">
-                <a:solidFill>
-                  <a:srgbClr val="142D26"/>
+              <a:defRPr sz="1300">
+                <a:solidFill>
+                  <a:srgbClr val="232D3A"/>
                 </a:solidFill>
               </a:defRPr>
             </a:pPr>
             <a:r>
-              <a:t>Food containers are essential for safety, quality, and convenience in modern supply chains.</a:t>
+              <a:t>Sensitivity Analysis (Professor Required)</a:t>
             </a:r>
           </a:p>
           <a:p>
             <a:pPr>
               <a:spcAft>
-                <a:spcPts val="600"/>
+                <a:spcPts val="400"/>
               </a:spcAft>
-              <a:defRPr sz="2200">
-                <a:solidFill>
-                  <a:srgbClr val="142D26"/>
+              <a:defRPr sz="1300">
+                <a:solidFill>
+                  <a:srgbClr val="232D3A"/>
                 </a:solidFill>
               </a:defRPr>
             </a:pPr>
             <a:r>
-              <a:t>Future-focused packaging is shifting to biodegradable materials and reusable systems.</a:t>
+              <a:t>• PLA is highly sensitive to feedstock/material price (±20%).</a:t>
             </a:r>
           </a:p>
           <a:p>
             <a:pPr>
               <a:spcAft>
-                <a:spcPts val="600"/>
+                <a:spcPts val="400"/>
               </a:spcAft>
-              <a:defRPr sz="2200">
-                <a:solidFill>
-                  <a:srgbClr val="142D26"/>
+              <a:defRPr sz="1300">
+                <a:solidFill>
+                  <a:srgbClr val="232D3A"/>
                 </a:solidFill>
               </a:defRPr>
             </a:pPr>
             <a:r>
-              <a:t>Reducing plastic waste is now a major global design and policy priority.</a:t>
+              <a:t>• PPE is highly sensitive to energy price (±30%).</a:t>
             </a:r>
           </a:p>
           <a:p>
             <a:pPr>
               <a:spcAft>
-                <a:spcPts val="600"/>
+                <a:spcPts val="400"/>
               </a:spcAft>
-              <a:defRPr sz="2200">
-                <a:solidFill>
-                  <a:srgbClr val="142D26"/>
+              <a:defRPr sz="1300">
+                <a:solidFill>
+                  <a:srgbClr val="232D3A"/>
                 </a:solidFill>
               </a:defRPr>
             </a:pPr>
             <a:r>
-              <a:t>Bonus Tip: Packaging choices directly impact food safety, shelf life, and sustainability.</a:t>
+              <a:t>• Higher scrap rates penalize PLA more strongly.</a:t>
+            </a:r>
+          </a:p>
+          <a:p>
+            <a:pPr>
+              <a:spcAft>
+                <a:spcPts val="400"/>
+              </a:spcAft>
+              <a:defRPr sz="1300">
+                <a:solidFill>
+                  <a:srgbClr val="232D3A"/>
+                </a:solidFill>
+              </a:defRPr>
+            </a:pPr>
+            <a:r>
+              <a:t>• PLA outcome depends on composting infrastructure quality.</a:t>
+            </a:r>
+          </a:p>
+          <a:p>
+            <a:pPr>
+              <a:spcAft>
+                <a:spcPts val="400"/>
+              </a:spcAft>
+              <a:defRPr sz="1300">
+                <a:solidFill>
+                  <a:srgbClr val="232D3A"/>
+                </a:solidFill>
+              </a:defRPr>
+            </a:pPr>
+            <a:r>
+              <a:t>• PPE gains from large-scale production volumes.</a:t>
+            </a:r>
+          </a:p>
+        </p:txBody>
+      </p:sp>
+      <p:sp>
+        <p:nvSpPr>
+          <p:cNvPr id="6" name="TextBox 5"/>
+          <p:cNvSpPr txBox="1"/>
+          <p:nvPr/>
+        </p:nvSpPr>
+        <p:spPr>
+          <a:xfrm>
+            <a:off x="914400" y="3657600"/>
+            <a:ext cx="2560320" cy="320040"/>
+          </a:xfrm>
+          <a:prstGeom prst="rect">
+            <a:avLst/>
+          </a:prstGeom>
+          <a:noFill/>
+        </p:spPr>
+        <p:txBody>
+          <a:bodyPr wrap="square">
+            <a:spAutoFit/>
+          </a:bodyPr>
+          <a:lstStyle/>
+          <a:p>
+            <a:pPr>
+              <a:spcAft>
+                <a:spcPts val="400"/>
+              </a:spcAft>
+              <a:defRPr sz="1100" b="1">
+                <a:solidFill>
+                  <a:srgbClr val="232D3A"/>
+                </a:solidFill>
+              </a:defRPr>
+            </a:pPr>
+            <a:r>
+              <a:t>Sensitivity Tornado (relative impact)</a:t>
+            </a:r>
+          </a:p>
+        </p:txBody>
+      </p:sp>
+      <p:sp>
+        <p:nvSpPr>
+          <p:cNvPr id="7" name="TextBox 6"/>
+          <p:cNvSpPr txBox="1"/>
+          <p:nvPr/>
+        </p:nvSpPr>
+        <p:spPr>
+          <a:xfrm>
+            <a:off x="914400" y="3977639"/>
+            <a:ext cx="1463040" cy="228600"/>
+          </a:xfrm>
+          <a:prstGeom prst="rect">
+            <a:avLst/>
+          </a:prstGeom>
+          <a:noFill/>
+        </p:spPr>
+        <p:txBody>
+          <a:bodyPr wrap="square">
+            <a:spAutoFit/>
+          </a:bodyPr>
+          <a:lstStyle/>
+          <a:p>
+            <a:pPr>
+              <a:spcAft>
+                <a:spcPts val="400"/>
+              </a:spcAft>
+              <a:defRPr sz="1000">
+                <a:solidFill>
+                  <a:srgbClr val="323232"/>
+                </a:solidFill>
+              </a:defRPr>
+            </a:pPr>
+            <a:r>
+              <a:t>Material price</a:t>
+            </a:r>
+          </a:p>
+        </p:txBody>
+      </p:sp>
+      <p:sp>
+        <p:nvSpPr>
+          <p:cNvPr id="8" name="Rectangle 7"/>
+          <p:cNvSpPr/>
+          <p:nvPr/>
+        </p:nvSpPr>
+        <p:spPr>
+          <a:xfrm>
+            <a:off x="2468880" y="3977639"/>
+            <a:ext cx="2432303" cy="201168"/>
+          </a:xfrm>
+          <a:prstGeom prst="rect">
+            <a:avLst/>
+          </a:prstGeom>
+          <a:solidFill>
+            <a:srgbClr val="5A89D6"/>
+          </a:solidFill>
+          <a:ln>
+            <a:noFill/>
+          </a:ln>
+        </p:spPr>
+        <p:style>
+          <a:lnRef idx="1">
+            <a:schemeClr val="accent1"/>
+          </a:lnRef>
+          <a:fillRef idx="3">
+            <a:schemeClr val="accent1"/>
+          </a:fillRef>
+          <a:effectRef idx="2">
+            <a:schemeClr val="accent1"/>
+          </a:effectRef>
+          <a:fontRef idx="minor">
+            <a:schemeClr val="lt1"/>
+          </a:fontRef>
+        </p:style>
+        <p:txBody>
+          <a:bodyPr rtlCol="0" anchor="ctr"/>
+          <a:lstStyle/>
+          <a:p>
+            <a:pPr algn="ctr"/>
+          </a:p>
+        </p:txBody>
+      </p:sp>
+      <p:sp>
+        <p:nvSpPr>
+          <p:cNvPr id="9" name="TextBox 8"/>
+          <p:cNvSpPr txBox="1"/>
+          <p:nvPr/>
+        </p:nvSpPr>
+        <p:spPr>
+          <a:xfrm>
+            <a:off x="914400" y="4389120"/>
+            <a:ext cx="1463040" cy="228600"/>
+          </a:xfrm>
+          <a:prstGeom prst="rect">
+            <a:avLst/>
+          </a:prstGeom>
+          <a:noFill/>
+        </p:spPr>
+        <p:txBody>
+          <a:bodyPr wrap="square">
+            <a:spAutoFit/>
+          </a:bodyPr>
+          <a:lstStyle/>
+          <a:p>
+            <a:pPr>
+              <a:spcAft>
+                <a:spcPts val="400"/>
+              </a:spcAft>
+              <a:defRPr sz="1000">
+                <a:solidFill>
+                  <a:srgbClr val="323232"/>
+                </a:solidFill>
+              </a:defRPr>
+            </a:pPr>
+            <a:r>
+              <a:t>Energy price</a:t>
+            </a:r>
+          </a:p>
+        </p:txBody>
+      </p:sp>
+      <p:sp>
+        <p:nvSpPr>
+          <p:cNvPr id="10" name="Rectangle 9"/>
+          <p:cNvSpPr/>
+          <p:nvPr/>
+        </p:nvSpPr>
+        <p:spPr>
+          <a:xfrm>
+            <a:off x="2468880" y="4389120"/>
+            <a:ext cx="1920239" cy="201168"/>
+          </a:xfrm>
+          <a:prstGeom prst="rect">
+            <a:avLst/>
+          </a:prstGeom>
+          <a:solidFill>
+            <a:srgbClr val="5A89D6"/>
+          </a:solidFill>
+          <a:ln>
+            <a:noFill/>
+          </a:ln>
+        </p:spPr>
+        <p:style>
+          <a:lnRef idx="1">
+            <a:schemeClr val="accent1"/>
+          </a:lnRef>
+          <a:fillRef idx="3">
+            <a:schemeClr val="accent1"/>
+          </a:fillRef>
+          <a:effectRef idx="2">
+            <a:schemeClr val="accent1"/>
+          </a:effectRef>
+          <a:fontRef idx="minor">
+            <a:schemeClr val="lt1"/>
+          </a:fontRef>
+        </p:style>
+        <p:txBody>
+          <a:bodyPr rtlCol="0" anchor="ctr"/>
+          <a:lstStyle/>
+          <a:p>
+            <a:pPr algn="ctr"/>
+          </a:p>
+        </p:txBody>
+      </p:sp>
+      <p:sp>
+        <p:nvSpPr>
+          <p:cNvPr id="11" name="TextBox 10"/>
+          <p:cNvSpPr txBox="1"/>
+          <p:nvPr/>
+        </p:nvSpPr>
+        <p:spPr>
+          <a:xfrm>
+            <a:off x="914400" y="4800600"/>
+            <a:ext cx="1463040" cy="228600"/>
+          </a:xfrm>
+          <a:prstGeom prst="rect">
+            <a:avLst/>
+          </a:prstGeom>
+          <a:noFill/>
+        </p:spPr>
+        <p:txBody>
+          <a:bodyPr wrap="square">
+            <a:spAutoFit/>
+          </a:bodyPr>
+          <a:lstStyle/>
+          <a:p>
+            <a:pPr>
+              <a:spcAft>
+                <a:spcPts val="400"/>
+              </a:spcAft>
+              <a:defRPr sz="1000">
+                <a:solidFill>
+                  <a:srgbClr val="323232"/>
+                </a:solidFill>
+              </a:defRPr>
+            </a:pPr>
+            <a:r>
+              <a:t>End-of-life</a:t>
+            </a:r>
+          </a:p>
+        </p:txBody>
+      </p:sp>
+      <p:sp>
+        <p:nvSpPr>
+          <p:cNvPr id="12" name="Rectangle 11"/>
+          <p:cNvSpPr/>
+          <p:nvPr/>
+        </p:nvSpPr>
+        <p:spPr>
+          <a:xfrm>
+            <a:off x="2468880" y="4800600"/>
+            <a:ext cx="1664207" cy="201168"/>
+          </a:xfrm>
+          <a:prstGeom prst="rect">
+            <a:avLst/>
+          </a:prstGeom>
+          <a:solidFill>
+            <a:srgbClr val="5A89D6"/>
+          </a:solidFill>
+          <a:ln>
+            <a:noFill/>
+          </a:ln>
+        </p:spPr>
+        <p:style>
+          <a:lnRef idx="1">
+            <a:schemeClr val="accent1"/>
+          </a:lnRef>
+          <a:fillRef idx="3">
+            <a:schemeClr val="accent1"/>
+          </a:fillRef>
+          <a:effectRef idx="2">
+            <a:schemeClr val="accent1"/>
+          </a:effectRef>
+          <a:fontRef idx="minor">
+            <a:schemeClr val="lt1"/>
+          </a:fontRef>
+        </p:style>
+        <p:txBody>
+          <a:bodyPr rtlCol="0" anchor="ctr"/>
+          <a:lstStyle/>
+          <a:p>
+            <a:pPr algn="ctr"/>
+          </a:p>
+        </p:txBody>
+      </p:sp>
+      <p:sp>
+        <p:nvSpPr>
+          <p:cNvPr id="13" name="TextBox 12"/>
+          <p:cNvSpPr txBox="1"/>
+          <p:nvPr/>
+        </p:nvSpPr>
+        <p:spPr>
+          <a:xfrm>
+            <a:off x="914400" y="5212080"/>
+            <a:ext cx="1463040" cy="228600"/>
+          </a:xfrm>
+          <a:prstGeom prst="rect">
+            <a:avLst/>
+          </a:prstGeom>
+          <a:noFill/>
+        </p:spPr>
+        <p:txBody>
+          <a:bodyPr wrap="square">
+            <a:spAutoFit/>
+          </a:bodyPr>
+          <a:lstStyle/>
+          <a:p>
+            <a:pPr>
+              <a:spcAft>
+                <a:spcPts val="400"/>
+              </a:spcAft>
+              <a:defRPr sz="1000">
+                <a:solidFill>
+                  <a:srgbClr val="323232"/>
+                </a:solidFill>
+              </a:defRPr>
+            </a:pPr>
+            <a:r>
+              <a:t>Scrap rate</a:t>
+            </a:r>
+          </a:p>
+        </p:txBody>
+      </p:sp>
+      <p:sp>
+        <p:nvSpPr>
+          <p:cNvPr id="14" name="Rectangle 13"/>
+          <p:cNvSpPr/>
+          <p:nvPr/>
+        </p:nvSpPr>
+        <p:spPr>
+          <a:xfrm>
+            <a:off x="2468880" y="5212080"/>
+            <a:ext cx="1408176" cy="201168"/>
+          </a:xfrm>
+          <a:prstGeom prst="rect">
+            <a:avLst/>
+          </a:prstGeom>
+          <a:solidFill>
+            <a:srgbClr val="5A89D6"/>
+          </a:solidFill>
+          <a:ln>
+            <a:noFill/>
+          </a:ln>
+        </p:spPr>
+        <p:style>
+          <a:lnRef idx="1">
+            <a:schemeClr val="accent1"/>
+          </a:lnRef>
+          <a:fillRef idx="3">
+            <a:schemeClr val="accent1"/>
+          </a:fillRef>
+          <a:effectRef idx="2">
+            <a:schemeClr val="accent1"/>
+          </a:effectRef>
+          <a:fontRef idx="minor">
+            <a:schemeClr val="lt1"/>
+          </a:fontRef>
+        </p:style>
+        <p:txBody>
+          <a:bodyPr rtlCol="0" anchor="ctr"/>
+          <a:lstStyle/>
+          <a:p>
+            <a:pPr algn="ctr"/>
+          </a:p>
+        </p:txBody>
+      </p:sp>
+      <p:sp>
+        <p:nvSpPr>
+          <p:cNvPr id="15" name="TextBox 14"/>
+          <p:cNvSpPr txBox="1"/>
+          <p:nvPr/>
+        </p:nvSpPr>
+        <p:spPr>
+          <a:xfrm>
+            <a:off x="914400" y="5623560"/>
+            <a:ext cx="1463040" cy="228600"/>
+          </a:xfrm>
+          <a:prstGeom prst="rect">
+            <a:avLst/>
+          </a:prstGeom>
+          <a:noFill/>
+        </p:spPr>
+        <p:txBody>
+          <a:bodyPr wrap="square">
+            <a:spAutoFit/>
+          </a:bodyPr>
+          <a:lstStyle/>
+          <a:p>
+            <a:pPr>
+              <a:spcAft>
+                <a:spcPts val="400"/>
+              </a:spcAft>
+              <a:defRPr sz="1000">
+                <a:solidFill>
+                  <a:srgbClr val="323232"/>
+                </a:solidFill>
+              </a:defRPr>
+            </a:pPr>
+            <a:r>
+              <a:t>Volume</a:t>
+            </a:r>
+          </a:p>
+        </p:txBody>
+      </p:sp>
+      <p:sp>
+        <p:nvSpPr>
+          <p:cNvPr id="16" name="Rectangle 15"/>
+          <p:cNvSpPr/>
+          <p:nvPr/>
+        </p:nvSpPr>
+        <p:spPr>
+          <a:xfrm>
+            <a:off x="2468880" y="5623560"/>
+            <a:ext cx="1280160" cy="201168"/>
+          </a:xfrm>
+          <a:prstGeom prst="rect">
+            <a:avLst/>
+          </a:prstGeom>
+          <a:solidFill>
+            <a:srgbClr val="5A89D6"/>
+          </a:solidFill>
+          <a:ln>
+            <a:noFill/>
+          </a:ln>
+        </p:spPr>
+        <p:style>
+          <a:lnRef idx="1">
+            <a:schemeClr val="accent1"/>
+          </a:lnRef>
+          <a:fillRef idx="3">
+            <a:schemeClr val="accent1"/>
+          </a:fillRef>
+          <a:effectRef idx="2">
+            <a:schemeClr val="accent1"/>
+          </a:effectRef>
+          <a:fontRef idx="minor">
+            <a:schemeClr val="lt1"/>
+          </a:fontRef>
+        </p:style>
+        <p:txBody>
+          <a:bodyPr rtlCol="0" anchor="ctr"/>
+          <a:lstStyle/>
+          <a:p>
+            <a:pPr algn="ctr"/>
+          </a:p>
+        </p:txBody>
+      </p:sp>
+      <p:sp>
+        <p:nvSpPr>
+          <p:cNvPr id="17" name="Rounded Rectangle 16"/>
+          <p:cNvSpPr/>
+          <p:nvPr/>
+        </p:nvSpPr>
+        <p:spPr>
+          <a:xfrm>
+            <a:off x="6583680" y="914400"/>
+            <a:ext cx="4937760" cy="5394960"/>
+          </a:xfrm>
+          <a:prstGeom prst="roundRect">
+            <a:avLst/>
+          </a:prstGeom>
+          <a:solidFill>
+            <a:srgbClr val="FFFFFF"/>
+          </a:solidFill>
+          <a:ln>
+            <a:noFill/>
+          </a:ln>
+        </p:spPr>
+        <p:style>
+          <a:lnRef idx="1">
+            <a:schemeClr val="accent1"/>
+          </a:lnRef>
+          <a:fillRef idx="3">
+            <a:schemeClr val="accent1"/>
+          </a:fillRef>
+          <a:effectRef idx="2">
+            <a:schemeClr val="accent1"/>
+          </a:effectRef>
+          <a:fontRef idx="minor">
+            <a:schemeClr val="lt1"/>
+          </a:fontRef>
+        </p:style>
+        <p:txBody>
+          <a:bodyPr rtlCol="0" anchor="ctr"/>
+          <a:lstStyle/>
+          <a:p>
+            <a:pPr algn="ctr"/>
+          </a:p>
+        </p:txBody>
+      </p:sp>
+      <p:sp>
+        <p:nvSpPr>
+          <p:cNvPr id="18" name="TextBox 17"/>
+          <p:cNvSpPr txBox="1"/>
+          <p:nvPr/>
+        </p:nvSpPr>
+        <p:spPr>
+          <a:xfrm>
+            <a:off x="6812280" y="1143000"/>
+            <a:ext cx="4480560" cy="411480"/>
+          </a:xfrm>
+          <a:prstGeom prst="rect">
+            <a:avLst/>
+          </a:prstGeom>
+          <a:noFill/>
+        </p:spPr>
+        <p:txBody>
+          <a:bodyPr wrap="square">
+            <a:spAutoFit/>
+          </a:bodyPr>
+          <a:lstStyle/>
+          <a:p>
+            <a:pPr>
+              <a:spcAft>
+                <a:spcPts val="400"/>
+              </a:spcAft>
+              <a:defRPr sz="1200" b="1">
+                <a:solidFill>
+                  <a:srgbClr val="2C2C2C"/>
+                </a:solidFill>
+              </a:defRPr>
+            </a:pPr>
+            <a:r>
+              <a:t>Alternatives Mapping (Cost–Environment–Technical)</a:t>
+            </a:r>
+          </a:p>
+        </p:txBody>
+      </p:sp>
+      <p:sp>
+        <p:nvSpPr>
+          <p:cNvPr id="19" name="Isosceles Triangle 18"/>
+          <p:cNvSpPr/>
+          <p:nvPr/>
+        </p:nvSpPr>
+        <p:spPr>
+          <a:xfrm>
+            <a:off x="7040880" y="1691640"/>
+            <a:ext cx="3566160" cy="2651760"/>
+          </a:xfrm>
+          <a:prstGeom prst="triangle">
+            <a:avLst/>
+          </a:prstGeom>
+          <a:solidFill>
+            <a:srgbClr val="ECF6EF"/>
+          </a:solidFill>
+          <a:ln>
+            <a:solidFill>
+              <a:srgbClr val="5E8E70"/>
+            </a:solidFill>
+          </a:ln>
+        </p:spPr>
+        <p:style>
+          <a:lnRef idx="1">
+            <a:schemeClr val="accent1"/>
+          </a:lnRef>
+          <a:fillRef idx="3">
+            <a:schemeClr val="accent1"/>
+          </a:fillRef>
+          <a:effectRef idx="2">
+            <a:schemeClr val="accent1"/>
+          </a:effectRef>
+          <a:fontRef idx="minor">
+            <a:schemeClr val="lt1"/>
+          </a:fontRef>
+        </p:style>
+        <p:txBody>
+          <a:bodyPr rtlCol="0" anchor="ctr"/>
+          <a:lstStyle/>
+          <a:p>
+            <a:pPr algn="ctr"/>
+          </a:p>
+        </p:txBody>
+      </p:sp>
+      <p:sp>
+        <p:nvSpPr>
+          <p:cNvPr id="20" name="TextBox 19"/>
+          <p:cNvSpPr txBox="1"/>
+          <p:nvPr/>
+        </p:nvSpPr>
+        <p:spPr>
+          <a:xfrm>
+            <a:off x="8183879" y="1664208"/>
+            <a:ext cx="914400" cy="228600"/>
+          </a:xfrm>
+          <a:prstGeom prst="rect">
+            <a:avLst/>
+          </a:prstGeom>
+          <a:noFill/>
+        </p:spPr>
+        <p:txBody>
+          <a:bodyPr wrap="square">
+            <a:spAutoFit/>
+          </a:bodyPr>
+          <a:lstStyle/>
+          <a:p>
+            <a:pPr>
+              <a:spcAft>
+                <a:spcPts val="400"/>
+              </a:spcAft>
+              <a:defRPr sz="1000">
+                <a:solidFill>
+                  <a:srgbClr val="2D5A3B"/>
+                </a:solidFill>
+              </a:defRPr>
+            </a:pPr>
+            <a:r>
+              <a:t>Environment</a:t>
+            </a:r>
+          </a:p>
+        </p:txBody>
+      </p:sp>
+      <p:sp>
+        <p:nvSpPr>
+          <p:cNvPr id="21" name="TextBox 20"/>
+          <p:cNvSpPr txBox="1"/>
+          <p:nvPr/>
+        </p:nvSpPr>
+        <p:spPr>
+          <a:xfrm>
+            <a:off x="6812280" y="4160520"/>
+            <a:ext cx="731520" cy="228600"/>
+          </a:xfrm>
+          <a:prstGeom prst="rect">
+            <a:avLst/>
+          </a:prstGeom>
+          <a:noFill/>
+        </p:spPr>
+        <p:txBody>
+          <a:bodyPr wrap="square">
+            <a:spAutoFit/>
+          </a:bodyPr>
+          <a:lstStyle/>
+          <a:p>
+            <a:pPr>
+              <a:spcAft>
+                <a:spcPts val="400"/>
+              </a:spcAft>
+              <a:defRPr sz="1000">
+                <a:solidFill>
+                  <a:srgbClr val="2D5A3B"/>
+                </a:solidFill>
+              </a:defRPr>
+            </a:pPr>
+            <a:r>
+              <a:t>Cost</a:t>
+            </a:r>
+          </a:p>
+        </p:txBody>
+      </p:sp>
+      <p:sp>
+        <p:nvSpPr>
+          <p:cNvPr id="22" name="TextBox 21"/>
+          <p:cNvSpPr txBox="1"/>
+          <p:nvPr/>
+        </p:nvSpPr>
+        <p:spPr>
+          <a:xfrm>
+            <a:off x="10012680" y="4160520"/>
+            <a:ext cx="914400" cy="228600"/>
+          </a:xfrm>
+          <a:prstGeom prst="rect">
+            <a:avLst/>
+          </a:prstGeom>
+          <a:noFill/>
+        </p:spPr>
+        <p:txBody>
+          <a:bodyPr wrap="square">
+            <a:spAutoFit/>
+          </a:bodyPr>
+          <a:lstStyle/>
+          <a:p>
+            <a:pPr>
+              <a:spcAft>
+                <a:spcPts val="400"/>
+              </a:spcAft>
+              <a:defRPr sz="1000">
+                <a:solidFill>
+                  <a:srgbClr val="2D5A3B"/>
+                </a:solidFill>
+              </a:defRPr>
+            </a:pPr>
+            <a:r>
+              <a:t>Technical</a:t>
+            </a:r>
+          </a:p>
+        </p:txBody>
+      </p:sp>
+      <p:sp>
+        <p:nvSpPr>
+          <p:cNvPr id="23" name="Rounded Rectangle 22"/>
+          <p:cNvSpPr/>
+          <p:nvPr/>
+        </p:nvSpPr>
+        <p:spPr>
+          <a:xfrm>
+            <a:off x="7863840" y="2377440"/>
+            <a:ext cx="164592" cy="164592"/>
+          </a:xfrm>
+          <a:prstGeom prst="roundRect">
+            <a:avLst/>
+          </a:prstGeom>
+          <a:solidFill>
+            <a:srgbClr val="47AB75"/>
+          </a:solidFill>
+          <a:ln>
+            <a:noFill/>
+          </a:ln>
+        </p:spPr>
+        <p:style>
+          <a:lnRef idx="1">
+            <a:schemeClr val="accent1"/>
+          </a:lnRef>
+          <a:fillRef idx="3">
+            <a:schemeClr val="accent1"/>
+          </a:fillRef>
+          <a:effectRef idx="2">
+            <a:schemeClr val="accent1"/>
+          </a:effectRef>
+          <a:fontRef idx="minor">
+            <a:schemeClr val="lt1"/>
+          </a:fontRef>
+        </p:style>
+        <p:txBody>
+          <a:bodyPr rtlCol="0" anchor="ctr"/>
+          <a:lstStyle/>
+          <a:p>
+            <a:pPr algn="ctr"/>
+          </a:p>
+        </p:txBody>
+      </p:sp>
+      <p:sp>
+        <p:nvSpPr>
+          <p:cNvPr id="24" name="TextBox 23"/>
+          <p:cNvSpPr txBox="1"/>
+          <p:nvPr/>
+        </p:nvSpPr>
+        <p:spPr>
+          <a:xfrm>
+            <a:off x="8046720" y="2340864"/>
+            <a:ext cx="548640" cy="182880"/>
+          </a:xfrm>
+          <a:prstGeom prst="rect">
+            <a:avLst/>
+          </a:prstGeom>
+          <a:noFill/>
+        </p:spPr>
+        <p:txBody>
+          <a:bodyPr wrap="square">
+            <a:spAutoFit/>
+          </a:bodyPr>
+          <a:lstStyle/>
+          <a:p>
+            <a:pPr>
+              <a:spcAft>
+                <a:spcPts val="400"/>
+              </a:spcAft>
+              <a:defRPr sz="1000">
+                <a:solidFill>
+                  <a:srgbClr val="225435"/>
+                </a:solidFill>
+              </a:defRPr>
+            </a:pPr>
+            <a:r>
+              <a:t>PLA</a:t>
+            </a:r>
+          </a:p>
+        </p:txBody>
+      </p:sp>
+      <p:sp>
+        <p:nvSpPr>
+          <p:cNvPr id="25" name="Rounded Rectangle 24"/>
+          <p:cNvSpPr/>
+          <p:nvPr/>
+        </p:nvSpPr>
+        <p:spPr>
+          <a:xfrm>
+            <a:off x="9006840" y="3246120"/>
+            <a:ext cx="164592" cy="164592"/>
+          </a:xfrm>
+          <a:prstGeom prst="roundRect">
+            <a:avLst/>
+          </a:prstGeom>
+          <a:solidFill>
+            <a:srgbClr val="E77A43"/>
+          </a:solidFill>
+          <a:ln>
+            <a:noFill/>
+          </a:ln>
+        </p:spPr>
+        <p:style>
+          <a:lnRef idx="1">
+            <a:schemeClr val="accent1"/>
+          </a:lnRef>
+          <a:fillRef idx="3">
+            <a:schemeClr val="accent1"/>
+          </a:fillRef>
+          <a:effectRef idx="2">
+            <a:schemeClr val="accent1"/>
+          </a:effectRef>
+          <a:fontRef idx="minor">
+            <a:schemeClr val="lt1"/>
+          </a:fontRef>
+        </p:style>
+        <p:txBody>
+          <a:bodyPr rtlCol="0" anchor="ctr"/>
+          <a:lstStyle/>
+          <a:p>
+            <a:pPr algn="ctr"/>
+          </a:p>
+        </p:txBody>
+      </p:sp>
+      <p:sp>
+        <p:nvSpPr>
+          <p:cNvPr id="26" name="TextBox 25"/>
+          <p:cNvSpPr txBox="1"/>
+          <p:nvPr/>
+        </p:nvSpPr>
+        <p:spPr>
+          <a:xfrm>
+            <a:off x="9217152" y="3218688"/>
+            <a:ext cx="548640" cy="182880"/>
+          </a:xfrm>
+          <a:prstGeom prst="rect">
+            <a:avLst/>
+          </a:prstGeom>
+          <a:noFill/>
+        </p:spPr>
+        <p:txBody>
+          <a:bodyPr wrap="square">
+            <a:spAutoFit/>
+          </a:bodyPr>
+          <a:lstStyle/>
+          <a:p>
+            <a:pPr>
+              <a:spcAft>
+                <a:spcPts val="400"/>
+              </a:spcAft>
+              <a:defRPr sz="1000">
+                <a:solidFill>
+                  <a:srgbClr val="6D3C22"/>
+                </a:solidFill>
+              </a:defRPr>
+            </a:pPr>
+            <a:r>
+              <a:t>PPE</a:t>
+            </a:r>
+          </a:p>
+        </p:txBody>
+      </p:sp>
+      <p:sp>
+        <p:nvSpPr>
+          <p:cNvPr id="27" name="TextBox 26"/>
+          <p:cNvSpPr txBox="1"/>
+          <p:nvPr/>
+        </p:nvSpPr>
+        <p:spPr>
+          <a:xfrm>
+            <a:off x="6812280" y="4526280"/>
+            <a:ext cx="4480560" cy="1463040"/>
+          </a:xfrm>
+          <a:prstGeom prst="rect">
+            <a:avLst/>
+          </a:prstGeom>
+          <a:noFill/>
+        </p:spPr>
+        <p:txBody>
+          <a:bodyPr wrap="square">
+            <a:spAutoFit/>
+          </a:bodyPr>
+          <a:lstStyle/>
+          <a:p>
+            <a:pPr>
+              <a:spcAft>
+                <a:spcPts val="400"/>
+              </a:spcAft>
+              <a:defRPr sz="1100">
+                <a:solidFill>
+                  <a:srgbClr val="282828"/>
+                </a:solidFill>
+              </a:defRPr>
+            </a:pPr>
+            <a:r>
+              <a:t>Final conclusions:</a:t>
+            </a:r>
+          </a:p>
+          <a:p>
+            <a:pPr>
+              <a:spcAft>
+                <a:spcPts val="400"/>
+              </a:spcAft>
+              <a:defRPr sz="1100">
+                <a:solidFill>
+                  <a:srgbClr val="282828"/>
+                </a:solidFill>
+              </a:defRPr>
+            </a:pPr>
+            <a:r>
+              <a:t>• PLA: best environmental option (if composting is available).</a:t>
+            </a:r>
+          </a:p>
+          <a:p>
+            <a:pPr>
+              <a:spcAft>
+                <a:spcPts val="400"/>
+              </a:spcAft>
+              <a:defRPr sz="1100">
+                <a:solidFill>
+                  <a:srgbClr val="282828"/>
+                </a:solidFill>
+              </a:defRPr>
+            </a:pPr>
+            <a:r>
+              <a:t>• PPE: best economic + technical option (especially hot food).</a:t>
+            </a:r>
+          </a:p>
+          <a:p>
+            <a:pPr>
+              <a:spcAft>
+                <a:spcPts val="400"/>
+              </a:spcAft>
+              <a:defRPr sz="1100">
+                <a:solidFill>
+                  <a:srgbClr val="282828"/>
+                </a:solidFill>
+              </a:defRPr>
+            </a:pPr>
+            <a:r>
+              <a:t>• Recommended for deployment: choose by temperature, waste system, and budget.</a:t>
             </a:r>
           </a:p>
         </p:txBody>

</xml_diff>

<commit_message>
Add PPE vs PLA comparison table slide
Agent-Logs-Url: https://github.com/aniket-kanani-3107/aniket-kanani-3107.github.io/sessions/0fdc059d-f47e-40b1-9c42-f663f5a20979

Co-authored-by: aniket-kanani-3107 <268387354+aniket-kanani-3107@users.noreply.github.com>
</commit_message>
<xml_diff>
--- a/Food-Packaging-Containers.pptx
+++ b/Food-Packaging-Containers.pptx
@@ -11,6 +11,7 @@
     <p:sldId id="259" r:id="rId10"/>
     <p:sldId id="260" r:id="rId11"/>
     <p:sldId id="261" r:id="rId12"/>
+    <p:sldId id="262" r:id="rId13"/>
   </p:sldIdLst>
   <p:sldSz cx="12188952" cy="6858000" type="screen4x3"/>
   <p:notesSz cx="6858000" cy="9144000"/>
@@ -12388,6 +12389,891 @@
             <a:br/>
             <a:r>
               <a:t>  composting infrastructure, and cost constraints.</a:t>
+            </a:r>
+          </a:p>
+        </p:txBody>
+      </p:sp>
+    </p:spTree>
+  </p:cSld>
+  <p:clrMapOvr>
+    <a:masterClrMapping/>
+  </p:clrMapOvr>
+</p:sld>
+</file>
+
+<file path=ppt/slides/slide7.xml><?xml version="1.0" encoding="utf-8"?>
+<p:sld xmlns:a="http://schemas.openxmlformats.org/drawingml/2006/main" xmlns:p="http://schemas.openxmlformats.org/presentationml/2006/main" xmlns:r="http://schemas.openxmlformats.org/officeDocument/2006/relationships">
+  <p:cSld>
+    <p:spTree>
+      <p:nvGrpSpPr>
+        <p:cNvPr id="1" name=""/>
+        <p:cNvGrpSpPr/>
+        <p:nvPr/>
+      </p:nvGrpSpPr>
+      <p:grpSpPr/>
+      <p:sp>
+        <p:nvSpPr>
+          <p:cNvPr id="2" name="Title 1"/>
+          <p:cNvSpPr>
+            <a:spLocks noGrp="1"/>
+          </p:cNvSpPr>
+          <p:nvPr>
+            <p:ph type="title"/>
+          </p:nvPr>
+        </p:nvSpPr>
+        <p:spPr/>
+        <p:txBody>
+          <a:bodyPr/>
+          <a:lstStyle/>
+          <a:p>
+            <a:r>
+              <a:rPr b="1" sz="3400">
+                <a:solidFill>
+                  <a:srgbClr val="18477A"/>
+                </a:solidFill>
+              </a:rPr>
+              <a:t>WHY WE ARE USING PPE INSTEAD OF PLA</a:t>
+            </a:r>
+          </a:p>
+        </p:txBody>
+      </p:sp>
+      <p:sp>
+        <p:nvSpPr>
+          <p:cNvPr id="3" name="TextBox 2"/>
+          <p:cNvSpPr txBox="1"/>
+          <p:nvPr/>
+        </p:nvSpPr>
+        <p:spPr>
+          <a:xfrm>
+            <a:off x="548640" y="1051560"/>
+            <a:ext cx="11155680" cy="411480"/>
+          </a:xfrm>
+          <a:prstGeom prst="rect">
+            <a:avLst/>
+          </a:prstGeom>
+          <a:noFill/>
+        </p:spPr>
+        <p:txBody>
+          <a:bodyPr wrap="none">
+            <a:spAutoFit/>
+          </a:bodyPr>
+          <a:lstStyle/>
+          <a:p>
+            <a:pPr algn="l"/>
+            <a:r>
+              <a:rPr sz="1600">
+                <a:solidFill>
+                  <a:srgbClr val="3C3C3C"/>
+                </a:solidFill>
+              </a:rPr>
+              <a:t>Comparison for takeaway food containers (editable table)</a:t>
+            </a:r>
+          </a:p>
+        </p:txBody>
+      </p:sp>
+      <p:graphicFrame>
+        <p:nvGraphicFramePr>
+          <p:cNvPr id="4" name="Table 3"/>
+          <p:cNvGraphicFramePr>
+            <a:graphicFrameLocks noGrp="1"/>
+          </p:cNvGraphicFramePr>
+          <p:nvPr/>
+        </p:nvGraphicFramePr>
+        <p:xfrm>
+          <a:off x="411480" y="1600200"/>
+          <a:ext cx="11338560" cy="4434840"/>
+        </p:xfrm>
+        <a:graphic>
+          <a:graphicData uri="http://schemas.openxmlformats.org/drawingml/2006/table">
+            <a:tbl>
+              <a:tblPr firstRow="1" bandRow="1">
+                <a:tableStyleId>{5C22544A-7EE6-4342-B048-85BDC9FD1C3A}</a:tableStyleId>
+              </a:tblPr>
+              <a:tblGrid>
+                <a:gridCol w="2286000"/>
+                <a:gridCol w="2926080"/>
+                <a:gridCol w="2926080"/>
+                <a:gridCol w="3200400"/>
+              </a:tblGrid>
+              <a:tr h="492760">
+                <a:tc>
+                  <a:txBody>
+                    <a:bodyPr/>
+                    <a:lstStyle/>
+                    <a:p>
+                      <a:pPr algn="ctr"/>
+                      <a:r>
+                        <a:rPr b="1" sz="1400">
+                          <a:solidFill>
+                            <a:srgbClr val="FFFFFF"/>
+                          </a:solidFill>
+                        </a:rPr>
+                        <a:t>Criteria</a:t>
+                      </a:r>
+                    </a:p>
+                  </a:txBody>
+                  <a:tcPr>
+                    <a:solidFill>
+                      <a:srgbClr val="18477A"/>
+                    </a:solidFill>
+                  </a:tcPr>
+                </a:tc>
+                <a:tc>
+                  <a:txBody>
+                    <a:bodyPr/>
+                    <a:lstStyle/>
+                    <a:p>
+                      <a:pPr algn="ctr"/>
+                      <a:r>
+                        <a:rPr b="1" sz="1400">
+                          <a:solidFill>
+                            <a:srgbClr val="FFFFFF"/>
+                          </a:solidFill>
+                        </a:rPr>
+                        <a:t>PLA</a:t>
+                      </a:r>
+                    </a:p>
+                  </a:txBody>
+                  <a:tcPr>
+                    <a:solidFill>
+                      <a:srgbClr val="18477A"/>
+                    </a:solidFill>
+                  </a:tcPr>
+                </a:tc>
+                <a:tc>
+                  <a:txBody>
+                    <a:bodyPr/>
+                    <a:lstStyle/>
+                    <a:p>
+                      <a:pPr algn="ctr"/>
+                      <a:r>
+                        <a:rPr b="1" sz="1400">
+                          <a:solidFill>
+                            <a:srgbClr val="FFFFFF"/>
+                          </a:solidFill>
+                        </a:rPr>
+                        <a:t>PPE</a:t>
+                      </a:r>
+                    </a:p>
+                  </a:txBody>
+                  <a:tcPr>
+                    <a:solidFill>
+                      <a:srgbClr val="18477A"/>
+                    </a:solidFill>
+                  </a:tcPr>
+                </a:tc>
+                <a:tc>
+                  <a:txBody>
+                    <a:bodyPr/>
+                    <a:lstStyle/>
+                    <a:p>
+                      <a:pPr algn="ctr"/>
+                      <a:r>
+                        <a:rPr b="1" sz="1400">
+                          <a:solidFill>
+                            <a:srgbClr val="FFFFFF"/>
+                          </a:solidFill>
+                        </a:rPr>
+                        <a:t>Why PPE is preferred here</a:t>
+                      </a:r>
+                    </a:p>
+                  </a:txBody>
+                  <a:tcPr>
+                    <a:solidFill>
+                      <a:srgbClr val="18477A"/>
+                    </a:solidFill>
+                  </a:tcPr>
+                </a:tc>
+              </a:tr>
+              <a:tr h="492760">
+                <a:tc>
+                  <a:txBody>
+                    <a:bodyPr wrap="square"/>
+                    <a:lstStyle/>
+                    <a:p>
+                      <a:pPr algn="ctr"/>
+                      <a:r>
+                        <a:rPr sz="1200" b="1">
+                          <a:solidFill>
+                            <a:srgbClr val="232323"/>
+                          </a:solidFill>
+                        </a:rPr>
+                        <a:t>Heat resistance</a:t>
+                      </a:r>
+                    </a:p>
+                  </a:txBody>
+                  <a:tcPr/>
+                </a:tc>
+                <a:tc>
+                  <a:txBody>
+                    <a:bodyPr wrap="square"/>
+                    <a:lstStyle/>
+                    <a:p>
+                      <a:pPr algn="l"/>
+                      <a:r>
+                        <a:rPr sz="1200">
+                          <a:solidFill>
+                            <a:srgbClr val="232323"/>
+                          </a:solidFill>
+                        </a:rPr>
+                        <a:t>~55°C (softens at higher temperature)</a:t>
+                      </a:r>
+                    </a:p>
+                  </a:txBody>
+                  <a:tcPr/>
+                </a:tc>
+                <a:tc>
+                  <a:txBody>
+                    <a:bodyPr wrap="square"/>
+                    <a:lstStyle/>
+                    <a:p>
+                      <a:pPr algn="l"/>
+                      <a:r>
+                        <a:rPr sz="1200">
+                          <a:solidFill>
+                            <a:srgbClr val="232323"/>
+                          </a:solidFill>
+                        </a:rPr>
+                        <a:t>Up to ~100°C</a:t>
+                      </a:r>
+                    </a:p>
+                  </a:txBody>
+                  <a:tcPr/>
+                </a:tc>
+                <a:tc>
+                  <a:txBody>
+                    <a:bodyPr wrap="square"/>
+                    <a:lstStyle/>
+                    <a:p>
+                      <a:pPr algn="l"/>
+                      <a:r>
+                        <a:rPr sz="1200">
+                          <a:solidFill>
+                            <a:srgbClr val="232323"/>
+                          </a:solidFill>
+                        </a:rPr>
+                        <a:t>Better for hot meals and transport.</a:t>
+                      </a:r>
+                    </a:p>
+                  </a:txBody>
+                  <a:tcPr/>
+                </a:tc>
+              </a:tr>
+              <a:tr h="492760">
+                <a:tc>
+                  <a:txBody>
+                    <a:bodyPr wrap="square"/>
+                    <a:lstStyle/>
+                    <a:p>
+                      <a:pPr algn="ctr"/>
+                      <a:r>
+                        <a:rPr sz="1200" b="1">
+                          <a:solidFill>
+                            <a:srgbClr val="232323"/>
+                          </a:solidFill>
+                        </a:rPr>
+                        <a:t>Manufacturing process</a:t>
+                      </a:r>
+                    </a:p>
+                  </a:txBody>
+                  <a:tcPr>
+                    <a:solidFill>
+                      <a:srgbClr val="F3F7FC"/>
+                    </a:solidFill>
+                  </a:tcPr>
+                </a:tc>
+                <a:tc>
+                  <a:txBody>
+                    <a:bodyPr wrap="square"/>
+                    <a:lstStyle/>
+                    <a:p>
+                      <a:pPr algn="l"/>
+                      <a:r>
+                        <a:rPr sz="1200">
+                          <a:solidFill>
+                            <a:srgbClr val="232323"/>
+                          </a:solidFill>
+                        </a:rPr>
+                        <a:t>Thermoforming sheet process</a:t>
+                      </a:r>
+                    </a:p>
+                  </a:txBody>
+                  <a:tcPr>
+                    <a:solidFill>
+                      <a:srgbClr val="F3F7FC"/>
+                    </a:solidFill>
+                  </a:tcPr>
+                </a:tc>
+                <a:tc>
+                  <a:txBody>
+                    <a:bodyPr wrap="square"/>
+                    <a:lstStyle/>
+                    <a:p>
+                      <a:pPr algn="l"/>
+                      <a:r>
+                        <a:rPr sz="1200">
+                          <a:solidFill>
+                            <a:srgbClr val="232323"/>
+                          </a:solidFill>
+                        </a:rPr>
+                        <a:t>Injection moulding</a:t>
+                      </a:r>
+                    </a:p>
+                  </a:txBody>
+                  <a:tcPr>
+                    <a:solidFill>
+                      <a:srgbClr val="F3F7FC"/>
+                    </a:solidFill>
+                  </a:tcPr>
+                </a:tc>
+                <a:tc>
+                  <a:txBody>
+                    <a:bodyPr wrap="square"/>
+                    <a:lstStyle/>
+                    <a:p>
+                      <a:pPr algn="l"/>
+                      <a:r>
+                        <a:rPr sz="1200">
+                          <a:solidFill>
+                            <a:srgbClr val="232323"/>
+                          </a:solidFill>
+                        </a:rPr>
+                        <a:t>More robust, repeatable parts at scale.</a:t>
+                      </a:r>
+                    </a:p>
+                  </a:txBody>
+                  <a:tcPr>
+                    <a:solidFill>
+                      <a:srgbClr val="F3F7FC"/>
+                    </a:solidFill>
+                  </a:tcPr>
+                </a:tc>
+              </a:tr>
+              <a:tr h="492760">
+                <a:tc>
+                  <a:txBody>
+                    <a:bodyPr wrap="square"/>
+                    <a:lstStyle/>
+                    <a:p>
+                      <a:pPr algn="ctr"/>
+                      <a:r>
+                        <a:rPr sz="1200" b="1">
+                          <a:solidFill>
+                            <a:srgbClr val="232323"/>
+                          </a:solidFill>
+                        </a:rPr>
+                        <a:t>Strength &amp; rigidity</a:t>
+                      </a:r>
+                    </a:p>
+                  </a:txBody>
+                  <a:tcPr/>
+                </a:tc>
+                <a:tc>
+                  <a:txBody>
+                    <a:bodyPr wrap="square"/>
+                    <a:lstStyle/>
+                    <a:p>
+                      <a:pPr algn="l"/>
+                      <a:r>
+                        <a:rPr sz="1200">
+                          <a:solidFill>
+                            <a:srgbClr val="232323"/>
+                          </a:solidFill>
+                        </a:rPr>
+                        <a:t>Lower impact strength</a:t>
+                      </a:r>
+                    </a:p>
+                  </a:txBody>
+                  <a:tcPr/>
+                </a:tc>
+                <a:tc>
+                  <a:txBody>
+                    <a:bodyPr wrap="square"/>
+                    <a:lstStyle/>
+                    <a:p>
+                      <a:pPr algn="l"/>
+                      <a:r>
+                        <a:rPr sz="1200">
+                          <a:solidFill>
+                            <a:srgbClr val="232323"/>
+                          </a:solidFill>
+                        </a:rPr>
+                        <a:t>Higher toughness</a:t>
+                      </a:r>
+                    </a:p>
+                  </a:txBody>
+                  <a:tcPr/>
+                </a:tc>
+                <a:tc>
+                  <a:txBody>
+                    <a:bodyPr wrap="square"/>
+                    <a:lstStyle/>
+                    <a:p>
+                      <a:pPr algn="l"/>
+                      <a:r>
+                        <a:rPr sz="1200">
+                          <a:solidFill>
+                            <a:srgbClr val="232323"/>
+                          </a:solidFill>
+                        </a:rPr>
+                        <a:t>Reduces cracks/leaks during handling.</a:t>
+                      </a:r>
+                    </a:p>
+                  </a:txBody>
+                  <a:tcPr/>
+                </a:tc>
+              </a:tr>
+              <a:tr h="492760">
+                <a:tc>
+                  <a:txBody>
+                    <a:bodyPr wrap="square"/>
+                    <a:lstStyle/>
+                    <a:p>
+                      <a:pPr algn="ctr"/>
+                      <a:r>
+                        <a:rPr sz="1200" b="1">
+                          <a:solidFill>
+                            <a:srgbClr val="232323"/>
+                          </a:solidFill>
+                        </a:rPr>
+                        <a:t>Unit cost (high volume)</a:t>
+                      </a:r>
+                    </a:p>
+                  </a:txBody>
+                  <a:tcPr>
+                    <a:solidFill>
+                      <a:srgbClr val="F3F7FC"/>
+                    </a:solidFill>
+                  </a:tcPr>
+                </a:tc>
+                <a:tc>
+                  <a:txBody>
+                    <a:bodyPr wrap="square"/>
+                    <a:lstStyle/>
+                    <a:p>
+                      <a:pPr algn="l"/>
+                      <a:r>
+                        <a:rPr sz="1200">
+                          <a:solidFill>
+                            <a:srgbClr val="232323"/>
+                          </a:solidFill>
+                        </a:rPr>
+                        <a:t>Material often higher cost</a:t>
+                      </a:r>
+                    </a:p>
+                  </a:txBody>
+                  <a:tcPr>
+                    <a:solidFill>
+                      <a:srgbClr val="F3F7FC"/>
+                    </a:solidFill>
+                  </a:tcPr>
+                </a:tc>
+                <a:tc>
+                  <a:txBody>
+                    <a:bodyPr wrap="square"/>
+                    <a:lstStyle/>
+                    <a:p>
+                      <a:pPr algn="l"/>
+                      <a:r>
+                        <a:rPr sz="1200">
+                          <a:solidFill>
+                            <a:srgbClr val="232323"/>
+                          </a:solidFill>
+                        </a:rPr>
+                        <a:t>Lower overall LCC in this study</a:t>
+                      </a:r>
+                    </a:p>
+                  </a:txBody>
+                  <a:tcPr>
+                    <a:solidFill>
+                      <a:srgbClr val="F3F7FC"/>
+                    </a:solidFill>
+                  </a:tcPr>
+                </a:tc>
+                <a:tc>
+                  <a:txBody>
+                    <a:bodyPr wrap="square"/>
+                    <a:lstStyle/>
+                    <a:p>
+                      <a:pPr algn="l"/>
+                      <a:r>
+                        <a:rPr sz="1200">
+                          <a:solidFill>
+                            <a:srgbClr val="232323"/>
+                          </a:solidFill>
+                        </a:rPr>
+                        <a:t>Improves profitability at mass production.</a:t>
+                      </a:r>
+                    </a:p>
+                  </a:txBody>
+                  <a:tcPr>
+                    <a:solidFill>
+                      <a:srgbClr val="F3F7FC"/>
+                    </a:solidFill>
+                  </a:tcPr>
+                </a:tc>
+              </a:tr>
+              <a:tr h="492760">
+                <a:tc>
+                  <a:txBody>
+                    <a:bodyPr wrap="square"/>
+                    <a:lstStyle/>
+                    <a:p>
+                      <a:pPr algn="ctr"/>
+                      <a:r>
+                        <a:rPr sz="1200" b="1">
+                          <a:solidFill>
+                            <a:srgbClr val="232323"/>
+                          </a:solidFill>
+                        </a:rPr>
+                        <a:t>Cycle time/tooling</a:t>
+                      </a:r>
+                    </a:p>
+                  </a:txBody>
+                  <a:tcPr/>
+                </a:tc>
+                <a:tc>
+                  <a:txBody>
+                    <a:bodyPr wrap="square"/>
+                    <a:lstStyle/>
+                    <a:p>
+                      <a:pPr algn="l"/>
+                      <a:r>
+                        <a:rPr sz="1200">
+                          <a:solidFill>
+                            <a:srgbClr val="232323"/>
+                          </a:solidFill>
+                        </a:rPr>
+                        <a:t>Stable but design-limited</a:t>
+                      </a:r>
+                    </a:p>
+                  </a:txBody>
+                  <a:tcPr/>
+                </a:tc>
+                <a:tc>
+                  <a:txBody>
+                    <a:bodyPr wrap="square"/>
+                    <a:lstStyle/>
+                    <a:p>
+                      <a:pPr algn="l"/>
+                      <a:r>
+                        <a:rPr sz="1200">
+                          <a:solidFill>
+                            <a:srgbClr val="232323"/>
+                          </a:solidFill>
+                        </a:rPr>
+                        <a:t>Fast cycles after tooling setup</a:t>
+                      </a:r>
+                    </a:p>
+                  </a:txBody>
+                  <a:tcPr/>
+                </a:tc>
+                <a:tc>
+                  <a:txBody>
+                    <a:bodyPr wrap="square"/>
+                    <a:lstStyle/>
+                    <a:p>
+                      <a:pPr algn="l"/>
+                      <a:r>
+                        <a:rPr sz="1200">
+                          <a:solidFill>
+                            <a:srgbClr val="232323"/>
+                          </a:solidFill>
+                        </a:rPr>
+                        <a:t>Higher throughput for large demand.</a:t>
+                      </a:r>
+                    </a:p>
+                  </a:txBody>
+                  <a:tcPr/>
+                </a:tc>
+              </a:tr>
+              <a:tr h="492760">
+                <a:tc>
+                  <a:txBody>
+                    <a:bodyPr wrap="square"/>
+                    <a:lstStyle/>
+                    <a:p>
+                      <a:pPr algn="ctr"/>
+                      <a:r>
+                        <a:rPr sz="1200" b="1">
+                          <a:solidFill>
+                            <a:srgbClr val="232323"/>
+                          </a:solidFill>
+                        </a:rPr>
+                        <a:t>Food service usage</a:t>
+                      </a:r>
+                    </a:p>
+                  </a:txBody>
+                  <a:tcPr>
+                    <a:solidFill>
+                      <a:srgbClr val="F3F7FC"/>
+                    </a:solidFill>
+                  </a:tcPr>
+                </a:tc>
+                <a:tc>
+                  <a:txBody>
+                    <a:bodyPr wrap="square"/>
+                    <a:lstStyle/>
+                    <a:p>
+                      <a:pPr algn="l"/>
+                      <a:r>
+                        <a:rPr sz="1200">
+                          <a:solidFill>
+                            <a:srgbClr val="232323"/>
+                          </a:solidFill>
+                        </a:rPr>
+                        <a:t>Good for mild-temperature food</a:t>
+                      </a:r>
+                    </a:p>
+                  </a:txBody>
+                  <a:tcPr>
+                    <a:solidFill>
+                      <a:srgbClr val="F3F7FC"/>
+                    </a:solidFill>
+                  </a:tcPr>
+                </a:tc>
+                <a:tc>
+                  <a:txBody>
+                    <a:bodyPr wrap="square"/>
+                    <a:lstStyle/>
+                    <a:p>
+                      <a:pPr algn="l"/>
+                      <a:r>
+                        <a:rPr sz="1200">
+                          <a:solidFill>
+                            <a:srgbClr val="232323"/>
+                          </a:solidFill>
+                        </a:rPr>
+                        <a:t>Better for hot/oily food service</a:t>
+                      </a:r>
+                    </a:p>
+                  </a:txBody>
+                  <a:tcPr>
+                    <a:solidFill>
+                      <a:srgbClr val="F3F7FC"/>
+                    </a:solidFill>
+                  </a:tcPr>
+                </a:tc>
+                <a:tc>
+                  <a:txBody>
+                    <a:bodyPr wrap="square"/>
+                    <a:lstStyle/>
+                    <a:p>
+                      <a:pPr algn="l"/>
+                      <a:r>
+                        <a:rPr sz="1200">
+                          <a:solidFill>
+                            <a:srgbClr val="232323"/>
+                          </a:solidFill>
+                        </a:rPr>
+                        <a:t>Wider usage range in takeaway market.</a:t>
+                      </a:r>
+                    </a:p>
+                  </a:txBody>
+                  <a:tcPr>
+                    <a:solidFill>
+                      <a:srgbClr val="F3F7FC"/>
+                    </a:solidFill>
+                  </a:tcPr>
+                </a:tc>
+              </a:tr>
+              <a:tr h="492760">
+                <a:tc>
+                  <a:txBody>
+                    <a:bodyPr wrap="square"/>
+                    <a:lstStyle/>
+                    <a:p>
+                      <a:pPr algn="ctr"/>
+                      <a:r>
+                        <a:rPr sz="1200" b="1">
+                          <a:solidFill>
+                            <a:srgbClr val="232323"/>
+                          </a:solidFill>
+                        </a:rPr>
+                        <a:t>Composting profile</a:t>
+                      </a:r>
+                    </a:p>
+                  </a:txBody>
+                  <a:tcPr/>
+                </a:tc>
+                <a:tc>
+                  <a:txBody>
+                    <a:bodyPr wrap="square"/>
+                    <a:lstStyle/>
+                    <a:p>
+                      <a:pPr algn="l"/>
+                      <a:r>
+                        <a:rPr sz="1200">
+                          <a:solidFill>
+                            <a:srgbClr val="232323"/>
+                          </a:solidFill>
+                        </a:rPr>
+                        <a:t>Industrial composting friendly</a:t>
+                      </a:r>
+                    </a:p>
+                  </a:txBody>
+                  <a:tcPr/>
+                </a:tc>
+                <a:tc>
+                  <a:txBody>
+                    <a:bodyPr wrap="square"/>
+                    <a:lstStyle/>
+                    <a:p>
+                      <a:pPr algn="l"/>
+                      <a:r>
+                        <a:rPr sz="1200">
+                          <a:solidFill>
+                            <a:srgbClr val="232323"/>
+                          </a:solidFill>
+                        </a:rPr>
+                        <a:t>Limited compostability</a:t>
+                      </a:r>
+                    </a:p>
+                  </a:txBody>
+                  <a:tcPr/>
+                </a:tc>
+                <a:tc>
+                  <a:txBody>
+                    <a:bodyPr wrap="square"/>
+                    <a:lstStyle/>
+                    <a:p>
+                      <a:pPr algn="l"/>
+                      <a:r>
+                        <a:rPr sz="1200">
+                          <a:solidFill>
+                            <a:srgbClr val="232323"/>
+                          </a:solidFill>
+                        </a:rPr>
+                        <a:t>PPE selected due to performance/cost trade-off.</a:t>
+                      </a:r>
+                    </a:p>
+                  </a:txBody>
+                  <a:tcPr/>
+                </a:tc>
+              </a:tr>
+              <a:tr h="492760">
+                <a:tc>
+                  <a:txBody>
+                    <a:bodyPr wrap="square"/>
+                    <a:lstStyle/>
+                    <a:p>
+                      <a:pPr algn="ctr"/>
+                      <a:r>
+                        <a:rPr sz="1200" b="1">
+                          <a:solidFill>
+                            <a:srgbClr val="232323"/>
+                          </a:solidFill>
+                        </a:rPr>
+                        <a:t>Final decision for this project</a:t>
+                      </a:r>
+                    </a:p>
+                  </a:txBody>
+                  <a:tcPr>
+                    <a:solidFill>
+                      <a:srgbClr val="F3F7FC"/>
+                    </a:solidFill>
+                  </a:tcPr>
+                </a:tc>
+                <a:tc>
+                  <a:txBody>
+                    <a:bodyPr wrap="square"/>
+                    <a:lstStyle/>
+                    <a:p>
+                      <a:pPr algn="l"/>
+                      <a:r>
+                        <a:rPr sz="1200">
+                          <a:solidFill>
+                            <a:srgbClr val="232323"/>
+                          </a:solidFill>
+                        </a:rPr>
+                        <a:t>Environment-focused baseline</a:t>
+                      </a:r>
+                    </a:p>
+                  </a:txBody>
+                  <a:tcPr>
+                    <a:solidFill>
+                      <a:srgbClr val="F3F7FC"/>
+                    </a:solidFill>
+                  </a:tcPr>
+                </a:tc>
+                <a:tc>
+                  <a:txBody>
+                    <a:bodyPr wrap="square"/>
+                    <a:lstStyle/>
+                    <a:p>
+                      <a:pPr algn="l"/>
+                      <a:r>
+                        <a:rPr sz="1200">
+                          <a:solidFill>
+                            <a:srgbClr val="232323"/>
+                          </a:solidFill>
+                        </a:rPr>
+                        <a:t>Selected option</a:t>
+                      </a:r>
+                    </a:p>
+                  </a:txBody>
+                  <a:tcPr>
+                    <a:solidFill>
+                      <a:srgbClr val="F3F7FC"/>
+                    </a:solidFill>
+                  </a:tcPr>
+                </a:tc>
+                <a:tc>
+                  <a:txBody>
+                    <a:bodyPr wrap="square"/>
+                    <a:lstStyle/>
+                    <a:p>
+                      <a:pPr algn="l"/>
+                      <a:r>
+                        <a:rPr sz="1200">
+                          <a:solidFill>
+                            <a:srgbClr val="232323"/>
+                          </a:solidFill>
+                        </a:rPr>
+                        <a:t>PPE chosen for heat, durability, and lower cost.</a:t>
+                      </a:r>
+                    </a:p>
+                  </a:txBody>
+                  <a:tcPr>
+                    <a:solidFill>
+                      <a:srgbClr val="F3F7FC"/>
+                    </a:solidFill>
+                  </a:tcPr>
+                </a:tc>
+              </a:tr>
+            </a:tbl>
+          </a:graphicData>
+        </a:graphic>
+      </p:graphicFrame>
+      <p:sp>
+        <p:nvSpPr>
+          <p:cNvPr id="5" name="TextBox 4"/>
+          <p:cNvSpPr txBox="1"/>
+          <p:nvPr/>
+        </p:nvSpPr>
+        <p:spPr>
+          <a:xfrm>
+            <a:off x="502920" y="6080760"/>
+            <a:ext cx="11155680" cy="320040"/>
+          </a:xfrm>
+          <a:prstGeom prst="rect">
+            <a:avLst/>
+          </a:prstGeom>
+          <a:noFill/>
+        </p:spPr>
+        <p:txBody>
+          <a:bodyPr wrap="none">
+            <a:spAutoFit/>
+          </a:bodyPr>
+          <a:lstStyle/>
+          <a:p>
+            <a:r>
+              <a:rPr sz="1100" i="1">
+                <a:solidFill>
+                  <a:srgbClr val="5A5A5A"/>
+                </a:solidFill>
+              </a:rPr>
+              <a:t>Note: PPE is selected for this case-study objective (hot-food performance + cost). PLA remains stronger on industrial compostability.</a:t>
             </a:r>
           </a:p>
         </p:txBody>

</xml_diff>

<commit_message>
Add material market share slide with pie chart
Agent-Logs-Url: https://github.com/aniket-kanani-3107/aniket-kanani-3107.github.io/sessions/bdb68997-60b9-4bbf-827c-40bde33bf0a9

Co-authored-by: aniket-kanani-3107 <268387354+aniket-kanani-3107@users.noreply.github.com>
</commit_message>
<xml_diff>
--- a/Food-Packaging-Containers.pptx
+++ b/Food-Packaging-Containers.pptx
@@ -12,6 +12,7 @@
     <p:sldId id="260" r:id="rId11"/>
     <p:sldId id="261" r:id="rId12"/>
     <p:sldId id="262" r:id="rId13"/>
+    <p:sldId id="263" r:id="rId14"/>
   </p:sldIdLst>
   <p:sldSz cx="12188952" cy="6858000" type="screen4x3"/>
   <p:notesSz cx="6858000" cy="9144000"/>
@@ -498,6 +499,103 @@
     </c:plotArea>
     <c:legend>
       <c:legendPos val="b"/>
+    </c:legend>
+    <c:dispBlanksAs val="gap"/>
+  </c:chart>
+  <c:txPr>
+    <a:bodyPr/>
+    <a:lstStyle/>
+    <a:p>
+      <a:pPr>
+        <a:defRPr sz="1800"/>
+      </a:pPr>
+      <a:endParaRPr lang="en-US"/>
+    </a:p>
+  </c:txPr>
+  <c:externalData r:id="rId1">
+    <c:autoUpdate val="0"/>
+  </c:externalData>
+</c:chartSpace>
+</file>
+
+<file path=ppt/charts/chart3.xml><?xml version="1.0" encoding="utf-8"?>
+<c:chartSpace xmlns:c="http://schemas.openxmlformats.org/drawingml/2006/chart" xmlns:a="http://schemas.openxmlformats.org/drawingml/2006/main" xmlns:r="http://schemas.openxmlformats.org/officeDocument/2006/relationships">
+  <c:chart>
+    <c:autoTitleDeleted val="1"/>
+    <c:plotArea>
+      <c:pieChart>
+        <c:varyColors val="1"/>
+        <c:ser>
+          <c:idx val="0"/>
+          <c:order val="0"/>
+          <c:tx>
+            <c:strRef>
+              <c:f>Sheet1!$B$1</c:f>
+              <c:strCache>
+                <c:ptCount val="1"/>
+                <c:pt idx="0">
+                  <c:v>Market Share</c:v>
+                </c:pt>
+              </c:strCache>
+            </c:strRef>
+          </c:tx>
+          <c:cat>
+            <c:strRef>
+              <c:f>Sheet1!$A$2:$A$5</c:f>
+              <c:strCache>
+                <c:ptCount val="4"/>
+                <c:pt idx="0">
+                  <c:v>Conventional Plastics (PP, PET)</c:v>
+                </c:pt>
+                <c:pt idx="1">
+                  <c:v>Paper &amp; Cardboard</c:v>
+                </c:pt>
+                <c:pt idx="2">
+                  <c:v>Bioplastics (PLA, etc.)</c:v>
+                </c:pt>
+                <c:pt idx="3">
+                  <c:v>Other Alternatives</c:v>
+                </c:pt>
+              </c:strCache>
+            </c:strRef>
+          </c:cat>
+          <c:val>
+            <c:numRef>
+              <c:f>Sheet1!$B$2:$B$5</c:f>
+              <c:numCache>
+                <c:formatCode>General</c:formatCode>
+                <c:ptCount val="4"/>
+                <c:pt idx="0">
+                  <c:v>68</c:v>
+                </c:pt>
+                <c:pt idx="1">
+                  <c:v>18</c:v>
+                </c:pt>
+                <c:pt idx="2">
+                  <c:v>7</c:v>
+                </c:pt>
+                <c:pt idx="3">
+                  <c:v>7</c:v>
+                </c:pt>
+              </c:numCache>
+            </c:numRef>
+          </c:val>
+        </c:ser>
+        <c:dLbls>
+          <c:numFmt formatCode="0%" sourceLinked="0"/>
+          <c:showLegendKey val="0"/>
+          <c:showVal val="0"/>
+          <c:showCatName val="0"/>
+          <c:showSerName val="0"/>
+          <c:showPercent val="1"/>
+          <c:showBubbleSize val="0"/>
+          <c:showLeaderLines val="1"/>
+        </c:dLbls>
+      </c:pieChart>
+    </c:plotArea>
+    <c:legend>
+      <c:legendPos/>
+      <c:overlay val="0"/>
     </c:legend>
     <c:dispBlanksAs val="gap"/>
   </c:chart>
@@ -13286,6 +13384,351 @@
 </p:sld>
 </file>
 
+<file path=ppt/slides/slide8.xml><?xml version="1.0" encoding="utf-8"?>
+<p:sld xmlns:a="http://schemas.openxmlformats.org/drawingml/2006/main" xmlns:p="http://schemas.openxmlformats.org/presentationml/2006/main" xmlns:r="http://schemas.openxmlformats.org/officeDocument/2006/relationships">
+  <p:cSld>
+    <p:spTree>
+      <p:nvGrpSpPr>
+        <p:cNvPr id="1" name=""/>
+        <p:cNvGrpSpPr/>
+        <p:nvPr/>
+      </p:nvGrpSpPr>
+      <p:grpSpPr/>
+      <p:sp>
+        <p:nvSpPr>
+          <p:cNvPr id="2" name="Title 1"/>
+          <p:cNvSpPr>
+            <a:spLocks noGrp="1"/>
+          </p:cNvSpPr>
+          <p:nvPr>
+            <p:ph type="title"/>
+          </p:nvPr>
+        </p:nvSpPr>
+        <p:spPr/>
+        <p:txBody>
+          <a:bodyPr/>
+          <a:lstStyle/>
+          <a:p>
+            <a:r>
+              <a:rPr b="1" sz="3400">
+                <a:solidFill>
+                  <a:srgbClr val="18477A"/>
+                </a:solidFill>
+              </a:rPr>
+              <a:t>Material Market Share (CORE PART)</a:t>
+            </a:r>
+          </a:p>
+        </p:txBody>
+      </p:sp>
+      <p:graphicFrame>
+        <p:nvGraphicFramePr>
+          <p:cNvPr id="3" name="Chart 2"/>
+          <p:cNvGraphicFramePr>
+            <a:graphicFrameLocks noGrp="1"/>
+          </p:cNvGraphicFramePr>
+          <p:nvPr/>
+        </p:nvGraphicFramePr>
+        <p:xfrm>
+          <a:off x="457200" y="1280160"/>
+          <a:ext cx="5760720" cy="4389120"/>
+        </p:xfrm>
+        <a:graphic>
+          <a:graphicData uri="http://schemas.openxmlformats.org/drawingml/2006/chart">
+            <c:chart xmlns:c="http://schemas.openxmlformats.org/drawingml/2006/chart" r:id="rId2"/>
+          </a:graphicData>
+        </a:graphic>
+      </p:graphicFrame>
+      <p:graphicFrame>
+        <p:nvGraphicFramePr>
+          <p:cNvPr id="4" name="Table 3"/>
+          <p:cNvGraphicFramePr>
+            <a:graphicFrameLocks noGrp="1"/>
+          </p:cNvGraphicFramePr>
+          <p:nvPr/>
+        </p:nvGraphicFramePr>
+        <p:xfrm>
+          <a:off x="6355080" y="1325880"/>
+          <a:ext cx="5212080" cy="3063240"/>
+        </p:xfrm>
+        <a:graphic>
+          <a:graphicData uri="http://schemas.openxmlformats.org/drawingml/2006/table">
+            <a:tbl>
+              <a:tblPr firstRow="1" bandRow="1">
+                <a:tableStyleId>{5C22544A-7EE6-4342-B048-85BDC9FD1C3A}</a:tableStyleId>
+              </a:tblPr>
+              <a:tblGrid>
+                <a:gridCol w="3566160"/>
+                <a:gridCol w="1645920"/>
+              </a:tblGrid>
+              <a:tr h="612648">
+                <a:tc>
+                  <a:txBody>
+                    <a:bodyPr/>
+                    <a:lstStyle/>
+                    <a:p>
+                      <a:pPr algn="ctr"/>
+                      <a:r>
+                        <a:rPr b="1" sz="1200">
+                          <a:solidFill>
+                            <a:srgbClr val="FFFFFF"/>
+                          </a:solidFill>
+                        </a:rPr>
+                        <a:t>Material Type</a:t>
+                      </a:r>
+                    </a:p>
+                  </a:txBody>
+                  <a:tcPr>
+                    <a:solidFill>
+                      <a:srgbClr val="18477A"/>
+                    </a:solidFill>
+                  </a:tcPr>
+                </a:tc>
+                <a:tc>
+                  <a:txBody>
+                    <a:bodyPr/>
+                    <a:lstStyle/>
+                    <a:p>
+                      <a:pPr algn="ctr"/>
+                      <a:r>
+                        <a:rPr b="1" sz="1200">
+                          <a:solidFill>
+                            <a:srgbClr val="FFFFFF"/>
+                          </a:solidFill>
+                        </a:rPr>
+                        <a:t>Market Share (%)</a:t>
+                      </a:r>
+                    </a:p>
+                  </a:txBody>
+                  <a:tcPr>
+                    <a:solidFill>
+                      <a:srgbClr val="18477A"/>
+                    </a:solidFill>
+                  </a:tcPr>
+                </a:tc>
+              </a:tr>
+              <a:tr h="612648">
+                <a:tc>
+                  <a:txBody>
+                    <a:bodyPr/>
+                    <a:lstStyle/>
+                    <a:p>
+                      <a:pPr algn="l"/>
+                      <a:r>
+                        <a:rPr sz="1100">
+                          <a:solidFill>
+                            <a:srgbClr val="232323"/>
+                          </a:solidFill>
+                        </a:rPr>
+                        <a:t>Conventional Plastics (PP, PET)</a:t>
+                      </a:r>
+                    </a:p>
+                  </a:txBody>
+                  <a:tcPr/>
+                </a:tc>
+                <a:tc>
+                  <a:txBody>
+                    <a:bodyPr/>
+                    <a:lstStyle/>
+                    <a:p>
+                      <a:pPr algn="ctr"/>
+                      <a:r>
+                        <a:rPr sz="1100">
+                          <a:solidFill>
+                            <a:srgbClr val="232323"/>
+                          </a:solidFill>
+                        </a:rPr>
+                        <a:t>65–70%</a:t>
+                      </a:r>
+                    </a:p>
+                  </a:txBody>
+                  <a:tcPr/>
+                </a:tc>
+              </a:tr>
+              <a:tr h="612648">
+                <a:tc>
+                  <a:txBody>
+                    <a:bodyPr/>
+                    <a:lstStyle/>
+                    <a:p>
+                      <a:pPr algn="l"/>
+                      <a:r>
+                        <a:rPr sz="1100">
+                          <a:solidFill>
+                            <a:srgbClr val="232323"/>
+                          </a:solidFill>
+                        </a:rPr>
+                        <a:t>Paper &amp; Cardboard</a:t>
+                      </a:r>
+                    </a:p>
+                  </a:txBody>
+                  <a:tcPr>
+                    <a:solidFill>
+                      <a:srgbClr val="F3F7FC"/>
+                    </a:solidFill>
+                  </a:tcPr>
+                </a:tc>
+                <a:tc>
+                  <a:txBody>
+                    <a:bodyPr/>
+                    <a:lstStyle/>
+                    <a:p>
+                      <a:pPr algn="ctr"/>
+                      <a:r>
+                        <a:rPr sz="1100">
+                          <a:solidFill>
+                            <a:srgbClr val="232323"/>
+                          </a:solidFill>
+                        </a:rPr>
+                        <a:t>15–20%</a:t>
+                      </a:r>
+                    </a:p>
+                  </a:txBody>
+                  <a:tcPr>
+                    <a:solidFill>
+                      <a:srgbClr val="F3F7FC"/>
+                    </a:solidFill>
+                  </a:tcPr>
+                </a:tc>
+              </a:tr>
+              <a:tr h="612648">
+                <a:tc>
+                  <a:txBody>
+                    <a:bodyPr/>
+                    <a:lstStyle/>
+                    <a:p>
+                      <a:pPr algn="l"/>
+                      <a:r>
+                        <a:rPr sz="1100">
+                          <a:solidFill>
+                            <a:srgbClr val="232323"/>
+                          </a:solidFill>
+                        </a:rPr>
+                        <a:t>Bioplastics (PLA, etc.)</a:t>
+                      </a:r>
+                    </a:p>
+                  </a:txBody>
+                  <a:tcPr/>
+                </a:tc>
+                <a:tc>
+                  <a:txBody>
+                    <a:bodyPr/>
+                    <a:lstStyle/>
+                    <a:p>
+                      <a:pPr algn="ctr"/>
+                      <a:r>
+                        <a:rPr sz="1100">
+                          <a:solidFill>
+                            <a:srgbClr val="232323"/>
+                          </a:solidFill>
+                        </a:rPr>
+                        <a:t>5–8%</a:t>
+                      </a:r>
+                    </a:p>
+                  </a:txBody>
+                  <a:tcPr/>
+                </a:tc>
+              </a:tr>
+              <a:tr h="612648">
+                <a:tc>
+                  <a:txBody>
+                    <a:bodyPr/>
+                    <a:lstStyle/>
+                    <a:p>
+                      <a:pPr algn="l"/>
+                      <a:r>
+                        <a:rPr sz="1100">
+                          <a:solidFill>
+                            <a:srgbClr val="232323"/>
+                          </a:solidFill>
+                        </a:rPr>
+                        <a:t>Other Alternatives</a:t>
+                      </a:r>
+                    </a:p>
+                  </a:txBody>
+                  <a:tcPr>
+                    <a:solidFill>
+                      <a:srgbClr val="F3F7FC"/>
+                    </a:solidFill>
+                  </a:tcPr>
+                </a:tc>
+                <a:tc>
+                  <a:txBody>
+                    <a:bodyPr/>
+                    <a:lstStyle/>
+                    <a:p>
+                      <a:pPr algn="ctr"/>
+                      <a:r>
+                        <a:rPr sz="1100">
+                          <a:solidFill>
+                            <a:srgbClr val="232323"/>
+                          </a:solidFill>
+                        </a:rPr>
+                        <a:t>5–7%</a:t>
+                      </a:r>
+                    </a:p>
+                  </a:txBody>
+                  <a:tcPr>
+                    <a:solidFill>
+                      <a:srgbClr val="F3F7FC"/>
+                    </a:solidFill>
+                  </a:tcPr>
+                </a:tc>
+              </a:tr>
+            </a:tbl>
+          </a:graphicData>
+        </a:graphic>
+      </p:graphicFrame>
+      <p:sp>
+        <p:nvSpPr>
+          <p:cNvPr id="5" name="TextBox 4"/>
+          <p:cNvSpPr txBox="1"/>
+          <p:nvPr/>
+        </p:nvSpPr>
+        <p:spPr>
+          <a:xfrm>
+            <a:off x="6355080" y="4663440"/>
+            <a:ext cx="5212080" cy="1371600"/>
+          </a:xfrm>
+          <a:prstGeom prst="rect">
+            <a:avLst/>
+          </a:prstGeom>
+          <a:noFill/>
+        </p:spPr>
+        <p:txBody>
+          <a:bodyPr wrap="square">
+            <a:spAutoFit/>
+          </a:bodyPr>
+          <a:lstStyle/>
+          <a:p>
+            <a:r>
+              <a:rPr b="1" sz="1400">
+                <a:solidFill>
+                  <a:srgbClr val="18477A"/>
+                </a:solidFill>
+              </a:rPr>
+              <a:t>💡 Key Insight:</a:t>
+            </a:r>
+          </a:p>
+          <a:p>
+            <a:r>
+              <a:rPr sz="1200">
+                <a:solidFill>
+                  <a:srgbClr val="232323"/>
+                </a:solidFill>
+              </a:rPr>
+              <a:t>Bioplastics (PLA) represent a small but rapidly growing segment driven by sustainability regulations.</a:t>
+            </a:r>
+          </a:p>
+        </p:txBody>
+      </p:sp>
+    </p:spTree>
+  </p:cSld>
+  <p:clrMapOvr>
+    <a:masterClrMapping/>
+  </p:clrMapOvr>
+</p:sld>
+</file>
+
 <file path=ppt/theme/theme1.xml><?xml version="1.0" encoding="utf-8"?>
 <a:theme xmlns:a="http://schemas.openxmlformats.org/drawingml/2006/main" name="Office Theme">
   <a:themeElements>

</xml_diff>

<commit_message>
Refine market share slide with richer submission-ready detail
Agent-Logs-Url: https://github.com/aniket-kanani-3107/aniket-kanani-3107.github.io/sessions/3d760c13-60d7-43db-983e-6f7602ac8a6b

Co-authored-by: aniket-kanani-3107 <268387354+aniket-kanani-3107@users.noreply.github.com>
</commit_message>
<xml_diff>
--- a/Food-Packaging-Containers.pptx
+++ b/Food-Packaging-Containers.pptx
@@ -595,6 +595,135 @@
     </c:plotArea>
     <c:legend>
       <c:legendPos/>
+      <c:overlay val="0"/>
+    </c:legend>
+    <c:dispBlanksAs val="gap"/>
+  </c:chart>
+  <c:txPr>
+    <a:bodyPr/>
+    <a:lstStyle/>
+    <a:p>
+      <a:pPr>
+        <a:defRPr sz="1800"/>
+      </a:pPr>
+      <a:endParaRPr lang="en-US"/>
+    </a:p>
+  </c:txPr>
+  <c:externalData r:id="rId1">
+    <c:autoUpdate val="0"/>
+  </c:externalData>
+</c:chartSpace>
+</file>
+
+<file path=ppt/charts/chart4.xml><?xml version="1.0" encoding="utf-8"?>
+<c:chartSpace xmlns:c="http://schemas.openxmlformats.org/drawingml/2006/chart" xmlns:a="http://schemas.openxmlformats.org/drawingml/2006/main" xmlns:r="http://schemas.openxmlformats.org/officeDocument/2006/relationships">
+  <c:chart>
+    <c:autoTitleDeleted val="1"/>
+    <c:plotArea>
+      <c:pieChart>
+        <c:varyColors val="1"/>
+        <c:ser>
+          <c:idx val="0"/>
+          <c:order val="0"/>
+          <c:tx>
+            <c:strRef>
+              <c:f>Sheet1!$B$1</c:f>
+              <c:strCache>
+                <c:ptCount val="1"/>
+                <c:pt idx="0">
+                  <c:v>Share</c:v>
+                </c:pt>
+              </c:strCache>
+            </c:strRef>
+          </c:tx>
+          <c:dPt>
+            <c:idx val="0"/>
+            <c:spPr>
+              <a:solidFill>
+                <a:srgbClr val="2674BA"/>
+              </a:solidFill>
+            </c:spPr>
+          </c:dPt>
+          <c:dPt>
+            <c:idx val="1"/>
+            <c:spPr>
+              <a:solidFill>
+                <a:srgbClr val="68A655"/>
+              </a:solidFill>
+            </c:spPr>
+          </c:dPt>
+          <c:dPt>
+            <c:idx val="2"/>
+            <c:spPr>
+              <a:solidFill>
+                <a:srgbClr val="F59E0B"/>
+              </a:solidFill>
+            </c:spPr>
+          </c:dPt>
+          <c:dPt>
+            <c:idx val="3"/>
+            <c:spPr>
+              <a:solidFill>
+                <a:srgbClr val="7C3AED"/>
+              </a:solidFill>
+            </c:spPr>
+          </c:dPt>
+          <c:cat>
+            <c:strRef>
+              <c:f>Sheet1!$A$2:$A$5</c:f>
+              <c:strCache>
+                <c:ptCount val="4"/>
+                <c:pt idx="0">
+                  <c:v>Conventional Plastics (PP, PET)</c:v>
+                </c:pt>
+                <c:pt idx="1">
+                  <c:v>Paper &amp; Cardboard</c:v>
+                </c:pt>
+                <c:pt idx="2">
+                  <c:v>Bioplastics (PLA, etc.)</c:v>
+                </c:pt>
+                <c:pt idx="3">
+                  <c:v>Other Alternatives</c:v>
+                </c:pt>
+              </c:strCache>
+            </c:strRef>
+          </c:cat>
+          <c:val>
+            <c:numRef>
+              <c:f>Sheet1!$B$2:$B$5</c:f>
+              <c:numCache>
+                <c:formatCode>General</c:formatCode>
+                <c:ptCount val="4"/>
+                <c:pt idx="0">
+                  <c:v>68</c:v>
+                </c:pt>
+                <c:pt idx="1">
+                  <c:v>18</c:v>
+                </c:pt>
+                <c:pt idx="2">
+                  <c:v>7</c:v>
+                </c:pt>
+                <c:pt idx="3">
+                  <c:v>7</c:v>
+                </c:pt>
+              </c:numCache>
+            </c:numRef>
+          </c:val>
+        </c:ser>
+        <c:dLbls>
+          <c:numFmt formatCode="0%" sourceLinked="0"/>
+          <c:showLegendKey val="0"/>
+          <c:showVal val="0"/>
+          <c:showCatName val="0"/>
+          <c:showSerName val="0"/>
+          <c:showPercent val="1"/>
+          <c:showBubbleSize val="0"/>
+          <c:showLeaderLines val="1"/>
+        </c:dLbls>
+      </c:pieChart>
+    </c:plotArea>
+    <c:legend>
+      <c:legendPos val="b"/>
       <c:overlay val="0"/>
     </c:legend>
     <c:dispBlanksAs val="gap"/>
@@ -13412,7 +13541,7 @@
             <a:r>
               <a:rPr b="1" sz="3400">
                 <a:solidFill>
-                  <a:srgbClr val="18477A"/>
+                  <a:srgbClr val="172B4D"/>
                 </a:solidFill>
               </a:rPr>
               <a:t>Material Market Share (CORE PART)</a:t>
@@ -13420,35 +13549,68 @@
           </a:p>
         </p:txBody>
       </p:sp>
+      <p:sp>
+        <p:nvSpPr>
+          <p:cNvPr id="3" name="TextBox 2"/>
+          <p:cNvSpPr txBox="1"/>
+          <p:nvPr/>
+        </p:nvSpPr>
+        <p:spPr>
+          <a:xfrm>
+            <a:off x="502920" y="914400"/>
+            <a:ext cx="11064240" cy="411480"/>
+          </a:xfrm>
+          <a:prstGeom prst="rect">
+            <a:avLst/>
+          </a:prstGeom>
+          <a:noFill/>
+        </p:spPr>
+        <p:txBody>
+          <a:bodyPr wrap="square">
+            <a:spAutoFit/>
+          </a:bodyPr>
+          <a:lstStyle/>
+          <a:p>
+            <a:r>
+              <a:rPr sz="1500" b="1">
+                <a:solidFill>
+                  <a:srgbClr val="363636"/>
+                </a:solidFill>
+              </a:rPr>
+              <a:t>Global Food Packaging Material Split (Indicative, 2025)</a:t>
+            </a:r>
+          </a:p>
+        </p:txBody>
+      </p:sp>
       <p:graphicFrame>
         <p:nvGraphicFramePr>
-          <p:cNvPr id="3" name="Chart 2"/>
+          <p:cNvPr id="4" name="Chart 3"/>
           <p:cNvGraphicFramePr>
             <a:graphicFrameLocks noGrp="1"/>
           </p:cNvGraphicFramePr>
           <p:nvPr/>
         </p:nvGraphicFramePr>
         <p:xfrm>
-          <a:off x="457200" y="1280160"/>
-          <a:ext cx="5760720" cy="4389120"/>
+          <a:off x="502920" y="1325880"/>
+          <a:ext cx="5394960" cy="3931920"/>
         </p:xfrm>
         <a:graphic>
           <a:graphicData uri="http://schemas.openxmlformats.org/drawingml/2006/chart">
-            <c:chart xmlns:c="http://schemas.openxmlformats.org/drawingml/2006/chart" r:id="rId2"/>
+            <c:chart xmlns:c="http://schemas.openxmlformats.org/drawingml/2006/chart" r:id="rId3"/>
           </a:graphicData>
         </a:graphic>
       </p:graphicFrame>
       <p:graphicFrame>
         <p:nvGraphicFramePr>
-          <p:cNvPr id="4" name="Table 3"/>
+          <p:cNvPr id="5" name="Table 4"/>
           <p:cNvGraphicFramePr>
             <a:graphicFrameLocks noGrp="1"/>
           </p:cNvGraphicFramePr>
           <p:nvPr/>
         </p:nvGraphicFramePr>
         <p:xfrm>
-          <a:off x="6355080" y="1325880"/>
-          <a:ext cx="5212080" cy="3063240"/>
+          <a:off x="5989320" y="1325880"/>
+          <a:ext cx="5989320" cy="3429000"/>
         </p:xfrm>
         <a:graphic>
           <a:graphicData uri="http://schemas.openxmlformats.org/drawingml/2006/table">
@@ -13457,10 +13619,11 @@
                 <a:tableStyleId>{5C22544A-7EE6-4342-B048-85BDC9FD1C3A}</a:tableStyleId>
               </a:tblPr>
               <a:tblGrid>
-                <a:gridCol w="3566160"/>
-                <a:gridCol w="1645920"/>
+                <a:gridCol w="2423160"/>
+                <a:gridCol w="1051560"/>
+                <a:gridCol w="2514600"/>
               </a:tblGrid>
-              <a:tr h="612648">
+              <a:tr h="685800">
                 <a:tc>
                   <a:txBody>
                     <a:bodyPr/>
@@ -13468,7 +13631,7 @@
                     <a:p>
                       <a:pPr algn="ctr"/>
                       <a:r>
-                        <a:rPr b="1" sz="1200">
+                        <a:rPr b="1" sz="1100">
                           <a:solidFill>
                             <a:srgbClr val="FFFFFF"/>
                           </a:solidFill>
@@ -13479,7 +13642,7 @@
                   </a:txBody>
                   <a:tcPr>
                     <a:solidFill>
-                      <a:srgbClr val="18477A"/>
+                      <a:srgbClr val="172B4D"/>
                     </a:solidFill>
                   </a:tcPr>
                 </a:tc>
@@ -13490,23 +13653,45 @@
                     <a:p>
                       <a:pPr algn="ctr"/>
                       <a:r>
-                        <a:rPr b="1" sz="1200">
+                        <a:rPr b="1" sz="1100">
                           <a:solidFill>
                             <a:srgbClr val="FFFFFF"/>
                           </a:solidFill>
                         </a:rPr>
-                        <a:t>Market Share (%)</a:t>
+                        <a:t>Share (%)</a:t>
                       </a:r>
                     </a:p>
                   </a:txBody>
                   <a:tcPr>
                     <a:solidFill>
-                      <a:srgbClr val="18477A"/>
+                      <a:srgbClr val="172B4D"/>
+                    </a:solidFill>
+                  </a:tcPr>
+                </a:tc>
+                <a:tc>
+                  <a:txBody>
+                    <a:bodyPr/>
+                    <a:lstStyle/>
+                    <a:p>
+                      <a:pPr algn="ctr"/>
+                      <a:r>
+                        <a:rPr b="1" sz="1100">
+                          <a:solidFill>
+                            <a:srgbClr val="FFFFFF"/>
+                          </a:solidFill>
+                        </a:rPr>
+                        <a:t>Market context</a:t>
+                      </a:r>
+                    </a:p>
+                  </a:txBody>
+                  <a:tcPr>
+                    <a:solidFill>
+                      <a:srgbClr val="172B4D"/>
                     </a:solidFill>
                   </a:tcPr>
                 </a:tc>
               </a:tr>
-              <a:tr h="612648">
+              <a:tr h="685800">
                 <a:tc>
                   <a:txBody>
                     <a:bodyPr/>
@@ -13514,9 +13699,9 @@
                     <a:p>
                       <a:pPr algn="l"/>
                       <a:r>
-                        <a:rPr sz="1100">
+                        <a:rPr sz="950">
                           <a:solidFill>
-                            <a:srgbClr val="232323"/>
+                            <a:srgbClr val="282828"/>
                           </a:solidFill>
                         </a:rPr>
                         <a:t>Conventional Plastics (PP, PET)</a:t>
@@ -13532,9 +13717,9 @@
                     <a:p>
                       <a:pPr algn="ctr"/>
                       <a:r>
-                        <a:rPr sz="1100">
+                        <a:rPr sz="950">
                           <a:solidFill>
-                            <a:srgbClr val="232323"/>
+                            <a:srgbClr val="282828"/>
                           </a:solidFill>
                         </a:rPr>
                         <a:t>65–70%</a:t>
@@ -13543,8 +13728,6 @@
                   </a:txBody>
                   <a:tcPr/>
                 </a:tc>
-              </a:tr>
-              <a:tr h="612648">
                 <a:tc>
                   <a:txBody>
                     <a:bodyPr/>
@@ -13552,9 +13735,29 @@
                     <a:p>
                       <a:pPr algn="l"/>
                       <a:r>
-                        <a:rPr sz="1100">
+                        <a:rPr sz="950">
                           <a:solidFill>
-                            <a:srgbClr val="232323"/>
+                            <a:srgbClr val="282828"/>
+                          </a:solidFill>
+                        </a:rPr>
+                        <a:t>Dominant due to low cost, strong barrier properties, and scale.</a:t>
+                      </a:r>
+                    </a:p>
+                  </a:txBody>
+                  <a:tcPr/>
+                </a:tc>
+              </a:tr>
+              <a:tr h="685800">
+                <a:tc>
+                  <a:txBody>
+                    <a:bodyPr/>
+                    <a:lstStyle/>
+                    <a:p>
+                      <a:pPr algn="l"/>
+                      <a:r>
+                        <a:rPr sz="950">
+                          <a:solidFill>
+                            <a:srgbClr val="282828"/>
                           </a:solidFill>
                         </a:rPr>
                         <a:t>Paper &amp; Cardboard</a:t>
@@ -13563,7 +13766,7 @@
                   </a:txBody>
                   <a:tcPr>
                     <a:solidFill>
-                      <a:srgbClr val="F3F7FC"/>
+                      <a:srgbClr val="F2F6FC"/>
                     </a:solidFill>
                   </a:tcPr>
                 </a:tc>
@@ -13574,9 +13777,9 @@
                     <a:p>
                       <a:pPr algn="ctr"/>
                       <a:r>
-                        <a:rPr sz="1100">
+                        <a:rPr sz="950">
                           <a:solidFill>
-                            <a:srgbClr val="232323"/>
+                            <a:srgbClr val="282828"/>
                           </a:solidFill>
                         </a:rPr>
                         <a:t>15–20%</a:t>
@@ -13585,12 +13788,10 @@
                   </a:txBody>
                   <a:tcPr>
                     <a:solidFill>
-                      <a:srgbClr val="F3F7FC"/>
+                      <a:srgbClr val="F2F6FC"/>
                     </a:solidFill>
                   </a:tcPr>
                 </a:tc>
-              </a:tr>
-              <a:tr h="612648">
                 <a:tc>
                   <a:txBody>
                     <a:bodyPr/>
@@ -13598,9 +13799,33 @@
                     <a:p>
                       <a:pPr algn="l"/>
                       <a:r>
-                        <a:rPr sz="1100">
+                        <a:rPr sz="950">
                           <a:solidFill>
-                            <a:srgbClr val="232323"/>
+                            <a:srgbClr val="282828"/>
+                          </a:solidFill>
+                        </a:rPr>
+                        <a:t>Growing in takeout wraps, cups, sleeves, and secondary packs.</a:t>
+                      </a:r>
+                    </a:p>
+                  </a:txBody>
+                  <a:tcPr>
+                    <a:solidFill>
+                      <a:srgbClr val="F2F6FC"/>
+                    </a:solidFill>
+                  </a:tcPr>
+                </a:tc>
+              </a:tr>
+              <a:tr h="685800">
+                <a:tc>
+                  <a:txBody>
+                    <a:bodyPr/>
+                    <a:lstStyle/>
+                    <a:p>
+                      <a:pPr algn="l"/>
+                      <a:r>
+                        <a:rPr sz="950">
+                          <a:solidFill>
+                            <a:srgbClr val="282828"/>
                           </a:solidFill>
                         </a:rPr>
                         <a:t>Bioplastics (PLA, etc.)</a:t>
@@ -13616,9 +13841,9 @@
                     <a:p>
                       <a:pPr algn="ctr"/>
                       <a:r>
-                        <a:rPr sz="1100">
+                        <a:rPr sz="950">
                           <a:solidFill>
-                            <a:srgbClr val="232323"/>
+                            <a:srgbClr val="282828"/>
                           </a:solidFill>
                         </a:rPr>
                         <a:t>5–8%</a:t>
@@ -13627,8 +13852,6 @@
                   </a:txBody>
                   <a:tcPr/>
                 </a:tc>
-              </a:tr>
-              <a:tr h="612648">
                 <a:tc>
                   <a:txBody>
                     <a:bodyPr/>
@@ -13636,9 +13859,29 @@
                     <a:p>
                       <a:pPr algn="l"/>
                       <a:r>
-                        <a:rPr sz="1100">
+                        <a:rPr sz="950">
                           <a:solidFill>
-                            <a:srgbClr val="232323"/>
+                            <a:srgbClr val="282828"/>
+                          </a:solidFill>
+                        </a:rPr>
+                        <a:t>Small base but fastest growth in compostable packaging formats.</a:t>
+                      </a:r>
+                    </a:p>
+                  </a:txBody>
+                  <a:tcPr/>
+                </a:tc>
+              </a:tr>
+              <a:tr h="685800">
+                <a:tc>
+                  <a:txBody>
+                    <a:bodyPr/>
+                    <a:lstStyle/>
+                    <a:p>
+                      <a:pPr algn="l"/>
+                      <a:r>
+                        <a:rPr sz="950">
+                          <a:solidFill>
+                            <a:srgbClr val="282828"/>
                           </a:solidFill>
                         </a:rPr>
                         <a:t>Other Alternatives</a:t>
@@ -13647,7 +13890,7 @@
                   </a:txBody>
                   <a:tcPr>
                     <a:solidFill>
-                      <a:srgbClr val="F3F7FC"/>
+                      <a:srgbClr val="F2F6FC"/>
                     </a:solidFill>
                   </a:tcPr>
                 </a:tc>
@@ -13658,9 +13901,9 @@
                     <a:p>
                       <a:pPr algn="ctr"/>
                       <a:r>
-                        <a:rPr sz="1100">
+                        <a:rPr sz="950">
                           <a:solidFill>
-                            <a:srgbClr val="232323"/>
+                            <a:srgbClr val="282828"/>
                           </a:solidFill>
                         </a:rPr>
                         <a:t>5–7%</a:t>
@@ -13669,7 +13912,29 @@
                   </a:txBody>
                   <a:tcPr>
                     <a:solidFill>
-                      <a:srgbClr val="F3F7FC"/>
+                      <a:srgbClr val="F2F6FC"/>
+                    </a:solidFill>
+                  </a:tcPr>
+                </a:tc>
+                <a:tc>
+                  <a:txBody>
+                    <a:bodyPr/>
+                    <a:lstStyle/>
+                    <a:p>
+                      <a:pPr algn="l"/>
+                      <a:r>
+                        <a:rPr sz="950">
+                          <a:solidFill>
+                            <a:srgbClr val="282828"/>
+                          </a:solidFill>
+                        </a:rPr>
+                        <a:t>Includes molded fiber, bagasse, aluminum, and glass niches.</a:t>
+                      </a:r>
+                    </a:p>
+                  </a:txBody>
+                  <a:tcPr>
+                    <a:solidFill>
+                      <a:srgbClr val="F2F6FC"/>
                     </a:solidFill>
                   </a:tcPr>
                 </a:tc>
@@ -13680,14 +13945,14 @@
       </p:graphicFrame>
       <p:sp>
         <p:nvSpPr>
-          <p:cNvPr id="5" name="TextBox 4"/>
+          <p:cNvPr id="6" name="TextBox 5"/>
           <p:cNvSpPr txBox="1"/>
           <p:nvPr/>
         </p:nvSpPr>
         <p:spPr>
           <a:xfrm>
-            <a:off x="6355080" y="4663440"/>
-            <a:ext cx="5212080" cy="1371600"/>
+            <a:off x="502920" y="5394960"/>
+            <a:ext cx="11475720" cy="1143000"/>
           </a:xfrm>
           <a:prstGeom prst="rect">
             <a:avLst/>
@@ -13701,22 +13966,55 @@
           <a:lstStyle/>
           <a:p>
             <a:r>
-              <a:rPr b="1" sz="1400">
-                <a:solidFill>
-                  <a:srgbClr val="18477A"/>
+              <a:rPr b="1" sz="1200">
+                <a:solidFill>
+                  <a:srgbClr val="172B4D"/>
                 </a:solidFill>
               </a:rPr>
-              <a:t>💡 Key Insight:</a:t>
-            </a:r>
-          </a:p>
-          <a:p>
-            <a:r>
-              <a:rPr sz="1200">
-                <a:solidFill>
-                  <a:srgbClr val="232323"/>
+              <a:t>💡 Key Insight: Bioplastics (PLA) are still a minority share, but expected to grow 2–3x faster than conventional plastics as regulations and ESG targets tighten.</a:t>
+            </a:r>
+          </a:p>
+          <a:p>
+            <a:r>
+              <a:rPr sz="1100">
+                <a:solidFill>
+                  <a:srgbClr val="373737"/>
                 </a:solidFill>
               </a:rPr>
-              <a:t>Bioplastics (PLA) represent a small but rapidly growing segment driven by sustainability regulations.</a:t>
+              <a:t>Primary growth drivers: single-use plastic restrictions, EPR/packaging compliance, and brand-level sustainability commitments.</a:t>
+            </a:r>
+          </a:p>
+        </p:txBody>
+      </p:sp>
+      <p:sp>
+        <p:nvSpPr>
+          <p:cNvPr id="7" name="TextBox 6"/>
+          <p:cNvSpPr txBox="1"/>
+          <p:nvPr/>
+        </p:nvSpPr>
+        <p:spPr>
+          <a:xfrm>
+            <a:off x="502920" y="6446520"/>
+            <a:ext cx="11475720" cy="228600"/>
+          </a:xfrm>
+          <a:prstGeom prst="rect">
+            <a:avLst/>
+          </a:prstGeom>
+          <a:noFill/>
+        </p:spPr>
+        <p:txBody>
+          <a:bodyPr wrap="none">
+            <a:spAutoFit/>
+          </a:bodyPr>
+          <a:lstStyle/>
+          <a:p>
+            <a:r>
+              <a:rPr sz="800">
+                <a:solidFill>
+                  <a:srgbClr val="6E6E6E"/>
+                </a:solidFill>
+              </a:rPr>
+              <a:t>Source note: Indicative synthesis from recent industry analyses (2024–2026) on global food-packaging material mix.</a:t>
             </a:r>
           </a:p>
         </p:txBody>

</xml_diff>

<commit_message>
Add Design Cost Analysis slide comparing PLA vs Biodegradable PPE design costs
Agent-Logs-Url: https://github.com/aniket-kanani-3107/aniket-kanani-3107.github.io/sessions/84fa9880-12c2-4a37-925c-0a4801180f71

Co-authored-by: aniket-kanani-3107 <268387354+aniket-kanani-3107@users.noreply.github.com>
</commit_message>
<xml_diff>
--- a/Food-Packaging-Containers.pptx
+++ b/Food-Packaging-Containers.pptx
@@ -13,6 +13,7 @@
     <p:sldId id="261" r:id="rId12"/>
     <p:sldId id="262" r:id="rId13"/>
     <p:sldId id="263" r:id="rId14"/>
+    <p:sldId id="264" r:id="rId15"/>
   </p:sldIdLst>
   <p:sldSz cx="12188952" cy="6858000" type="screen4x3"/>
   <p:notesSz cx="6858000" cy="9144000"/>
@@ -14027,6 +14028,1013 @@
 </p:sld>
 </file>
 
+<file path=ppt/slides/slide9.xml><?xml version="1.0" encoding="utf-8"?>
+<p:sld xmlns:a="http://schemas.openxmlformats.org/drawingml/2006/main" xmlns:p="http://schemas.openxmlformats.org/presentationml/2006/main" xmlns:r="http://schemas.openxmlformats.org/officeDocument/2006/relationships">
+  <p:cSld>
+    <p:spTree>
+      <p:nvGrpSpPr>
+        <p:cNvPr id="1" name=""/>
+        <p:cNvGrpSpPr/>
+        <p:nvPr/>
+      </p:nvGrpSpPr>
+      <p:grpSpPr/>
+      <p:sp>
+        <p:nvSpPr>
+          <p:cNvPr id="2" name="Rectangle 1"/>
+          <p:cNvSpPr/>
+          <p:nvPr/>
+        </p:nvSpPr>
+        <p:spPr>
+          <a:xfrm>
+            <a:off x="0" y="0"/>
+            <a:ext cx="12188952" cy="6858000"/>
+          </a:xfrm>
+          <a:prstGeom prst="rect">
+            <a:avLst/>
+          </a:prstGeom>
+          <a:solidFill>
+            <a:srgbClr val="F5F7FA"/>
+          </a:solidFill>
+          <a:ln>
+            <a:noFill/>
+          </a:ln>
+        </p:spPr>
+        <p:style>
+          <a:lnRef idx="1">
+            <a:schemeClr val="accent1"/>
+          </a:lnRef>
+          <a:fillRef idx="3">
+            <a:schemeClr val="accent1"/>
+          </a:fillRef>
+          <a:effectRef idx="2">
+            <a:schemeClr val="accent1"/>
+          </a:effectRef>
+          <a:fontRef idx="minor">
+            <a:schemeClr val="lt1"/>
+          </a:fontRef>
+        </p:style>
+        <p:txBody>
+          <a:bodyPr rtlCol="0" anchor="ctr"/>
+          <a:lstStyle/>
+          <a:p>
+            <a:pPr algn="ctr"/>
+          </a:p>
+        </p:txBody>
+      </p:sp>
+      <p:sp>
+        <p:nvSpPr>
+          <p:cNvPr id="3" name="Rectangle 2"/>
+          <p:cNvSpPr/>
+          <p:nvPr/>
+        </p:nvSpPr>
+        <p:spPr>
+          <a:xfrm>
+            <a:off x="0" y="0"/>
+            <a:ext cx="12188952" cy="109728"/>
+          </a:xfrm>
+          <a:prstGeom prst="rect">
+            <a:avLst/>
+          </a:prstGeom>
+          <a:solidFill>
+            <a:srgbClr val="172B4D"/>
+          </a:solidFill>
+          <a:ln>
+            <a:noFill/>
+          </a:ln>
+        </p:spPr>
+        <p:style>
+          <a:lnRef idx="1">
+            <a:schemeClr val="accent1"/>
+          </a:lnRef>
+          <a:fillRef idx="3">
+            <a:schemeClr val="accent1"/>
+          </a:fillRef>
+          <a:effectRef idx="2">
+            <a:schemeClr val="accent1"/>
+          </a:effectRef>
+          <a:fontRef idx="minor">
+            <a:schemeClr val="lt1"/>
+          </a:fontRef>
+        </p:style>
+        <p:txBody>
+          <a:bodyPr rtlCol="0" anchor="ctr"/>
+          <a:lstStyle/>
+          <a:p>
+            <a:pPr algn="ctr"/>
+          </a:p>
+        </p:txBody>
+      </p:sp>
+      <p:sp>
+        <p:nvSpPr>
+          <p:cNvPr id="4" name="TextBox 3"/>
+          <p:cNvSpPr txBox="1"/>
+          <p:nvPr/>
+        </p:nvSpPr>
+        <p:spPr>
+          <a:xfrm>
+            <a:off x="502920" y="164592"/>
+            <a:ext cx="11155680" cy="640080"/>
+          </a:xfrm>
+          <a:prstGeom prst="rect">
+            <a:avLst/>
+          </a:prstGeom>
+          <a:noFill/>
+        </p:spPr>
+        <p:txBody>
+          <a:bodyPr wrap="none">
+            <a:spAutoFit/>
+          </a:bodyPr>
+          <a:lstStyle/>
+          <a:p>
+            <a:pPr algn="ctr"/>
+            <a:r>
+              <a:rPr b="1" sz="3000">
+                <a:solidFill>
+                  <a:srgbClr val="172B4D"/>
+                </a:solidFill>
+              </a:rPr>
+              <a:t>Design Cost Analysis: PLA vs. Biodegradable PPE</a:t>
+            </a:r>
+          </a:p>
+        </p:txBody>
+      </p:sp>
+      <p:sp>
+        <p:nvSpPr>
+          <p:cNvPr id="5" name="TextBox 4"/>
+          <p:cNvSpPr txBox="1"/>
+          <p:nvPr/>
+        </p:nvSpPr>
+        <p:spPr>
+          <a:xfrm>
+            <a:off x="502920" y="841248"/>
+            <a:ext cx="11155680" cy="292608"/>
+          </a:xfrm>
+          <a:prstGeom prst="rect">
+            <a:avLst/>
+          </a:prstGeom>
+          <a:noFill/>
+        </p:spPr>
+        <p:txBody>
+          <a:bodyPr wrap="none">
+            <a:spAutoFit/>
+          </a:bodyPr>
+          <a:lstStyle/>
+          <a:p>
+            <a:pPr algn="ctr"/>
+            <a:r>
+              <a:rPr sz="1100" i="1">
+                <a:solidFill>
+                  <a:srgbClr val="5A5A5A"/>
+                </a:solidFill>
+              </a:rPr>
+              <a:t>Scope: Design-phase costs only  ·  Excludes raw-material procurement, production tooling wear, and manufacturing overheads</a:t>
+            </a:r>
+          </a:p>
+        </p:txBody>
+      </p:sp>
+      <p:graphicFrame>
+        <p:nvGraphicFramePr>
+          <p:cNvPr id="6" name="Table 5"/>
+          <p:cNvGraphicFramePr>
+            <a:graphicFrameLocks noGrp="1"/>
+          </p:cNvGraphicFramePr>
+          <p:nvPr/>
+        </p:nvGraphicFramePr>
+        <p:xfrm>
+          <a:off x="502920" y="1170432"/>
+          <a:ext cx="11155680" cy="4663440"/>
+        </p:xfrm>
+        <a:graphic>
+          <a:graphicData uri="http://schemas.openxmlformats.org/drawingml/2006/table">
+            <a:tbl>
+              <a:tblPr firstRow="1" bandRow="1">
+                <a:tableStyleId>{5C22544A-7EE6-4342-B048-85BDC9FD1C3A}</a:tableStyleId>
+              </a:tblPr>
+              <a:tblGrid>
+                <a:gridCol w="5303520"/>
+                <a:gridCol w="2926080"/>
+                <a:gridCol w="2926080"/>
+              </a:tblGrid>
+              <a:tr h="466344">
+                <a:tc>
+                  <a:txBody>
+                    <a:bodyPr wrap="square"/>
+                    <a:lstStyle/>
+                    <a:p>
+                      <a:pPr algn="ctr"/>
+                      <a:r>
+                        <a:rPr sz="1100" b="1" i="0">
+                          <a:solidFill>
+                            <a:srgbClr val="FFFFFF"/>
+                          </a:solidFill>
+                        </a:rPr>
+                        <a:t>Design Cost Component</a:t>
+                      </a:r>
+                    </a:p>
+                  </a:txBody>
+                  <a:tcPr>
+                    <a:solidFill>
+                      <a:srgbClr val="172B4D"/>
+                    </a:solidFill>
+                  </a:tcPr>
+                </a:tc>
+                <a:tc>
+                  <a:txBody>
+                    <a:bodyPr wrap="square"/>
+                    <a:lstStyle/>
+                    <a:p>
+                      <a:pPr algn="ctr"/>
+                      <a:r>
+                        <a:rPr sz="1100" b="1" i="0">
+                          <a:solidFill>
+                            <a:srgbClr val="FFFFFF"/>
+                          </a:solidFill>
+                        </a:rPr>
+                        <a:t>PLA (Thermoformed)</a:t>
+                      </a:r>
+                    </a:p>
+                  </a:txBody>
+                  <a:tcPr>
+                    <a:solidFill>
+                      <a:srgbClr val="172B4D"/>
+                    </a:solidFill>
+                  </a:tcPr>
+                </a:tc>
+                <a:tc>
+                  <a:txBody>
+                    <a:bodyPr wrap="square"/>
+                    <a:lstStyle/>
+                    <a:p>
+                      <a:pPr algn="ctr"/>
+                      <a:r>
+                        <a:rPr sz="1100" b="1" i="0">
+                          <a:solidFill>
+                            <a:srgbClr val="FFFFFF"/>
+                          </a:solidFill>
+                        </a:rPr>
+                        <a:t>Biodegradable PPE
+(Injection Moulded)</a:t>
+                      </a:r>
+                    </a:p>
+                  </a:txBody>
+                  <a:tcPr>
+                    <a:solidFill>
+                      <a:srgbClr val="172B4D"/>
+                    </a:solidFill>
+                  </a:tcPr>
+                </a:tc>
+              </a:tr>
+              <a:tr h="466344">
+                <a:tc>
+                  <a:txBody>
+                    <a:bodyPr wrap="square"/>
+                    <a:lstStyle/>
+                    <a:p>
+                      <a:pPr algn="l"/>
+                      <a:r>
+                        <a:rPr sz="1000" b="0" i="0">
+                          <a:solidFill>
+                            <a:srgbClr val="282828"/>
+                          </a:solidFill>
+                        </a:rPr>
+                        <a:t>CAD / 3D Modelling
+(~20 hrs PLA  /  ~28 hrs PPE  ×  €45/hr)</a:t>
+                      </a:r>
+                    </a:p>
+                  </a:txBody>
+                  <a:tcPr>
+                    <a:solidFill>
+                      <a:srgbClr val="FFFFFF"/>
+                    </a:solidFill>
+                  </a:tcPr>
+                </a:tc>
+                <a:tc>
+                  <a:txBody>
+                    <a:bodyPr wrap="square"/>
+                    <a:lstStyle/>
+                    <a:p>
+                      <a:pPr algn="ctr"/>
+                      <a:r>
+                        <a:rPr sz="1000" b="0" i="0">
+                          <a:solidFill>
+                            <a:srgbClr val="1A73E8"/>
+                          </a:solidFill>
+                        </a:rPr>
+                        <a:t>€  900</a:t>
+                      </a:r>
+                    </a:p>
+                  </a:txBody>
+                  <a:tcPr>
+                    <a:solidFill>
+                      <a:srgbClr val="FFFFFF"/>
+                    </a:solidFill>
+                  </a:tcPr>
+                </a:tc>
+                <a:tc>
+                  <a:txBody>
+                    <a:bodyPr wrap="square"/>
+                    <a:lstStyle/>
+                    <a:p>
+                      <a:pPr algn="ctr"/>
+                      <a:r>
+                        <a:rPr sz="1000" b="0" i="0">
+                          <a:solidFill>
+                            <a:srgbClr val="34A853"/>
+                          </a:solidFill>
+                        </a:rPr>
+                        <a:t>€ 1,260</a:t>
+                      </a:r>
+                    </a:p>
+                  </a:txBody>
+                  <a:tcPr>
+                    <a:solidFill>
+                      <a:srgbClr val="FFFFFF"/>
+                    </a:solidFill>
+                  </a:tcPr>
+                </a:tc>
+              </a:tr>
+              <a:tr h="466344">
+                <a:tc>
+                  <a:txBody>
+                    <a:bodyPr wrap="square"/>
+                    <a:lstStyle/>
+                    <a:p>
+                      <a:pPr algn="l"/>
+                      <a:r>
+                        <a:rPr sz="1000" b="0" i="0">
+                          <a:solidFill>
+                            <a:srgbClr val="282828"/>
+                          </a:solidFill>
+                        </a:rPr>
+                        <a:t>Design Software License
+(SolidWorks / Fusion 360 — prorated per project)</a:t>
+                      </a:r>
+                    </a:p>
+                  </a:txBody>
+                  <a:tcPr>
+                    <a:solidFill>
+                      <a:srgbClr val="EAEFF8"/>
+                    </a:solidFill>
+                  </a:tcPr>
+                </a:tc>
+                <a:tc>
+                  <a:txBody>
+                    <a:bodyPr wrap="square"/>
+                    <a:lstStyle/>
+                    <a:p>
+                      <a:pPr algn="ctr"/>
+                      <a:r>
+                        <a:rPr sz="1000" b="0" i="0">
+                          <a:solidFill>
+                            <a:srgbClr val="1A73E8"/>
+                          </a:solidFill>
+                        </a:rPr>
+                        <a:t>€  350</a:t>
+                      </a:r>
+                    </a:p>
+                  </a:txBody>
+                  <a:tcPr>
+                    <a:solidFill>
+                      <a:srgbClr val="EAEFF8"/>
+                    </a:solidFill>
+                  </a:tcPr>
+                </a:tc>
+                <a:tc>
+                  <a:txBody>
+                    <a:bodyPr wrap="square"/>
+                    <a:lstStyle/>
+                    <a:p>
+                      <a:pPr algn="ctr"/>
+                      <a:r>
+                        <a:rPr sz="1000" b="0" i="0">
+                          <a:solidFill>
+                            <a:srgbClr val="34A853"/>
+                          </a:solidFill>
+                        </a:rPr>
+                        <a:t>€    350</a:t>
+                      </a:r>
+                    </a:p>
+                  </a:txBody>
+                  <a:tcPr>
+                    <a:solidFill>
+                      <a:srgbClr val="EAEFF8"/>
+                    </a:solidFill>
+                  </a:tcPr>
+                </a:tc>
+              </a:tr>
+              <a:tr h="466344">
+                <a:tc>
+                  <a:txBody>
+                    <a:bodyPr wrap="square"/>
+                    <a:lstStyle/>
+                    <a:p>
+                      <a:pPr algn="l"/>
+                      <a:r>
+                        <a:rPr sz="1000" b="0" i="0">
+                          <a:solidFill>
+                            <a:srgbClr val="282828"/>
+                          </a:solidFill>
+                        </a:rPr>
+                        <a:t>Engineering Design Review
+(~5 hrs  ×  €60/hr  —  DfM, tolerances, wall checks)</a:t>
+                      </a:r>
+                    </a:p>
+                  </a:txBody>
+                  <a:tcPr>
+                    <a:solidFill>
+                      <a:srgbClr val="FFFFFF"/>
+                    </a:solidFill>
+                  </a:tcPr>
+                </a:tc>
+                <a:tc>
+                  <a:txBody>
+                    <a:bodyPr wrap="square"/>
+                    <a:lstStyle/>
+                    <a:p>
+                      <a:pPr algn="ctr"/>
+                      <a:r>
+                        <a:rPr sz="1000" b="0" i="0">
+                          <a:solidFill>
+                            <a:srgbClr val="1A73E8"/>
+                          </a:solidFill>
+                        </a:rPr>
+                        <a:t>€  300</a:t>
+                      </a:r>
+                    </a:p>
+                  </a:txBody>
+                  <a:tcPr>
+                    <a:solidFill>
+                      <a:srgbClr val="FFFFFF"/>
+                    </a:solidFill>
+                  </a:tcPr>
+                </a:tc>
+                <a:tc>
+                  <a:txBody>
+                    <a:bodyPr wrap="square"/>
+                    <a:lstStyle/>
+                    <a:p>
+                      <a:pPr algn="ctr"/>
+                      <a:r>
+                        <a:rPr sz="1000" b="0" i="0">
+                          <a:solidFill>
+                            <a:srgbClr val="34A853"/>
+                          </a:solidFill>
+                        </a:rPr>
+                        <a:t>€    300</a:t>
+                      </a:r>
+                    </a:p>
+                  </a:txBody>
+                  <a:tcPr>
+                    <a:solidFill>
+                      <a:srgbClr val="FFFFFF"/>
+                    </a:solidFill>
+                  </a:tcPr>
+                </a:tc>
+              </a:tr>
+              <a:tr h="466344">
+                <a:tc>
+                  <a:txBody>
+                    <a:bodyPr wrap="square"/>
+                    <a:lstStyle/>
+                    <a:p>
+                      <a:pPr algn="l"/>
+                      <a:r>
+                        <a:rPr sz="1000" b="0" i="0">
+                          <a:solidFill>
+                            <a:srgbClr val="282828"/>
+                          </a:solidFill>
+                        </a:rPr>
+                        <a:t>Tooling / Die Design
+(Thermoforming die sketch  vs.  Injection-mould cavity layout)</a:t>
+                      </a:r>
+                    </a:p>
+                  </a:txBody>
+                  <a:tcPr>
+                    <a:solidFill>
+                      <a:srgbClr val="EAEFF8"/>
+                    </a:solidFill>
+                  </a:tcPr>
+                </a:tc>
+                <a:tc>
+                  <a:txBody>
+                    <a:bodyPr wrap="square"/>
+                    <a:lstStyle/>
+                    <a:p>
+                      <a:pPr algn="ctr"/>
+                      <a:r>
+                        <a:rPr sz="1000" b="0" i="0">
+                          <a:solidFill>
+                            <a:srgbClr val="1A73E8"/>
+                          </a:solidFill>
+                        </a:rPr>
+                        <a:t>€ 1,200</a:t>
+                      </a:r>
+                    </a:p>
+                  </a:txBody>
+                  <a:tcPr>
+                    <a:solidFill>
+                      <a:srgbClr val="EAEFF8"/>
+                    </a:solidFill>
+                  </a:tcPr>
+                </a:tc>
+                <a:tc>
+                  <a:txBody>
+                    <a:bodyPr wrap="square"/>
+                    <a:lstStyle/>
+                    <a:p>
+                      <a:pPr algn="ctr"/>
+                      <a:r>
+                        <a:rPr sz="1000" b="0" i="0">
+                          <a:solidFill>
+                            <a:srgbClr val="34A853"/>
+                          </a:solidFill>
+                        </a:rPr>
+                        <a:t>€  4,500</a:t>
+                      </a:r>
+                    </a:p>
+                  </a:txBody>
+                  <a:tcPr>
+                    <a:solidFill>
+                      <a:srgbClr val="EAEFF8"/>
+                    </a:solidFill>
+                  </a:tcPr>
+                </a:tc>
+              </a:tr>
+              <a:tr h="466344">
+                <a:tc>
+                  <a:txBody>
+                    <a:bodyPr wrap="square"/>
+                    <a:lstStyle/>
+                    <a:p>
+                      <a:pPr algn="l"/>
+                      <a:r>
+                        <a:rPr sz="1000" b="0" i="0">
+                          <a:solidFill>
+                            <a:srgbClr val="282828"/>
+                          </a:solidFill>
+                        </a:rPr>
+                        <a:t>Mould-Flow / FEA Simulation
+(Filling, cooling &amp; warpage  —  only required for IM)</a:t>
+                      </a:r>
+                    </a:p>
+                  </a:txBody>
+                  <a:tcPr>
+                    <a:solidFill>
+                      <a:srgbClr val="FFFFFF"/>
+                    </a:solidFill>
+                  </a:tcPr>
+                </a:tc>
+                <a:tc>
+                  <a:txBody>
+                    <a:bodyPr wrap="square"/>
+                    <a:lstStyle/>
+                    <a:p>
+                      <a:pPr algn="ctr"/>
+                      <a:r>
+                        <a:rPr sz="1000" b="0" i="0">
+                          <a:solidFill>
+                            <a:srgbClr val="1A73E8"/>
+                          </a:solidFill>
+                        </a:rPr>
+                        <a:t>€    —</a:t>
+                      </a:r>
+                    </a:p>
+                  </a:txBody>
+                  <a:tcPr>
+                    <a:solidFill>
+                      <a:srgbClr val="FFFFFF"/>
+                    </a:solidFill>
+                  </a:tcPr>
+                </a:tc>
+                <a:tc>
+                  <a:txBody>
+                    <a:bodyPr wrap="square"/>
+                    <a:lstStyle/>
+                    <a:p>
+                      <a:pPr algn="ctr"/>
+                      <a:r>
+                        <a:rPr sz="1000" b="0" i="0">
+                          <a:solidFill>
+                            <a:srgbClr val="34A853"/>
+                          </a:solidFill>
+                        </a:rPr>
+                        <a:t>€    800</a:t>
+                      </a:r>
+                    </a:p>
+                  </a:txBody>
+                  <a:tcPr>
+                    <a:solidFill>
+                      <a:srgbClr val="FFFFFF"/>
+                    </a:solidFill>
+                  </a:tcPr>
+                </a:tc>
+              </a:tr>
+              <a:tr h="466344">
+                <a:tc>
+                  <a:txBody>
+                    <a:bodyPr wrap="square"/>
+                    <a:lstStyle/>
+                    <a:p>
+                      <a:pPr algn="l"/>
+                      <a:r>
+                        <a:rPr sz="1000" b="0" i="0">
+                          <a:solidFill>
+                            <a:srgbClr val="282828"/>
+                          </a:solidFill>
+                        </a:rPr>
+                        <a:t>Rapid Prototype (3D-print verification)
+(1 unit  ×  ~€120 material + machine time)</a:t>
+                      </a:r>
+                    </a:p>
+                  </a:txBody>
+                  <a:tcPr>
+                    <a:solidFill>
+                      <a:srgbClr val="EAEFF8"/>
+                    </a:solidFill>
+                  </a:tcPr>
+                </a:tc>
+                <a:tc>
+                  <a:txBody>
+                    <a:bodyPr wrap="square"/>
+                    <a:lstStyle/>
+                    <a:p>
+                      <a:pPr algn="ctr"/>
+                      <a:r>
+                        <a:rPr sz="1000" b="0" i="0">
+                          <a:solidFill>
+                            <a:srgbClr val="1A73E8"/>
+                          </a:solidFill>
+                        </a:rPr>
+                        <a:t>€  120</a:t>
+                      </a:r>
+                    </a:p>
+                  </a:txBody>
+                  <a:tcPr>
+                    <a:solidFill>
+                      <a:srgbClr val="EAEFF8"/>
+                    </a:solidFill>
+                  </a:tcPr>
+                </a:tc>
+                <a:tc>
+                  <a:txBody>
+                    <a:bodyPr wrap="square"/>
+                    <a:lstStyle/>
+                    <a:p>
+                      <a:pPr algn="ctr"/>
+                      <a:r>
+                        <a:rPr sz="1000" b="0" i="0">
+                          <a:solidFill>
+                            <a:srgbClr val="34A853"/>
+                          </a:solidFill>
+                        </a:rPr>
+                        <a:t>€    120</a:t>
+                      </a:r>
+                    </a:p>
+                  </a:txBody>
+                  <a:tcPr>
+                    <a:solidFill>
+                      <a:srgbClr val="EAEFF8"/>
+                    </a:solidFill>
+                  </a:tcPr>
+                </a:tc>
+              </a:tr>
+              <a:tr h="466344">
+                <a:tc>
+                  <a:txBody>
+                    <a:bodyPr wrap="square"/>
+                    <a:lstStyle/>
+                    <a:p>
+                      <a:pPr algn="l"/>
+                      <a:r>
+                        <a:rPr sz="1000" b="0" i="0">
+                          <a:solidFill>
+                            <a:srgbClr val="282828"/>
+                          </a:solidFill>
+                        </a:rPr>
+                        <a:t>Design Iteration &amp; Revision Rounds
+(~3 rounds avg.  ×  €80 / round)</a:t>
+                      </a:r>
+                    </a:p>
+                  </a:txBody>
+                  <a:tcPr>
+                    <a:solidFill>
+                      <a:srgbClr val="FFFFFF"/>
+                    </a:solidFill>
+                  </a:tcPr>
+                </a:tc>
+                <a:tc>
+                  <a:txBody>
+                    <a:bodyPr wrap="square"/>
+                    <a:lstStyle/>
+                    <a:p>
+                      <a:pPr algn="ctr"/>
+                      <a:r>
+                        <a:rPr sz="1000" b="0" i="0">
+                          <a:solidFill>
+                            <a:srgbClr val="1A73E8"/>
+                          </a:solidFill>
+                        </a:rPr>
+                        <a:t>€  240</a:t>
+                      </a:r>
+                    </a:p>
+                  </a:txBody>
+                  <a:tcPr>
+                    <a:solidFill>
+                      <a:srgbClr val="FFFFFF"/>
+                    </a:solidFill>
+                  </a:tcPr>
+                </a:tc>
+                <a:tc>
+                  <a:txBody>
+                    <a:bodyPr wrap="square"/>
+                    <a:lstStyle/>
+                    <a:p>
+                      <a:pPr algn="ctr"/>
+                      <a:r>
+                        <a:rPr sz="1000" b="0" i="0">
+                          <a:solidFill>
+                            <a:srgbClr val="34A853"/>
+                          </a:solidFill>
+                        </a:rPr>
+                        <a:t>€    240</a:t>
+                      </a:r>
+                    </a:p>
+                  </a:txBody>
+                  <a:tcPr>
+                    <a:solidFill>
+                      <a:srgbClr val="FFFFFF"/>
+                    </a:solidFill>
+                  </a:tcPr>
+                </a:tc>
+              </a:tr>
+              <a:tr h="466344">
+                <a:tc>
+                  <a:txBody>
+                    <a:bodyPr wrap="square"/>
+                    <a:lstStyle/>
+                    <a:p>
+                      <a:pPr algn="l"/>
+                      <a:r>
+                        <a:rPr sz="1000" b="0" i="0">
+                          <a:solidFill>
+                            <a:srgbClr val="282828"/>
+                          </a:solidFill>
+                        </a:rPr>
+                        <a:t>IP / Patent Prior-Art Search
+(1-off desktop search, parallelised across both)</a:t>
+                      </a:r>
+                    </a:p>
+                  </a:txBody>
+                  <a:tcPr>
+                    <a:solidFill>
+                      <a:srgbClr val="EAEFF8"/>
+                    </a:solidFill>
+                  </a:tcPr>
+                </a:tc>
+                <a:tc>
+                  <a:txBody>
+                    <a:bodyPr wrap="square"/>
+                    <a:lstStyle/>
+                    <a:p>
+                      <a:pPr algn="ctr"/>
+                      <a:r>
+                        <a:rPr sz="1000" b="0" i="0">
+                          <a:solidFill>
+                            <a:srgbClr val="1A73E8"/>
+                          </a:solidFill>
+                        </a:rPr>
+                        <a:t>€  150</a:t>
+                      </a:r>
+                    </a:p>
+                  </a:txBody>
+                  <a:tcPr>
+                    <a:solidFill>
+                      <a:srgbClr val="EAEFF8"/>
+                    </a:solidFill>
+                  </a:tcPr>
+                </a:tc>
+                <a:tc>
+                  <a:txBody>
+                    <a:bodyPr wrap="square"/>
+                    <a:lstStyle/>
+                    <a:p>
+                      <a:pPr algn="ctr"/>
+                      <a:r>
+                        <a:rPr sz="1000" b="0" i="0">
+                          <a:solidFill>
+                            <a:srgbClr val="34A853"/>
+                          </a:solidFill>
+                        </a:rPr>
+                        <a:t>€    150</a:t>
+                      </a:r>
+                    </a:p>
+                  </a:txBody>
+                  <a:tcPr>
+                    <a:solidFill>
+                      <a:srgbClr val="EAEFF8"/>
+                    </a:solidFill>
+                  </a:tcPr>
+                </a:tc>
+              </a:tr>
+              <a:tr h="466344">
+                <a:tc>
+                  <a:txBody>
+                    <a:bodyPr wrap="square"/>
+                    <a:lstStyle/>
+                    <a:p>
+                      <a:pPr algn="l"/>
+                      <a:r>
+                        <a:rPr sz="1100" b="1" i="0">
+                          <a:solidFill>
+                            <a:srgbClr val="FFFFFF"/>
+                          </a:solidFill>
+                        </a:rPr>
+                        <a:t>TOTAL DESIGN COST (per container SKU)</a:t>
+                      </a:r>
+                    </a:p>
+                  </a:txBody>
+                  <a:tcPr>
+                    <a:solidFill>
+                      <a:srgbClr val="172B4D"/>
+                    </a:solidFill>
+                  </a:tcPr>
+                </a:tc>
+                <a:tc>
+                  <a:txBody>
+                    <a:bodyPr wrap="square"/>
+                    <a:lstStyle/>
+                    <a:p>
+                      <a:pPr algn="ctr"/>
+                      <a:r>
+                        <a:rPr sz="1100" b="1" i="0">
+                          <a:solidFill>
+                            <a:srgbClr val="FFFFFF"/>
+                          </a:solidFill>
+                        </a:rPr>
+                        <a:t>€ 3,260</a:t>
+                      </a:r>
+                    </a:p>
+                  </a:txBody>
+                  <a:tcPr>
+                    <a:solidFill>
+                      <a:srgbClr val="172B4D"/>
+                    </a:solidFill>
+                  </a:tcPr>
+                </a:tc>
+                <a:tc>
+                  <a:txBody>
+                    <a:bodyPr wrap="square"/>
+                    <a:lstStyle/>
+                    <a:p>
+                      <a:pPr algn="ctr"/>
+                      <a:r>
+                        <a:rPr sz="1100" b="1" i="0">
+                          <a:solidFill>
+                            <a:srgbClr val="FFFFFF"/>
+                          </a:solidFill>
+                        </a:rPr>
+                        <a:t>€  7,720</a:t>
+                      </a:r>
+                    </a:p>
+                  </a:txBody>
+                  <a:tcPr>
+                    <a:solidFill>
+                      <a:srgbClr val="172B4D"/>
+                    </a:solidFill>
+                  </a:tcPr>
+                </a:tc>
+              </a:tr>
+            </a:tbl>
+          </a:graphicData>
+        </a:graphic>
+      </p:graphicFrame>
+      <p:sp>
+        <p:nvSpPr>
+          <p:cNvPr id="7" name="Rectangle 6"/>
+          <p:cNvSpPr/>
+          <p:nvPr/>
+        </p:nvSpPr>
+        <p:spPr>
+          <a:xfrm>
+            <a:off x="502920" y="5916168"/>
+            <a:ext cx="11155680" cy="685800"/>
+          </a:xfrm>
+          <a:prstGeom prst="rect">
+            <a:avLst/>
+          </a:prstGeom>
+          <a:solidFill>
+            <a:srgbClr val="EBF2FF"/>
+          </a:solidFill>
+          <a:ln>
+            <a:noFill/>
+          </a:ln>
+        </p:spPr>
+        <p:style>
+          <a:lnRef idx="1">
+            <a:schemeClr val="accent1"/>
+          </a:lnRef>
+          <a:fillRef idx="3">
+            <a:schemeClr val="accent1"/>
+          </a:fillRef>
+          <a:effectRef idx="2">
+            <a:schemeClr val="accent1"/>
+          </a:effectRef>
+          <a:fontRef idx="minor">
+            <a:schemeClr val="lt1"/>
+          </a:fontRef>
+        </p:style>
+        <p:txBody>
+          <a:bodyPr rtlCol="0" anchor="ctr"/>
+          <a:lstStyle/>
+          <a:p>
+            <a:pPr algn="ctr"/>
+          </a:p>
+        </p:txBody>
+      </p:sp>
+      <p:sp>
+        <p:nvSpPr>
+          <p:cNvPr id="8" name="TextBox 7"/>
+          <p:cNvSpPr txBox="1"/>
+          <p:nvPr/>
+        </p:nvSpPr>
+        <p:spPr>
+          <a:xfrm>
+            <a:off x="685800" y="5943600"/>
+            <a:ext cx="10789920" cy="640080"/>
+          </a:xfrm>
+          <a:prstGeom prst="rect">
+            <a:avLst/>
+          </a:prstGeom>
+          <a:noFill/>
+        </p:spPr>
+        <p:txBody>
+          <a:bodyPr wrap="square">
+            <a:spAutoFit/>
+          </a:bodyPr>
+          <a:lstStyle/>
+          <a:p>
+            <a:r>
+              <a:rPr sz="1000">
+                <a:solidFill>
+                  <a:srgbClr val="172B4D"/>
+                </a:solidFill>
+              </a:rPr>
+              <a:t>💡  Key Takeaway:  PPE injection moulding design is ~2.4× more expensive to design than PLA thermoforming, driven primarily by complex mould-cavity layout and mandatory mould-flow simulation.  However, the mould design is a one-time capital cost amortised over high-volume production runs.</a:t>
+            </a:r>
+          </a:p>
+        </p:txBody>
+      </p:sp>
+      <p:sp>
+        <p:nvSpPr>
+          <p:cNvPr id="9" name="Rectangle 8"/>
+          <p:cNvSpPr/>
+          <p:nvPr/>
+        </p:nvSpPr>
+        <p:spPr>
+          <a:xfrm>
+            <a:off x="0" y="6766560"/>
+            <a:ext cx="12188952" cy="91440"/>
+          </a:xfrm>
+          <a:prstGeom prst="rect">
+            <a:avLst/>
+          </a:prstGeom>
+          <a:solidFill>
+            <a:srgbClr val="172B4D"/>
+          </a:solidFill>
+          <a:ln>
+            <a:noFill/>
+          </a:ln>
+        </p:spPr>
+        <p:style>
+          <a:lnRef idx="1">
+            <a:schemeClr val="accent1"/>
+          </a:lnRef>
+          <a:fillRef idx="3">
+            <a:schemeClr val="accent1"/>
+          </a:fillRef>
+          <a:effectRef idx="2">
+            <a:schemeClr val="accent1"/>
+          </a:effectRef>
+          <a:fontRef idx="minor">
+            <a:schemeClr val="lt1"/>
+          </a:fontRef>
+        </p:style>
+        <p:txBody>
+          <a:bodyPr rtlCol="0" anchor="ctr"/>
+          <a:lstStyle/>
+          <a:p>
+            <a:pPr algn="ctr"/>
+          </a:p>
+        </p:txBody>
+      </p:sp>
+    </p:spTree>
+  </p:cSld>
+  <p:clrMapOvr>
+    <a:masterClrMapping/>
+  </p:clrMapOvr>
+</p:sld>
+</file>
+
 <file path=ppt/theme/theme1.xml><?xml version="1.0" encoding="utf-8"?>
 <a:theme xmlns:a="http://schemas.openxmlformats.org/drawingml/2006/main" name="Office Theme">
   <a:themeElements>

</xml_diff>